<commit_message>
docs: price Tina at the free plan for two people
The comparison no longer uses the paid team rate. A third login is called out as an upgrade this budget does not include.
</commit_message>
<xml_diff>
--- a/docs/website-options.pptx
+++ b/docs/website-options.pptx
@@ -4782,7 +4782,7 @@
                           <a:ea typeface="Calibri" pitchFamily="34" charset="-122"/>
                           <a:cs typeface="Calibri" pitchFamily="34" charset="-120"/>
                         </a:rPr>
-                        <a:t>Tina Team, $24 a month for 3 people. $290 if paid yearly. Free plan stops at 2 people.</a:t>
+                        <a:t>Free. Two people only. A third login is not on this plan.</a:t>
                       </a:r>
                       <a:endParaRPr lang="en-US" sz="1300" dirty="0">
                         <a:latin typeface="Calibri" charset="0"/>
@@ -5400,7 +5400,7 @@
                           <a:ea typeface="Calibri" pitchFamily="34" charset="-122"/>
                           <a:cs typeface="Calibri" pitchFamily="34" charset="-120"/>
                         </a:rPr>
-                        <a:t>Tina publishes prices. Checked 28 September 2026 at tina.io/pricing.</a:t>
+                        <a:t>Free tier, checked 28 September 2026 at tina.io/pricing. It stops at 2 users.</a:t>
                       </a:r>
                       <a:endParaRPr lang="en-US" sz="1300" dirty="0">
                         <a:latin typeface="Calibri" charset="0"/>
@@ -5606,7 +5606,7 @@
                           <a:ea typeface="Calibri" pitchFamily="34" charset="-122"/>
                           <a:cs typeface="Calibri" pitchFamily="34" charset="-120"/>
                         </a:rPr>
-                        <a:t>About $290 to $530, plus time to finish the editor.</a:t>
+                        <a:t>$0 for Tina. Hosting is $0 to $240 a year, plus time to finish the editor.</a:t>
                       </a:r>
                       <a:endParaRPr lang="en-US" sz="1300" dirty="0">
                         <a:latin typeface="Calibri" charset="0"/>
@@ -7328,7 +7328,7 @@
                 <a:ea typeface="Georgia" pitchFamily="34" charset="-122"/>
                 <a:cs typeface="Georgia" pitchFamily="34" charset="-120"/>
               </a:rPr>
-              <a:t>Tina is the known bill.</a:t>
+              <a:t>Tina is free for two people.</a:t>
             </a:r>
             <a:endParaRPr lang="en-US" sz="1600" dirty="0"/>
           </a:p>
@@ -7367,7 +7367,7 @@
                 <a:ea typeface="Calibri" pitchFamily="34" charset="-122"/>
                 <a:cs typeface="Calibri" pitchFamily="34" charset="-120"/>
               </a:rPr>
-              <a:t>Team is $24 a month, or $290 a year, for 3 editors. A fourth person is about $90 more per year. Prices from tina.io/pricing on 28 September 2026.</a:t>
+              <a:t>The free plan is $0 and stops at 2 users. A third person is a paid upgrade, and this comparison does not include it. Checked 28 September 2026 at tina.io/pricing.</a:t>
             </a:r>
             <a:endParaRPr lang="en-US" sz="1500" dirty="0"/>
           </a:p>
@@ -7679,7 +7679,7 @@
                 <a:ea typeface="Calibri" pitchFamily="34" charset="-122"/>
                 <a:cs typeface="Calibri" pitchFamily="34" charset="-120"/>
               </a:rPr>
-              <a:t>Option 1 spends a small monthly fee to keep the site that exists. Option 2 spends the rebuild to put the website inside the login the church already trusts.</a:t>
+              <a:t>Option 1 keeps the site that exists, with no editor fee for two people. Option 2 spends the rebuild to put the website inside the login the church already trusts.</a:t>
             </a:r>
             <a:endParaRPr lang="en-US" sz="1500" dirty="0"/>
           </a:p>

</xml_diff>

<commit_message>
docs: rewrite the website choice for Pastor Dave and Pastor Shawn
The deck now explains Tina and SnapPages in plain language, with the app, giving, and sermons staying on Subsplash either way.
</commit_message>
<xml_diff>
--- a/docs/website-options.pptx
+++ b/docs/website-options.pptx
@@ -1590,7 +1590,7 @@
                 <a:ea typeface="Georgia" pitchFamily="34" charset="-122"/>
                 <a:cs typeface="Georgia" pitchFamily="34" charset="-120"/>
               </a:rPr>
-              <a:t>Where the public website</a:t>
+              <a:t>Two ways forward</a:t>
             </a:r>
             <a:endParaRPr lang="en-US" sz="4800" dirty="0"/>
           </a:p>
@@ -1607,7 +1607,7 @@
                 <a:ea typeface="Georgia" pitchFamily="34" charset="-122"/>
                 <a:cs typeface="Georgia" pitchFamily="34" charset="-120"/>
               </a:rPr>
-              <a:t>should live</a:t>
+              <a:t>for our website</a:t>
             </a:r>
             <a:endParaRPr lang="en-US" sz="4800" dirty="0"/>
           </a:p>
@@ -1646,7 +1646,7 @@
                 <a:ea typeface="Calibri" pitchFamily="34" charset="-122"/>
                 <a:cs typeface="Calibri" pitchFamily="34" charset="-120"/>
               </a:rPr>
-              <a:t>Two options. The church app, online giving, and sermons stay on Subsplash either way.</a:t>
+              <a:t>For Pastor Dave and Pastor Shawn. The app, giving, and sermons stay on Subsplash either way.</a:t>
             </a:r>
             <a:endParaRPr lang="en-US" sz="1800" dirty="0"/>
           </a:p>
@@ -1685,7 +1685,7 @@
                 <a:ea typeface="Calibri" pitchFamily="34" charset="-122"/>
                 <a:cs typeface="Calibri" pitchFamily="34" charset="-120"/>
               </a:rPr>
-              <a:t>Decision brief  ·  28 September 2026</a:t>
+              <a:t>A simple look at the choice  ·  28 September 2026</a:t>
             </a:r>
             <a:endParaRPr lang="en-US" sz="1400" dirty="0"/>
           </a:p>
@@ -1756,7 +1756,7 @@
                 <a:ea typeface="Georgia" pitchFamily="34" charset="-122"/>
                 <a:cs typeface="Georgia" pitchFamily="34" charset="-120"/>
               </a:rPr>
-              <a:t>The only open question is the front door</a:t>
+              <a:t>What we are deciding</a:t>
             </a:r>
             <a:endParaRPr lang="en-US" sz="3200" dirty="0"/>
           </a:p>
@@ -1795,7 +1795,7 @@
                 <a:ea typeface="Calibri" pitchFamily="34" charset="-122"/>
                 <a:cs typeface="Calibri" pitchFamily="34" charset="-120"/>
               </a:rPr>
-              <a:t>calvaryfrederick.com is on Squarespace today. Giving, sermons, podcasts, and the app are already Subsplash. This choice does not move those.</a:t>
+              <a:t>People visit calvaryfrederick.com. That site is on Squarespace today. Giving, sermons, and the app already live in Subsplash. We are not moving those.</a:t>
             </a:r>
             <a:endParaRPr lang="en-US" sz="1600" dirty="0"/>
           </a:p>
@@ -1920,7 +1920,7 @@
                 <a:ea typeface="Georgia" pitchFamily="34" charset="-122"/>
                 <a:cs typeface="Georgia" pitchFamily="34" charset="-120"/>
               </a:rPr>
-              <a:t>Tina, on the site already designed</a:t>
+              <a:t>Keep the new website. Edit it in Tina.</a:t>
             </a:r>
             <a:endParaRPr lang="en-US" sz="2600" dirty="0"/>
           </a:p>
@@ -1959,7 +1959,7 @@
                 <a:ea typeface="Calibri" pitchFamily="34" charset="-122"/>
                 <a:cs typeface="Calibri" pitchFamily="34" charset="-120"/>
               </a:rPr>
-              <a:t>The public website lives outside Subsplash. The office edits words on the real page in Tina. Sermons, giving, and the app stay in the Subsplash dashboards they use now.</a:t>
+              <a:t>The website we have been designing stays. The office clicks the words on the page and changes them. Sermons, giving, and the app stay in Subsplash, just as they are now.</a:t>
             </a:r>
             <a:endParaRPr lang="en-US" sz="1600" dirty="0"/>
           </a:p>
@@ -1998,7 +1998,7 @@
                 <a:ea typeface="Calibri" pitchFamily="34" charset="-122"/>
                 <a:cs typeface="Calibri" pitchFamily="34" charset="-120"/>
               </a:rPr>
-              <a:t>Preview already exists</a:t>
+              <a:t>You can already look</a:t>
             </a:r>
             <a:endParaRPr lang="en-US" sz="1500" dirty="0"/>
           </a:p>
@@ -2015,7 +2015,7 @@
                 <a:ea typeface="Calibri" pitchFamily="34" charset="-122"/>
                 <a:cs typeface="Calibri" pitchFamily="34" charset="-120"/>
               </a:rPr>
-              <a:t>calvary-frederick.vercel.app</a:t>
+              <a:t>We can open the sample together.</a:t>
             </a:r>
             <a:endParaRPr lang="en-US" sz="1500" dirty="0"/>
           </a:p>
@@ -2140,7 +2140,7 @@
                 <a:ea typeface="Georgia" pitchFamily="34" charset="-122"/>
                 <a:cs typeface="Georgia" pitchFamily="34" charset="-120"/>
               </a:rPr>
-              <a:t>Rebuild the site in SnapPages</a:t>
+              <a:t>Rebuild the website inside Subsplash.</a:t>
             </a:r>
             <a:endParaRPr lang="en-US" sz="2600" dirty="0"/>
           </a:p>
@@ -2179,7 +2179,7 @@
                 <a:ea typeface="Calibri" pitchFamily="34" charset="-122"/>
                 <a:cs typeface="Calibri" pitchFamily="34" charset="-120"/>
               </a:rPr>
-              <a:t>The public website moves into Subsplash’s website builder. The office edits with drag and drop, in the same login as the app. The designed site cannot be imported. It is rebuilt by hand.</a:t>
+              <a:t>We start over in Subsplash’s website tool, called SnapPages. The office edits by dragging and dropping, in the same login they already use. The new design cannot be copied over. It has to be built again.</a:t>
             </a:r>
             <a:endParaRPr lang="en-US" sz="1600" dirty="0"/>
           </a:p>
@@ -2218,7 +2218,7 @@
                 <a:ea typeface="Calibri" pitchFamily="34" charset="-122"/>
                 <a:cs typeface="Calibri" pitchFamily="34" charset="-120"/>
               </a:rPr>
-              <a:t>A holding site already exists</a:t>
+              <a:t>A practice site is already started</a:t>
             </a:r>
             <a:endParaRPr lang="en-US" sz="1500" dirty="0"/>
           </a:p>
@@ -2235,7 +2235,7 @@
                 <a:ea typeface="Calibri" pitchFamily="34" charset="-122"/>
                 <a:cs typeface="Calibri" pitchFamily="34" charset="-120"/>
               </a:rPr>
-              <a:t>calvarychapelfrederick1.snappages.site</a:t>
+              <a:t>It lives in our Subsplash account.</a:t>
             </a:r>
             <a:endParaRPr lang="en-US" sz="1500" dirty="0"/>
           </a:p>
@@ -2274,7 +2274,7 @@
                 <a:ea typeface="Calibri" pitchFamily="34" charset="-122"/>
                 <a:cs typeface="Calibri" pitchFamily="34" charset="-120"/>
               </a:rPr>
-              <a:t>Calvary Chapel Frederick  ·  Public website options  ·  28 September 2026</a:t>
+              <a:t>For Pastor Dave and Pastor Shawn  ·  28 September 2026</a:t>
             </a:r>
             <a:endParaRPr lang="en-US" sz="1100" dirty="0"/>
           </a:p>
@@ -2384,7 +2384,7 @@
                 <a:ea typeface="Georgia" pitchFamily="34" charset="-122"/>
                 <a:cs typeface="Georgia" pitchFamily="34" charset="-120"/>
               </a:rPr>
-              <a:t>What does not change</a:t>
+              <a:t>What stays the same</a:t>
             </a:r>
             <a:endParaRPr lang="en-US" sz="3200" dirty="0"/>
           </a:p>
@@ -2423,7 +2423,7 @@
                 <a:ea typeface="Calibri" pitchFamily="34" charset="-122"/>
                 <a:cs typeface="Calibri" pitchFamily="34" charset="-120"/>
               </a:rPr>
-              <a:t>Both options keep the church on Subsplash for everything except the marketing pages.</a:t>
+              <a:t>Whichever way we choose, these do not move.</a:t>
             </a:r>
             <a:endParaRPr lang="en-US" sz="1600" dirty="0"/>
           </a:p>
@@ -2482,7 +2482,7 @@
                 <a:ea typeface="Georgia" pitchFamily="34" charset="-122"/>
                 <a:cs typeface="Georgia" pitchFamily="34" charset="-120"/>
               </a:rPr>
-              <a:t>Sermons, live, and podcasts</a:t>
+              <a:t>Sermons and podcasts</a:t>
             </a:r>
             <a:endParaRPr lang="en-US" sz="1800" dirty="0"/>
           </a:p>
@@ -2521,7 +2521,7 @@
                 <a:ea typeface="Calibri" pitchFamily="34" charset="-122"/>
                 <a:cs typeface="Calibri" pitchFamily="34" charset="-120"/>
               </a:rPr>
-              <a:t>Subsplash Media. Upload once. The app and podcasts keep working.</a:t>
+              <a:t>Still uploaded in Subsplash. The app and the podcasts keep working.</a:t>
             </a:r>
             <a:endParaRPr lang="en-US" sz="1600" dirty="0"/>
           </a:p>
@@ -2580,7 +2580,7 @@
                 <a:ea typeface="Georgia" pitchFamily="34" charset="-122"/>
                 <a:cs typeface="Georgia" pitchFamily="34" charset="-120"/>
               </a:rPr>
-              <a:t>Online giving and receipts</a:t>
+              <a:t>Giving and receipts</a:t>
             </a:r>
             <a:endParaRPr lang="en-US" sz="1800" dirty="0"/>
           </a:p>
@@ -2619,7 +2619,7 @@
                 <a:ea typeface="Calibri" pitchFamily="34" charset="-122"/>
                 <a:cs typeface="Calibri" pitchFamily="34" charset="-120"/>
               </a:rPr>
-              <a:t>Subsplash Wallet. Card 2.3% + $0.30 and ACH 1.0%, as checked 16 August 2026.</a:t>
+              <a:t>Still Subsplash. A card gift is 2.3% plus 30 cents. A bank gift is 1%.</a:t>
             </a:r>
             <a:endParaRPr lang="en-US" sz="1600" dirty="0"/>
           </a:p>
@@ -2717,7 +2717,7 @@
                 <a:ea typeface="Calibri" pitchFamily="34" charset="-122"/>
                 <a:cs typeface="Calibri" pitchFamily="34" charset="-120"/>
               </a:rPr>
-              <a:t>The app people already installed. Push, live, and the app store stay in Subsplash.</a:t>
+              <a:t>The app people already have on their phones stays put.</a:t>
             </a:r>
             <a:endParaRPr lang="en-US" sz="1600" dirty="0"/>
           </a:p>
@@ -2776,7 +2776,7 @@
                 <a:ea typeface="Georgia" pitchFamily="34" charset="-122"/>
                 <a:cs typeface="Georgia" pitchFamily="34" charset="-120"/>
               </a:rPr>
-              <a:t>The domain name</a:t>
+              <a:t>Our web address</a:t>
             </a:r>
             <a:endParaRPr lang="en-US" sz="1800" dirty="0"/>
           </a:p>
@@ -2815,7 +2815,7 @@
                 <a:ea typeface="Calibri" pitchFamily="34" charset="-122"/>
                 <a:cs typeface="Calibri" pitchFamily="34" charset="-120"/>
               </a:rPr>
-              <a:t>calvaryfrederick.com stays. DNS is not switched until leadership picks.</a:t>
+              <a:t>calvaryfrederick.com stays. We do not switch it until you decide.</a:t>
             </a:r>
             <a:endParaRPr lang="en-US" sz="1600" dirty="0"/>
           </a:p>
@@ -2874,7 +2874,7 @@
                 <a:ea typeface="Georgia" pitchFamily="34" charset="-122"/>
                 <a:cs typeface="Georgia" pitchFamily="34" charset="-120"/>
               </a:rPr>
-              <a:t>Squarespace</a:t>
+              <a:t>The old Squarespace site</a:t>
             </a:r>
             <a:endParaRPr lang="en-US" sz="1800" dirty="0"/>
           </a:p>
@@ -2913,7 +2913,7 @@
                 <a:ea typeface="Calibri" pitchFamily="34" charset="-122"/>
                 <a:cs typeface="Calibri" pitchFamily="34" charset="-120"/>
               </a:rPr>
-              <a:t>The current public site is retired when the new front door goes live. That happens on either option.</a:t>
+              <a:t>It comes down when the new site goes up. That is true for both choices.</a:t>
             </a:r>
             <a:endParaRPr lang="en-US" sz="1600" dirty="0"/>
           </a:p>
@@ -2952,7 +2952,7 @@
                 <a:ea typeface="Calibri" pitchFamily="34" charset="-122"/>
                 <a:cs typeface="Calibri" pitchFamily="34" charset="-120"/>
               </a:rPr>
-              <a:t>Calvary Chapel Frederick  ·  Public website options  ·  28 September 2026</a:t>
+              <a:t>For Pastor Dave and Pastor Shawn  ·  28 September 2026</a:t>
             </a:r>
             <a:endParaRPr lang="en-US" sz="1100" dirty="0"/>
           </a:p>
@@ -3062,7 +3062,7 @@
                 <a:ea typeface="Georgia" pitchFamily="34" charset="-122"/>
                 <a:cs typeface="Georgia" pitchFamily="34" charset="-120"/>
               </a:rPr>
-              <a:t>Option 1  ·  Tina</a:t>
+              <a:t>Option 1. Tina</a:t>
             </a:r>
             <a:endParaRPr lang="en-US" sz="3200" dirty="0"/>
           </a:p>
@@ -3101,7 +3101,7 @@
                 <a:ea typeface="Calibri" pitchFamily="34" charset="-122"/>
                 <a:cs typeface="Calibri" pitchFamily="34" charset="-120"/>
               </a:rPr>
-              <a:t>The office sees the page while they type. A save updates the same files a developer can still edit.</a:t>
+              <a:t>The office sees the page while they type. They do not need to learn code.</a:t>
             </a:r>
             <a:endParaRPr lang="en-US" sz="1600" dirty="0"/>
           </a:p>
@@ -3199,7 +3199,7 @@
                 <a:ea typeface="Calibri" pitchFamily="34" charset="-122"/>
                 <a:cs typeface="Calibri" pitchFamily="34" charset="-120"/>
               </a:rPr>
-              <a:t>Opens Tina, clicks the homepage headline or a ministry title, rewrites it, and saves. No code.</a:t>
+              <a:t>They open Tina, click the words on the page, type the new words, and save.</a:t>
             </a:r>
             <a:endParaRPr lang="en-US" sz="1500" dirty="0"/>
           </a:p>
@@ -3297,7 +3297,7 @@
                 <a:ea typeface="Calibri" pitchFamily="34" charset="-122"/>
                 <a:cs typeface="Calibri" pitchFamily="34" charset="-120"/>
               </a:rPr>
-              <a:t>Service times, the bulletin path, ministry paragraphs, address, and the weekly message title.</a:t>
+              <a:t>Service times, the bulletin, ministry pages, the address, and this week’s message title.</a:t>
             </a:r>
             <a:endParaRPr lang="en-US" sz="1500" dirty="0"/>
           </a:p>
@@ -3356,7 +3356,7 @@
                 <a:ea typeface="Georgia" pitchFamily="34" charset="-122"/>
                 <a:cs typeface="Georgia" pitchFamily="34" charset="-120"/>
               </a:rPr>
-              <a:t>What they do not change</a:t>
+              <a:t>What they leave alone</a:t>
             </a:r>
             <a:endParaRPr lang="en-US" sz="1600" dirty="0"/>
           </a:p>
@@ -3395,7 +3395,7 @@
                 <a:ea typeface="Calibri" pitchFamily="34" charset="-122"/>
                 <a:cs typeface="Calibri" pitchFamily="34" charset="-120"/>
               </a:rPr>
-              <a:t>Sermon video, the app, and giving. Those stay in Subsplash. Wallet IDs stay off the form.</a:t>
+              <a:t>Sermon videos, the app, and giving. Those stay in Subsplash.</a:t>
             </a:r>
             <a:endParaRPr lang="en-US" sz="1500" dirty="0"/>
           </a:p>
@@ -3454,7 +3454,7 @@
                 <a:ea typeface="Georgia" pitchFamily="34" charset="-122"/>
                 <a:cs typeface="Georgia" pitchFamily="34" charset="-120"/>
               </a:rPr>
-              <a:t>What you keep</a:t>
+              <a:t>What we keep</a:t>
             </a:r>
             <a:endParaRPr lang="en-US" sz="1600" dirty="0"/>
           </a:p>
@@ -3493,7 +3493,7 @@
                 <a:ea typeface="Calibri" pitchFamily="34" charset="-122"/>
                 <a:cs typeface="Calibri" pitchFamily="34" charset="-120"/>
               </a:rPr>
-              <a:t>The designed site: hero, ministry films, Visit page, and the look already in the preview.</a:t>
+              <a:t>The look of the new site you have already seen. Home, Visit, and the ministry pages.</a:t>
             </a:r>
             <a:endParaRPr lang="en-US" sz="1500" dirty="0"/>
           </a:p>
@@ -3591,7 +3591,7 @@
                 <a:ea typeface="Calibri" pitchFamily="34" charset="-122"/>
                 <a:cs typeface="Calibri" pitchFamily="34" charset="-120"/>
               </a:rPr>
-              <a:t>Two logins. Website in Tina. Sermons, giving, and the app in Subsplash. The homepage Watch card still follows Subsplash, not the message-title field.</a:t>
+              <a:t>Two logins. The website is Tina. Sermons, giving, and the app are Subsplash. The Watch button still plays the sermon from Subsplash.</a:t>
             </a:r>
             <a:endParaRPr lang="en-US" sz="1500" dirty="0"/>
           </a:p>
@@ -3630,7 +3630,7 @@
                 <a:ea typeface="Calibri" pitchFamily="34" charset="-122"/>
                 <a:cs typeface="Calibri" pitchFamily="34" charset="-120"/>
               </a:rPr>
-              <a:t>Calvary Chapel Frederick  ·  Public website options  ·  28 September 2026</a:t>
+              <a:t>For Pastor Dave and Pastor Shawn  ·  28 September 2026</a:t>
             </a:r>
             <a:endParaRPr lang="en-US" sz="1100" dirty="0"/>
           </a:p>
@@ -3740,7 +3740,7 @@
                 <a:ea typeface="Georgia" pitchFamily="34" charset="-122"/>
                 <a:cs typeface="Georgia" pitchFamily="34" charset="-120"/>
               </a:rPr>
-              <a:t>Option 2  ·  SnapPages</a:t>
+              <a:t>Option 2. SnapPages</a:t>
             </a:r>
             <a:endParaRPr lang="en-US" sz="3200" dirty="0"/>
           </a:p>
@@ -3779,7 +3779,7 @@
                 <a:ea typeface="Calibri" pitchFamily="34" charset="-122"/>
                 <a:cs typeface="Calibri" pitchFamily="34" charset="-120"/>
               </a:rPr>
-              <a:t>Subsplash’s website builder. The holding site shows the church already has a websites seat. The interiors on it are still placeholder copy.</a:t>
+              <a:t>This is Subsplash’s own website builder. A practice site is already started. A lot of the writing on it is still filler.</a:t>
             </a:r>
             <a:endParaRPr lang="en-US" sz="1600" dirty="0"/>
           </a:p>
@@ -3877,7 +3877,7 @@
                 <a:ea typeface="Calibri" pitchFamily="34" charset="-122"/>
                 <a:cs typeface="Calibri" pitchFamily="34" charset="-120"/>
               </a:rPr>
-              <a:t>Signs into Subsplash and edits blocks on the page. One login covers the website, the app, and giving.</a:t>
+              <a:t>They log into Subsplash and change the words on the page. One login covers the website, the app, and giving.</a:t>
             </a:r>
             <a:endParaRPr lang="en-US" sz="1500" dirty="0"/>
           </a:p>
@@ -3975,7 +3975,7 @@
                 <a:ea typeface="Calibri" pitchFamily="34" charset="-122"/>
                 <a:cs typeface="Calibri" pitchFamily="34" charset="-120"/>
               </a:rPr>
-              <a:t>Text, photos, and sections inside the SnapPages theme. A native giving block and media block sit in the same editor.</a:t>
+              <a:t>Words, photos, and sections, inside Subsplash’s design.</a:t>
             </a:r>
             <a:endParaRPr lang="en-US" sz="1500" dirty="0"/>
           </a:p>
@@ -4034,7 +4034,7 @@
                 <a:ea typeface="Georgia" pitchFamily="34" charset="-122"/>
                 <a:cs typeface="Georgia" pitchFamily="34" charset="-120"/>
               </a:rPr>
-              <a:t>What gets rebuilt</a:t>
+              <a:t>What we would rebuild</a:t>
             </a:r>
             <a:endParaRPr lang="en-US" sz="1600" dirty="0"/>
           </a:p>
@@ -4073,7 +4073,7 @@
                 <a:ea typeface="Calibri" pitchFamily="34" charset="-122"/>
                 <a:cs typeface="Calibri" pitchFamily="34" charset="-120"/>
               </a:rPr>
-              <a:t>Home, Visit, ministries, Media, and Give. The current site cannot be dropped in. Layout, type, and the ministry films are approximated.</a:t>
+              <a:t>Home, Visit, the ministry pages, the sermons page, and the giving page. We cannot move the new site over. We build it again.</a:t>
             </a:r>
             <a:endParaRPr lang="en-US" sz="1500" dirty="0"/>
           </a:p>
@@ -4132,7 +4132,7 @@
                 <a:ea typeface="Georgia" pitchFamily="34" charset="-122"/>
                 <a:cs typeface="Georgia" pitchFamily="34" charset="-120"/>
               </a:rPr>
-              <a:t>What you give up</a:t>
+              <a:t>What we would give up</a:t>
             </a:r>
             <a:endParaRPr lang="en-US" sz="1600" dirty="0"/>
           </a:p>
@@ -4171,7 +4171,7 @@
                 <a:ea typeface="Calibri" pitchFamily="34" charset="-122"/>
                 <a:cs typeface="Calibri" pitchFamily="34" charset="-120"/>
               </a:rPr>
-              <a:t>Grok and an IDE cannot edit the public pages the way they edit this project. Custom layout CSS is outside SnapPages support.</a:t>
+              <a:t>The exact look of the new site. Subsplash sets the layout. We can change colors and words. We cannot freely redesign the page.</a:t>
             </a:r>
             <a:endParaRPr lang="en-US" sz="1500" dirty="0"/>
           </a:p>
@@ -4269,7 +4269,7 @@
                 <a:ea typeface="Calibri" pitchFamily="34" charset="-122"/>
                 <a:cs typeface="Calibri" pitchFamily="34" charset="-120"/>
               </a:rPr>
-              <a:t>Simpler for a volunteer who wants one church login. The finished look is the theme, not the site already designed.</a:t>
+              <a:t>Easier if the office wants one church login. The finished site will look like a Subsplash site, not the one already designed.</a:t>
             </a:r>
             <a:endParaRPr lang="en-US" sz="1500" dirty="0"/>
           </a:p>
@@ -4308,7 +4308,7 @@
                 <a:ea typeface="Calibri" pitchFamily="34" charset="-122"/>
                 <a:cs typeface="Calibri" pitchFamily="34" charset="-120"/>
               </a:rPr>
-              <a:t>Calvary Chapel Frederick  ·  Public website options  ·  28 September 2026</a:t>
+              <a:t>For Pastor Dave and Pastor Shawn  ·  28 September 2026</a:t>
             </a:r>
             <a:endParaRPr lang="en-US" sz="1100" dirty="0"/>
           </a:p>
@@ -4418,7 +4418,7 @@
                 <a:ea typeface="Georgia" pitchFamily="34" charset="-122"/>
                 <a:cs typeface="Georgia" pitchFamily="34" charset="-120"/>
               </a:rPr>
-              <a:t>What is new money, and what is not</a:t>
+              <a:t>What this costs</a:t>
             </a:r>
             <a:endParaRPr lang="en-US" sz="3000" dirty="0"/>
           </a:p>
@@ -4457,7 +4457,7 @@
                 <a:ea typeface="Calibri" pitchFamily="34" charset="-122"/>
                 <a:cs typeface="Calibri" pitchFamily="34" charset="-120"/>
               </a:rPr>
-              <a:t>The Subsplash bill for the app, giving, and sermons stays on both options. These rows are only the website.</a:t>
+              <a:t>The Subsplash bill for the app, giving, and sermons stays either way. This table is only the website.</a:t>
             </a:r>
             <a:endParaRPr lang="en-US" sz="1500" dirty="0"/>
           </a:p>
@@ -4714,7 +4714,7 @@
                           <a:ea typeface="Calibri" pitchFamily="34" charset="-122"/>
                           <a:cs typeface="Calibri" pitchFamily="34" charset="-120"/>
                         </a:rPr>
-                        <a:t>Editor software</a:t>
+                        <a:t>The editing tool</a:t>
                       </a:r>
                       <a:endParaRPr lang="en-US" sz="1300" dirty="0">
                         <a:latin typeface="Calibri" charset="0"/>
@@ -4782,7 +4782,7 @@
                           <a:ea typeface="Calibri" pitchFamily="34" charset="-122"/>
                           <a:cs typeface="Calibri" pitchFamily="34" charset="-120"/>
                         </a:rPr>
-                        <a:t>Free. Two people only. A third login is not on this plan.</a:t>
+                        <a:t>Free for two people. A third person is not included.</a:t>
                       </a:r>
                       <a:endParaRPr lang="en-US" sz="1300" dirty="0">
                         <a:latin typeface="Calibri" charset="0"/>
@@ -4850,7 +4850,7 @@
                           <a:ea typeface="Calibri" pitchFamily="34" charset="-122"/>
                           <a:cs typeface="Calibri" pitchFamily="34" charset="-120"/>
                         </a:rPr>
-                        <a:t>No separate editor fee. Uses the Subsplash websites seat the church already has.</a:t>
+                        <a:t>No extra charge. It uses the Subsplash website tools we already have.</a:t>
                       </a:r>
                       <a:endParaRPr lang="en-US" sz="1300" dirty="0">
                         <a:latin typeface="Calibri" charset="0"/>
@@ -4920,7 +4920,7 @@
                           <a:ea typeface="Calibri" pitchFamily="34" charset="-122"/>
                           <a:cs typeface="Calibri" pitchFamily="34" charset="-120"/>
                         </a:rPr>
-                        <a:t>Hosting</a:t>
+                        <a:t>Where it lives online</a:t>
                       </a:r>
                       <a:endParaRPr lang="en-US" sz="1300" dirty="0">
                         <a:latin typeface="Calibri" charset="0"/>
@@ -4988,7 +4988,7 @@
                           <a:ea typeface="Calibri" pitchFamily="34" charset="-122"/>
                           <a:cs typeface="Calibri" pitchFamily="34" charset="-120"/>
                         </a:rPr>
-                        <a:t>Vercel, already running the preview. Budget $0 extra on the current team, or $20 a month if a new Pro seat is required.</a:t>
+                        <a:t>The sample site is already hosted. Plan on $0 extra, or about $20 a month if a paid hosting seat is needed.</a:t>
                       </a:r>
                       <a:endParaRPr lang="en-US" sz="1300" dirty="0">
                         <a:latin typeface="Calibri" charset="0"/>
@@ -5056,7 +5056,7 @@
                           <a:ea typeface="Calibri" pitchFamily="34" charset="-122"/>
                           <a:cs typeface="Calibri" pitchFamily="34" charset="-120"/>
                         </a:rPr>
-                        <a:t>Included with SnapPages. Hosting is Subsplash.</a:t>
+                        <a:t>Included. Subsplash hosts the site.</a:t>
                       </a:r>
                       <a:endParaRPr lang="en-US" sz="1300" dirty="0">
                         <a:latin typeface="Calibri" charset="0"/>
@@ -5126,7 +5126,7 @@
                           <a:ea typeface="Calibri" pitchFamily="34" charset="-122"/>
                           <a:cs typeface="Calibri" pitchFamily="34" charset="-120"/>
                         </a:rPr>
-                        <a:t>Rebuild</a:t>
+                        <a:t>Building the pages</a:t>
                       </a:r>
                       <a:endParaRPr lang="en-US" sz="1300" dirty="0">
                         <a:latin typeface="Calibri" charset="0"/>
@@ -5194,7 +5194,7 @@
                           <a:ea typeface="Calibri" pitchFamily="34" charset="-122"/>
                           <a:cs typeface="Calibri" pitchFamily="34" charset="-120"/>
                         </a:rPr>
-                        <a:t>The site is already built. Remaining work is finishing Tina and training the office.</a:t>
+                        <a:t>The site is already built. We finish the editor and show the office how to use it.</a:t>
                       </a:r>
                       <a:endParaRPr lang="en-US" sz="1300" dirty="0">
                         <a:latin typeface="Calibri" charset="0"/>
@@ -5262,7 +5262,7 @@
                           <a:ea typeface="Calibri" pitchFamily="34" charset="-122"/>
                           <a:cs typeface="Calibri" pitchFamily="34" charset="-120"/>
                         </a:rPr>
-                        <a:t>Full rebuild by hand. The designed pages cannot be imported. That is staff or vendor time, not a listed monthly fee.</a:t>
+                        <a:t>Every page is built again by hand. That is people’s time, not a monthly fee.</a:t>
                       </a:r>
                       <a:endParaRPr lang="en-US" sz="1300" dirty="0">
                         <a:latin typeface="Calibri" charset="0"/>
@@ -5332,7 +5332,7 @@
                           <a:ea typeface="Calibri" pitchFamily="34" charset="-122"/>
                           <a:cs typeface="Calibri" pitchFamily="34" charset="-120"/>
                         </a:rPr>
-                        <a:t>Published list price</a:t>
+                        <a:t>Is the price public?</a:t>
                       </a:r>
                       <a:endParaRPr lang="en-US" sz="1300" dirty="0">
                         <a:latin typeface="Calibri" charset="0"/>
@@ -5400,7 +5400,7 @@
                           <a:ea typeface="Calibri" pitchFamily="34" charset="-122"/>
                           <a:cs typeface="Calibri" pitchFamily="34" charset="-120"/>
                         </a:rPr>
-                        <a:t>Free tier, checked 28 September 2026 at tina.io/pricing. It stops at 2 users.</a:t>
+                        <a:t>Yes. Free for two people. Checked 28 September 2026.</a:t>
                       </a:r>
                       <a:endParaRPr lang="en-US" sz="1300" dirty="0">
                         <a:latin typeface="Calibri" charset="0"/>
@@ -5468,7 +5468,7 @@
                           <a:ea typeface="Calibri" pitchFamily="34" charset="-122"/>
                           <a:cs typeface="Calibri" pitchFamily="34" charset="-120"/>
                         </a:rPr>
-                        <a:t>SnapPages names Basic and Advanced plans and does not publish the dollars. Subsplash One is a custom quote.</a:t>
+                        <a:t>Subsplash does not list a public price. Check our current bill before assuming a new charge.</a:t>
                       </a:r>
                       <a:endParaRPr lang="en-US" sz="1300" dirty="0">
                         <a:latin typeface="Calibri" charset="0"/>
@@ -5538,7 +5538,7 @@
                           <a:ea typeface="Calibri" pitchFamily="34" charset="-122"/>
                           <a:cs typeface="Calibri" pitchFamily="34" charset="-120"/>
                         </a:rPr>
-                        <a:t>Year-one website cash</a:t>
+                        <a:t>Cost this year</a:t>
                       </a:r>
                       <a:endParaRPr lang="en-US" sz="1300" dirty="0">
                         <a:latin typeface="Calibri" charset="0"/>
@@ -5606,7 +5606,7 @@
                           <a:ea typeface="Calibri" pitchFamily="34" charset="-122"/>
                           <a:cs typeface="Calibri" pitchFamily="34" charset="-120"/>
                         </a:rPr>
-                        <a:t>$0 for Tina. Hosting is $0 to $240 a year, plus time to finish the editor.</a:t>
+                        <a:t>$0 for Tina. Hosting is $0, or up to about $240 for the year if a paid seat is needed.</a:t>
                       </a:r>
                       <a:endParaRPr lang="en-US" sz="1300" dirty="0">
                         <a:latin typeface="Calibri" charset="0"/>
@@ -5674,7 +5674,7 @@
                           <a:ea typeface="Calibri" pitchFamily="34" charset="-122"/>
                           <a:cs typeface="Calibri" pitchFamily="34" charset="-120"/>
                         </a:rPr>
-                        <a:t>$0 of new software if the current websites seat covers it. The cost is the rebuild.</a:t>
+                        <a:t>$0 in new software if our plan already includes the website. The cost is the time to rebuild.</a:t>
                       </a:r>
                       <a:endParaRPr lang="en-US" sz="1300" dirty="0">
                         <a:latin typeface="Calibri" charset="0"/>
@@ -5763,7 +5763,7 @@
                 <a:ea typeface="Calibri" pitchFamily="34" charset="-122"/>
                 <a:cs typeface="Calibri" pitchFamily="34" charset="-120"/>
               </a:rPr>
-              <a:t>Calvary Chapel Frederick  ·  Public website options  ·  28 September 2026</a:t>
+              <a:t>For Pastor Dave and Pastor Shawn  ·  28 September 2026</a:t>
             </a:r>
             <a:endParaRPr lang="en-US" sz="1100" dirty="0"/>
           </a:p>
@@ -5873,7 +5873,7 @@
                 <a:ea typeface="Georgia" pitchFamily="34" charset="-122"/>
                 <a:cs typeface="Georgia" pitchFamily="34" charset="-120"/>
               </a:rPr>
-              <a:t>How a normal week feels</a:t>
+              <a:t>A normal week at the church</a:t>
             </a:r>
             <a:endParaRPr lang="en-US" sz="3200" dirty="0"/>
           </a:p>
@@ -5924,7 +5924,7 @@
                           <a:ea typeface="Calibri" pitchFamily="34" charset="-122"/>
                           <a:cs typeface="Calibri" pitchFamily="34" charset="-120"/>
                         </a:rPr>
-                        <a:t>Job</a:t>
+                        <a:t>The job</a:t>
                       </a:r>
                       <a:endParaRPr lang="en-US" sz="1400" dirty="0">
                         <a:latin typeface="Calibri" charset="0"/>
@@ -6130,7 +6130,7 @@
                           <a:ea typeface="Calibri" pitchFamily="34" charset="-122"/>
                           <a:cs typeface="Calibri" pitchFamily="34" charset="-120"/>
                         </a:rPr>
-                        <a:t>Change Sunday’s time</a:t>
+                        <a:t>Change the Sunday time</a:t>
                       </a:r>
                       <a:endParaRPr lang="en-US" sz="1300" dirty="0">
                         <a:latin typeface="Calibri" charset="0"/>
@@ -6266,7 +6266,7 @@
                           <a:ea typeface="Calibri" pitchFamily="34" charset="-122"/>
                           <a:cs typeface="Calibri" pitchFamily="34" charset="-120"/>
                         </a:rPr>
-                        <a:t>Open the SnapPages block and edit the text.</a:t>
+                        <a:t>Open the page in Subsplash and change the words.</a:t>
                       </a:r>
                       <a:endParaRPr lang="en-US" sz="1300" dirty="0">
                         <a:latin typeface="Calibri" charset="0"/>
@@ -6336,7 +6336,7 @@
                           <a:ea typeface="Calibri" pitchFamily="34" charset="-122"/>
                           <a:cs typeface="Calibri" pitchFamily="34" charset="-120"/>
                         </a:rPr>
-                        <a:t>New sermon video</a:t>
+                        <a:t>A new sermon video</a:t>
                       </a:r>
                       <a:endParaRPr lang="en-US" sz="1300" dirty="0">
                         <a:latin typeface="Calibri" charset="0"/>
@@ -6404,7 +6404,7 @@
                           <a:ea typeface="Calibri" pitchFamily="34" charset="-122"/>
                           <a:cs typeface="Calibri" pitchFamily="34" charset="-120"/>
                         </a:rPr>
-                        <a:t>Subsplash. Same as today.</a:t>
+                        <a:t>Upload it in Subsplash. Same as today.</a:t>
                       </a:r>
                       <a:endParaRPr lang="en-US" sz="1300" dirty="0">
                         <a:latin typeface="Calibri" charset="0"/>
@@ -6472,7 +6472,7 @@
                           <a:ea typeface="Calibri" pitchFamily="34" charset="-122"/>
                           <a:cs typeface="Calibri" pitchFamily="34" charset="-120"/>
                         </a:rPr>
-                        <a:t>Subsplash. Same as today.</a:t>
+                        <a:t>Upload it in Subsplash. Same as today.</a:t>
                       </a:r>
                       <a:endParaRPr lang="en-US" sz="1300" dirty="0">
                         <a:latin typeface="Calibri" charset="0"/>
@@ -6542,7 +6542,7 @@
                           <a:ea typeface="Calibri" pitchFamily="34" charset="-122"/>
                           <a:cs typeface="Calibri" pitchFamily="34" charset="-120"/>
                         </a:rPr>
-                        <a:t>New bulletin PDF</a:t>
+                        <a:t>A new bulletin</a:t>
                       </a:r>
                       <a:endParaRPr lang="en-US" sz="1300" dirty="0">
                         <a:latin typeface="Calibri" charset="0"/>
@@ -6610,7 +6610,7 @@
                           <a:ea typeface="Calibri" pitchFamily="34" charset="-122"/>
                           <a:cs typeface="Calibri" pitchFamily="34" charset="-120"/>
                         </a:rPr>
-                        <a:t>Aaron places the file. The office pastes the path.</a:t>
+                        <a:t>We add the PDF. The office links it on the page.</a:t>
                       </a:r>
                       <a:endParaRPr lang="en-US" sz="1300" dirty="0">
                         <a:latin typeface="Calibri" charset="0"/>
@@ -6678,7 +6678,7 @@
                           <a:ea typeface="Calibri" pitchFamily="34" charset="-122"/>
                           <a:cs typeface="Calibri" pitchFamily="34" charset="-120"/>
                         </a:rPr>
-                        <a:t>Upload into SnapPages storage and link it.</a:t>
+                        <a:t>Upload it in Subsplash and link it.</a:t>
                       </a:r>
                       <a:endParaRPr lang="en-US" sz="1300" dirty="0">
                         <a:latin typeface="Calibri" charset="0"/>
@@ -6748,7 +6748,7 @@
                           <a:ea typeface="Calibri" pitchFamily="34" charset="-122"/>
                           <a:cs typeface="Calibri" pitchFamily="34" charset="-120"/>
                         </a:rPr>
-                        <a:t>Rewrite a ministry page</a:t>
+                        <a:t>Update a ministry page</a:t>
                       </a:r>
                       <a:endParaRPr lang="en-US" sz="1300" dirty="0">
                         <a:latin typeface="Calibri" charset="0"/>
@@ -6816,7 +6816,7 @@
                           <a:ea typeface="Calibri" pitchFamily="34" charset="-122"/>
                           <a:cs typeface="Calibri" pitchFamily="34" charset="-120"/>
                         </a:rPr>
-                        <a:t>Open that page in Tina and edit on the page.</a:t>
+                        <a:t>Open that page and edit the words right on it.</a:t>
                       </a:r>
                       <a:endParaRPr lang="en-US" sz="1300" dirty="0">
                         <a:latin typeface="Calibri" charset="0"/>
@@ -6884,7 +6884,7 @@
                           <a:ea typeface="Calibri" pitchFamily="34" charset="-122"/>
                           <a:cs typeface="Calibri" pitchFamily="34" charset="-120"/>
                         </a:rPr>
-                        <a:t>Edit the section in the theme.</a:t>
+                        <a:t>Edit that section in Subsplash.</a:t>
                       </a:r>
                       <a:endParaRPr lang="en-US" sz="1300" dirty="0">
                         <a:latin typeface="Calibri" charset="0"/>
@@ -6954,7 +6954,7 @@
                           <a:ea typeface="Calibri" pitchFamily="34" charset="-122"/>
                           <a:cs typeface="Calibri" pitchFamily="34" charset="-120"/>
                         </a:rPr>
-                        <a:t>Change the look of Home</a:t>
+                        <a:t>Change how Home looks</a:t>
                       </a:r>
                       <a:endParaRPr lang="en-US" sz="1300" dirty="0">
                         <a:latin typeface="Calibri" charset="0"/>
@@ -7022,7 +7022,7 @@
                           <a:ea typeface="Calibri" pitchFamily="34" charset="-122"/>
                           <a:cs typeface="Calibri" pitchFamily="34" charset="-120"/>
                         </a:rPr>
-                        <a:t>A developer, in the project.</a:t>
+                        <a:t>That is a design change, not an office edit.</a:t>
                       </a:r>
                       <a:endParaRPr lang="en-US" sz="1300" dirty="0">
                         <a:latin typeface="Calibri" charset="0"/>
@@ -7090,7 +7090,7 @@
                           <a:ea typeface="Calibri" pitchFamily="34" charset="-122"/>
                           <a:cs typeface="Calibri" pitchFamily="34" charset="-120"/>
                         </a:rPr>
-                        <a:t>Whatever the theme allows. Custom layout is unsupported.</a:t>
+                        <a:t>Only as far as Subsplash’s design allows.</a:t>
                       </a:r>
                       <a:endParaRPr lang="en-US" sz="1300" dirty="0">
                         <a:latin typeface="Calibri" charset="0"/>
@@ -7179,7 +7179,7 @@
                 <a:ea typeface="Calibri" pitchFamily="34" charset="-122"/>
                 <a:cs typeface="Calibri" pitchFamily="34" charset="-120"/>
               </a:rPr>
-              <a:t>Calvary Chapel Frederick  ·  Public website options  ·  28 September 2026</a:t>
+              <a:t>For Pastor Dave and Pastor Shawn  ·  28 September 2026</a:t>
             </a:r>
             <a:endParaRPr lang="en-US" sz="1100" dirty="0"/>
           </a:p>
@@ -7289,7 +7289,7 @@
                 <a:ea typeface="Georgia" pitchFamily="34" charset="-122"/>
                 <a:cs typeface="Georgia" pitchFamily="34" charset="-120"/>
               </a:rPr>
-              <a:t>How to read the numbers</a:t>
+              <a:t>The simple version</a:t>
             </a:r>
             <a:endParaRPr lang="en-US" sz="3200" dirty="0"/>
           </a:p>
@@ -7367,7 +7367,7 @@
                 <a:ea typeface="Calibri" pitchFamily="34" charset="-122"/>
                 <a:cs typeface="Calibri" pitchFamily="34" charset="-120"/>
               </a:rPr>
-              <a:t>The free plan is $0 and stops at 2 users. A third person is a paid upgrade, and this comparison does not include it. Checked 28 September 2026 at tina.io/pricing.</a:t>
+              <a:t>Two staff can each have a login. A third person would cost extra, and we are not planning that.</a:t>
             </a:r>
             <a:endParaRPr lang="en-US" sz="1500" dirty="0"/>
           </a:p>
@@ -7406,7 +7406,7 @@
                 <a:ea typeface="Georgia" pitchFamily="34" charset="-122"/>
                 <a:cs typeface="Georgia" pitchFamily="34" charset="-120"/>
               </a:rPr>
-              <a:t>SnapPages is already in the house.</a:t>
+              <a:t>SnapPages is already in our account.</a:t>
             </a:r>
             <a:endParaRPr lang="en-US" sz="1600" dirty="0"/>
           </a:p>
@@ -7445,7 +7445,7 @@
                 <a:ea typeface="Calibri" pitchFamily="34" charset="-122"/>
                 <a:cs typeface="Calibri" pitchFamily="34" charset="-120"/>
               </a:rPr>
-              <a:t>The holding site proves a websites seat. SnapPages does not publish a dollar price. Do not budget a new website subscription until the Subsplash invoice is checked.</a:t>
+              <a:t>A practice website is already started in Subsplash. They do not list a public price. Check our bill before adding a new website charge.</a:t>
             </a:r>
             <a:endParaRPr lang="en-US" sz="1500" dirty="0"/>
           </a:p>
@@ -7484,7 +7484,7 @@
                 <a:ea typeface="Georgia" pitchFamily="34" charset="-122"/>
                 <a:cs typeface="Georgia" pitchFamily="34" charset="-120"/>
               </a:rPr>
-              <a:t>Do not subtract Subsplash.</a:t>
+              <a:t>We still pay Subsplash.</a:t>
             </a:r>
             <a:endParaRPr lang="en-US" sz="1600" dirty="0"/>
           </a:p>
@@ -7523,7 +7523,7 @@
                 <a:ea typeface="Calibri" pitchFamily="34" charset="-122"/>
                 <a:cs typeface="Calibri" pitchFamily="34" charset="-120"/>
               </a:rPr>
-              <a:t>Choosing Tina does not cancel the app, giving, or media. If websites are bundled into Subsplash One, that line may stay even when the public site lives outside it.</a:t>
+              <a:t>Choosing Tina does not cancel the app, giving, or sermons. If the website is part of our package, that part of the bill may stay.</a:t>
             </a:r>
             <a:endParaRPr lang="en-US" sz="1500" dirty="0"/>
           </a:p>
@@ -7562,7 +7562,7 @@
                 <a:ea typeface="Georgia" pitchFamily="34" charset="-122"/>
                 <a:cs typeface="Georgia" pitchFamily="34" charset="-120"/>
               </a:rPr>
-              <a:t>Giving fees are not a tie-breaker.</a:t>
+              <a:t>Giving fees stay the same.</a:t>
             </a:r>
             <a:endParaRPr lang="en-US" sz="1600" dirty="0"/>
           </a:p>
@@ -7601,7 +7601,7 @@
                 <a:ea typeface="Calibri" pitchFamily="34" charset="-122"/>
                 <a:cs typeface="Calibri" pitchFamily="34" charset="-120"/>
               </a:rPr>
-              <a:t>Card 2.3% + $0.30 and ACH 1.0% were the live rates on 16 August 2026. Both options keep that processor.</a:t>
+              <a:t>A card gift is 2.3% plus 30 cents. A bank gift is 1%. Both choices keep Subsplash for giving.</a:t>
             </a:r>
             <a:endParaRPr lang="en-US" sz="1500" dirty="0"/>
           </a:p>
@@ -7640,7 +7640,7 @@
                 <a:ea typeface="Georgia" pitchFamily="34" charset="-122"/>
                 <a:cs typeface="Georgia" pitchFamily="34" charset="-120"/>
               </a:rPr>
-              <a:t>The real difference is the rebuild.</a:t>
+              <a:t>The real choice</a:t>
             </a:r>
             <a:endParaRPr lang="en-US" sz="1600" dirty="0"/>
           </a:p>
@@ -7679,7 +7679,7 @@
                 <a:ea typeface="Calibri" pitchFamily="34" charset="-122"/>
                 <a:cs typeface="Calibri" pitchFamily="34" charset="-120"/>
               </a:rPr>
-              <a:t>Option 1 keeps the site that exists, with no editor fee for two people. Option 2 spends the rebuild to put the website inside the login the church already trusts.</a:t>
+              <a:t>Option 1 keeps the website we have already designed, at no editor cost for two people. Option 2 rebuilds it inside the Subsplash login the office already knows.</a:t>
             </a:r>
             <a:endParaRPr lang="en-US" sz="1500" dirty="0"/>
           </a:p>
@@ -7718,7 +7718,7 @@
                 <a:ea typeface="Calibri" pitchFamily="34" charset="-122"/>
                 <a:cs typeface="Calibri" pitchFamily="34" charset="-120"/>
               </a:rPr>
-              <a:t>Calvary Chapel Frederick  ·  Public website options  ·  28 September 2026</a:t>
+              <a:t>For Pastor Dave and Pastor Shawn  ·  28 September 2026</a:t>
             </a:r>
             <a:endParaRPr lang="en-US" sz="1100" dirty="0"/>
           </a:p>

</xml_diff>

<commit_message>
docs: show Tina CMS on the pastors’ website choice
The deck names it a content management system and adds the real editing screen, with the homepage on one side and the word boxes on the other.
</commit_message>
<xml_diff>
--- a/docs/website-options.pptx
+++ b/docs/website-options.pptx
@@ -4,21 +4,23 @@
   <p:sldMasterIdLst>
     <p:sldMasterId id="2147483648" r:id="rId1"/>
   </p:sldMasterIdLst>
+  <p:notesMasterIdLst>
+    <p:notesMasterId r:id="rId12"/>
+  </p:notesMasterIdLst>
   <p:sldIdLst>
     <p:sldId id="256" r:id="rId2"/>
     <p:sldId id="257" r:id="rId3"/>
     <p:sldId id="258" r:id="rId4"/>
     <p:sldId id="259" r:id="rId5"/>
-    <p:sldId id="260" r:id="rId6"/>
-    <p:sldId id="261" r:id="rId7"/>
-    <p:sldId id="262" r:id="rId8"/>
-    <p:sldId id="263" r:id="rId9"/>
+    <p:sldId id="264" r:id="rId6"/>
+    <p:sldId id="265" r:id="rId7"/>
+    <p:sldId id="260" r:id="rId8"/>
+    <p:sldId id="261" r:id="rId9"/>
+    <p:sldId id="262" r:id="rId10"/>
+    <p:sldId id="263" r:id="rId11"/>
   </p:sldIdLst>
-  <p:notesMasterIdLst>
-    <p:notesMasterId r:id="rId10"/>
-  </p:notesMasterIdLst>
-  <p:sldSz cx="12191695" cy="6858000"/>
-  <p:notesSz cx="6858000" cy="12191695"/>
+  <p:sldSz cx="12192000" cy="6858000"/>
+  <p:notesSz cx="6858000" cy="12192000"/>
   <p:defaultTextStyle>
     <a:lvl1pPr marL="0" algn="l" defTabSz="914400" rtl="0" eaLnBrk="1" latinLnBrk="0" hangingPunct="1">
       <a:defRPr sz="1800" kern="1200">
@@ -111,6 +113,11 @@
       </a:defRPr>
     </a:lvl9pPr>
   </p:defaultTextStyle>
+  <p:extLst>
+    <p:ext uri="{EFAFB233-063F-42B5-8137-9DF3F51BA10A}">
+      <p15:sldGuideLst xmlns:p15="http://schemas.microsoft.com/office/powerpoint/2012/main"/>
+    </p:ext>
+  </p:extLst>
 </p:presentation>
 </file>
 
@@ -136,234 +143,10 @@
           <a:chExt cx="0" cy="0"/>
         </a:xfrm>
       </p:grpSpPr>
-      <p:sp>
-        <p:nvSpPr>
-          <p:cNvPr id="2" name="Header Placeholder 1"/>
-          <p:cNvSpPr>
-            <a:spLocks noGrp="1"/>
-          </p:cNvSpPr>
-          <p:nvPr>
-            <p:ph type="hdr" sz="quarter"/>
-          </p:nvPr>
-        </p:nvSpPr>
-        <p:spPr>
-          <a:xfrm>
-            <a:off x="0" y="0"/>
-            <a:ext cx="2971800" cy="458788"/>
-          </a:xfrm>
-          <a:prstGeom prst="rect">
-            <a:avLst/>
-          </a:prstGeom>
-        </p:spPr>
-        <p:txBody>
-          <a:bodyPr vert="horz" lIns="91440" tIns="45720" rIns="91440" bIns="45720" rtlCol="0"/>
-          <a:lstStyle>
-            <a:lvl1pPr algn="l">
-              <a:defRPr sz="1200"/>
-            </a:lvl1pPr>
-          </a:lstStyle>
-          <a:p>
-            <a:endParaRPr lang="en-US"/>
-          </a:p>
-        </p:txBody>
-      </p:sp>
-      <p:sp>
-        <p:nvSpPr>
-          <p:cNvPr id="3" name="Date Placeholder 2"/>
-          <p:cNvSpPr>
-            <a:spLocks noGrp="1"/>
-          </p:cNvSpPr>
-          <p:nvPr>
-            <p:ph type="dt" idx="1"/>
-          </p:nvPr>
-        </p:nvSpPr>
-        <p:spPr>
-          <a:xfrm>
-            <a:off x="3884613" y="0"/>
-            <a:ext cx="2971800" cy="458788"/>
-          </a:xfrm>
-          <a:prstGeom prst="rect">
-            <a:avLst/>
-          </a:prstGeom>
-        </p:spPr>
-        <p:txBody>
-          <a:bodyPr vert="horz" lIns="91440" tIns="45720" rIns="91440" bIns="45720" rtlCol="0"/>
-          <a:lstStyle>
-            <a:lvl1pPr algn="r">
-              <a:defRPr sz="1200"/>
-            </a:lvl1pPr>
-          </a:lstStyle>
-          <a:p>
-            <a:fld id="{5282F153-3F37-0F45-9E97-73ACFA13230C}" type="datetimeFigureOut">
-              <a:rPr lang="en-US"/>
-              <a:t>7/23/19</a:t>
-            </a:fld>
-            <a:endParaRPr lang="en-US"/>
-          </a:p>
-        </p:txBody>
-      </p:sp>
-      <p:sp>
-        <p:nvSpPr>
-          <p:cNvPr id="4" name="Slide Image Placeholder 3"/>
-          <p:cNvSpPr>
-            <a:spLocks noGrp="1" noRot="1" noChangeAspect="1"/>
-          </p:cNvSpPr>
-          <p:nvPr>
-            <p:ph type="sldImg" idx="2"/>
-          </p:nvPr>
-        </p:nvSpPr>
-        <p:spPr>
-          <a:xfrm>
-            <a:off x="685800" y="1143000"/>
-            <a:ext cx="5486400" cy="3086100"/>
-          </a:xfrm>
-          <a:prstGeom prst="rect">
-            <a:avLst/>
-          </a:prstGeom>
-          <a:noFill/>
-          <a:ln w="12700">
-            <a:solidFill>
-              <a:prstClr val="black"/>
-            </a:solidFill>
-          </a:ln>
-        </p:spPr>
-        <p:txBody>
-          <a:bodyPr vert="horz" lIns="91440" tIns="45720" rIns="91440" bIns="45720" rtlCol="0" anchor="ctr"/>
-          <a:lstStyle/>
-          <a:p>
-            <a:endParaRPr lang="en-US"/>
-          </a:p>
-        </p:txBody>
-      </p:sp>
-      <p:sp>
-        <p:nvSpPr>
-          <p:cNvPr id="5" name="Notes Placeholder 4"/>
-          <p:cNvSpPr>
-            <a:spLocks noGrp="1"/>
-          </p:cNvSpPr>
-          <p:nvPr>
-            <p:ph type="body" sz="quarter" idx="3"/>
-          </p:nvPr>
-        </p:nvSpPr>
-        <p:spPr>
-          <a:xfrm>
-            <a:off x="685800" y="4400550"/>
-            <a:ext cx="5486400" cy="3600450"/>
-          </a:xfrm>
-          <a:prstGeom prst="rect">
-            <a:avLst/>
-          </a:prstGeom>
-        </p:spPr>
-        <p:txBody>
-          <a:bodyPr vert="horz" lIns="91440" tIns="45720" rIns="91440" bIns="45720" rtlCol="0"/>
-          <a:lstStyle/>
-          <a:p>
-            <a:pPr lvl="0"/>
-            <a:r>
-              <a:rPr lang="en-US"/>
-              <a:t>Click to edit Master text styles</a:t>
-            </a:r>
-          </a:p>
-          <a:p>
-            <a:pPr lvl="1"/>
-            <a:r>
-              <a:rPr lang="en-US"/>
-              <a:t>Second level</a:t>
-            </a:r>
-          </a:p>
-          <a:p>
-            <a:pPr lvl="2"/>
-            <a:r>
-              <a:rPr lang="en-US"/>
-              <a:t>Third level</a:t>
-            </a:r>
-          </a:p>
-          <a:p>
-            <a:pPr lvl="3"/>
-            <a:r>
-              <a:rPr lang="en-US"/>
-              <a:t>Fourth level</a:t>
-            </a:r>
-          </a:p>
-          <a:p>
-            <a:pPr lvl="4"/>
-            <a:r>
-              <a:rPr lang="en-US"/>
-              <a:t>Fifth level</a:t>
-            </a:r>
-          </a:p>
-        </p:txBody>
-      </p:sp>
-      <p:sp>
-        <p:nvSpPr>
-          <p:cNvPr id="6" name="Footer Placeholder 5"/>
-          <p:cNvSpPr>
-            <a:spLocks noGrp="1"/>
-          </p:cNvSpPr>
-          <p:nvPr>
-            <p:ph type="ftr" sz="quarter" idx="4"/>
-          </p:nvPr>
-        </p:nvSpPr>
-        <p:spPr>
-          <a:xfrm>
-            <a:off x="0" y="8685213"/>
-            <a:ext cx="2971800" cy="458787"/>
-          </a:xfrm>
-          <a:prstGeom prst="rect">
-            <a:avLst/>
-          </a:prstGeom>
-        </p:spPr>
-        <p:txBody>
-          <a:bodyPr vert="horz" lIns="91440" tIns="45720" rIns="91440" bIns="45720" rtlCol="0" anchor="b"/>
-          <a:lstStyle>
-            <a:lvl1pPr algn="l">
-              <a:defRPr sz="1200"/>
-            </a:lvl1pPr>
-          </a:lstStyle>
-          <a:p>
-            <a:endParaRPr lang="en-US"/>
-          </a:p>
-        </p:txBody>
-      </p:sp>
-      <p:sp>
-        <p:nvSpPr>
-          <p:cNvPr id="7" name="Slide Number Placeholder 6"/>
-          <p:cNvSpPr>
-            <a:spLocks noGrp="1"/>
-          </p:cNvSpPr>
-          <p:nvPr>
-            <p:ph type="sldNum" sz="quarter" idx="5"/>
-          </p:nvPr>
-        </p:nvSpPr>
-        <p:spPr>
-          <a:xfrm>
-            <a:off x="3884613" y="8685213"/>
-            <a:ext cx="2971800" cy="458787"/>
-          </a:xfrm>
-          <a:prstGeom prst="rect">
-            <a:avLst/>
-          </a:prstGeom>
-        </p:spPr>
-        <p:txBody>
-          <a:bodyPr vert="horz" lIns="91440" tIns="45720" rIns="91440" bIns="45720" rtlCol="0" anchor="b"/>
-          <a:lstStyle>
-            <a:lvl1pPr algn="r">
-              <a:defRPr sz="1200"/>
-            </a:lvl1pPr>
-          </a:lstStyle>
-          <a:p>
-            <a:fld id="{CE5E9CC1-C706-0F49-92D6-E571CC5EEA8F}" type="slidenum">
-              <a:rPr lang="en-US"/>
-              <a:t>‹#›</a:t>
-            </a:fld>
-            <a:endParaRPr lang="en-US"/>
-          </a:p>
-        </p:txBody>
-      </p:sp>
     </p:spTree>
     <p:extLst>
       <p:ext uri="{BB962C8B-B14F-4D97-AF65-F5344CB8AC3E}">
-        <p14:creationId xmlns:p14="http://schemas.microsoft.com/office/powerpoint/2010/main" val="1024086991"/>
+        <p14:creationId xmlns:p14="http://schemas.microsoft.com/office/powerpoint/2010/main" val="1566942129"/>
       </p:ext>
     </p:extLst>
   </p:cSld>
@@ -507,10 +290,6 @@
           <a:bodyPr/>
           <a:lstStyle/>
           <a:p>
-            <a:r>
-              <a:rPr lang="en-US" dirty="0"/>
-              <a:t/>
-            </a:r>
             <a:endParaRPr lang="en-US" dirty="0"/>
           </a:p>
         </p:txBody>
@@ -595,10 +374,6 @@
           <a:bodyPr/>
           <a:lstStyle/>
           <a:p>
-            <a:r>
-              <a:rPr lang="en-US" dirty="0"/>
-              <a:t/>
-            </a:r>
             <a:endParaRPr lang="en-US" dirty="0"/>
           </a:p>
         </p:txBody>
@@ -683,10 +458,6 @@
           <a:bodyPr/>
           <a:lstStyle/>
           <a:p>
-            <a:r>
-              <a:rPr lang="en-US" dirty="0"/>
-              <a:t/>
-            </a:r>
             <a:endParaRPr lang="en-US" dirty="0"/>
           </a:p>
         </p:txBody>
@@ -771,10 +542,6 @@
           <a:bodyPr/>
           <a:lstStyle/>
           <a:p>
-            <a:r>
-              <a:rPr lang="en-US" dirty="0"/>
-              <a:t/>
-            </a:r>
             <a:endParaRPr lang="en-US" dirty="0"/>
           </a:p>
         </p:txBody>
@@ -859,10 +626,6 @@
           <a:bodyPr/>
           <a:lstStyle/>
           <a:p>
-            <a:r>
-              <a:rPr lang="en-US" dirty="0"/>
-              <a:t/>
-            </a:r>
             <a:endParaRPr lang="en-US" dirty="0"/>
           </a:p>
         </p:txBody>
@@ -884,7 +647,7 @@
           <a:p>
             <a:fld id="{F7021451-1387-4CA6-816F-3879F97B5CBC}" type="slidenum">
               <a:rPr lang="en-US"/>
-              <a:t>5</a:t>
+              <a:t>7</a:t>
             </a:fld>
             <a:endParaRPr lang="en-US"/>
           </a:p>
@@ -947,10 +710,6 @@
           <a:bodyPr/>
           <a:lstStyle/>
           <a:p>
-            <a:r>
-              <a:rPr lang="en-US" dirty="0"/>
-              <a:t/>
-            </a:r>
             <a:endParaRPr lang="en-US" dirty="0"/>
           </a:p>
         </p:txBody>
@@ -972,7 +731,7 @@
           <a:p>
             <a:fld id="{F7021451-1387-4CA6-816F-3879F97B5CBC}" type="slidenum">
               <a:rPr lang="en-US"/>
-              <a:t>6</a:t>
+              <a:t>8</a:t>
             </a:fld>
             <a:endParaRPr lang="en-US"/>
           </a:p>
@@ -1035,10 +794,6 @@
           <a:bodyPr/>
           <a:lstStyle/>
           <a:p>
-            <a:r>
-              <a:rPr lang="en-US" dirty="0"/>
-              <a:t/>
-            </a:r>
             <a:endParaRPr lang="en-US" dirty="0"/>
           </a:p>
         </p:txBody>
@@ -1060,7 +815,7 @@
           <a:p>
             <a:fld id="{F7021451-1387-4CA6-816F-3879F97B5CBC}" type="slidenum">
               <a:rPr lang="en-US"/>
-              <a:t>7</a:t>
+              <a:t>9</a:t>
             </a:fld>
             <a:endParaRPr lang="en-US"/>
           </a:p>
@@ -1123,10 +878,6 @@
           <a:bodyPr/>
           <a:lstStyle/>
           <a:p>
-            <a:r>
-              <a:rPr lang="en-US" dirty="0"/>
-              <a:t/>
-            </a:r>
             <a:endParaRPr lang="en-US" dirty="0"/>
           </a:p>
         </p:txBody>
@@ -1148,7 +899,7 @@
           <a:p>
             <a:fld id="{F7021451-1387-4CA6-816F-3879F97B5CBC}" type="slidenum">
               <a:rPr lang="en-US"/>
-              <a:t>8</a:t>
+              <a:t>10</a:t>
             </a:fld>
             <a:endParaRPr lang="en-US"/>
           </a:p>
@@ -1200,6 +951,11 @@
 <file path=ppt/slideMasters/slideMaster1.xml><?xml version="1.0" encoding="utf-8"?>
 <p:sldMaster xmlns:a="http://schemas.openxmlformats.org/drawingml/2006/main" xmlns:r="http://schemas.openxmlformats.org/officeDocument/2006/relationships" xmlns:p="http://schemas.openxmlformats.org/presentationml/2006/main">
   <p:cSld>
+    <p:bg>
+      <p:bgRef idx="1001">
+        <a:schemeClr val="bg1"/>
+      </p:bgRef>
+    </p:bg>
     <p:spTree>
       <p:nvGrpSpPr>
         <p:cNvPr id="1" name=""/>
@@ -1482,6 +1238,7 @@
         <a:solidFill>
           <a:srgbClr val="122820"/>
         </a:solidFill>
+        <a:effectLst/>
       </p:bgPr>
     </p:bg>
     <p:spTree>
@@ -1517,6 +1274,13 @@
           </a:solidFill>
           <a:ln/>
         </p:spPr>
+        <p:txBody>
+          <a:bodyPr/>
+          <a:lstStyle/>
+          <a:p>
+            <a:endParaRPr lang="en-US"/>
+          </a:p>
+        </p:txBody>
       </p:sp>
       <p:sp>
         <p:nvSpPr>
@@ -1539,11 +1303,11 @@
           <a:bodyPr wrap="square" lIns="0" tIns="0" rIns="0" bIns="0" rtlCol="0" anchor="ctr"/>
           <a:lstStyle/>
           <a:p>
-            <a:pPr indent="0" marL="0">
+            <a:pPr marL="0" indent="0">
               <a:buNone/>
             </a:pPr>
             <a:r>
-              <a:rPr lang="en-US" sz="1400" spc="220" kern="0" dirty="0">
+              <a:rPr lang="en-US" sz="1400" kern="0" spc="220" dirty="0">
                 <a:solidFill>
                   <a:srgbClr val="A68445"/>
                 </a:solidFill>
@@ -1578,7 +1342,7 @@
           <a:bodyPr wrap="square" lIns="0" tIns="0" rIns="0" bIns="0" rtlCol="0" anchor="ctr"/>
           <a:lstStyle/>
           <a:p>
-            <a:pPr indent="0" marL="0">
+            <a:pPr marL="0" indent="0">
               <a:buNone/>
             </a:pPr>
             <a:r>
@@ -1595,7 +1359,7 @@
             <a:endParaRPr lang="en-US" sz="4800" dirty="0"/>
           </a:p>
           <a:p>
-            <a:pPr indent="0" marL="0">
+            <a:pPr marL="0" indent="0">
               <a:buNone/>
             </a:pPr>
             <a:r>
@@ -1607,7 +1371,7 @@
                 <a:ea typeface="Georgia" pitchFamily="34" charset="-122"/>
                 <a:cs typeface="Georgia" pitchFamily="34" charset="-120"/>
               </a:rPr>
-              <a:t>for our website</a:t>
+              <a:t>for the website</a:t>
             </a:r>
             <a:endParaRPr lang="en-US" sz="4800" dirty="0"/>
           </a:p>
@@ -1634,7 +1398,7 @@
           <a:bodyPr wrap="square" lIns="0" tIns="0" rIns="0" bIns="0" rtlCol="0" anchor="ctr"/>
           <a:lstStyle/>
           <a:p>
-            <a:pPr indent="0" marL="0">
+            <a:pPr marL="0" indent="0">
               <a:buNone/>
             </a:pPr>
             <a:r>
@@ -1673,7 +1437,7 @@
           <a:bodyPr wrap="square" lIns="0" tIns="0" rIns="0" bIns="0" rtlCol="0" anchor="ctr"/>
           <a:lstStyle/>
           <a:p>
-            <a:pPr indent="0" marL="0">
+            <a:pPr marL="0" indent="0">
               <a:buNone/>
             </a:pPr>
             <a:r>
@@ -1688,6 +1452,546 @@
               <a:t>A simple look at the choice  ·  28 September 2026</a:t>
             </a:r>
             <a:endParaRPr lang="en-US" sz="1400" dirty="0"/>
+          </a:p>
+        </p:txBody>
+      </p:sp>
+    </p:spTree>
+  </p:cSld>
+  <p:clrMapOvr>
+    <a:masterClrMapping/>
+  </p:clrMapOvr>
+</p:sld>
+</file>
+
+<file path=ppt/slides/slide10.xml><?xml version="1.0" encoding="utf-8"?>
+<p:sld xmlns:a="http://schemas.openxmlformats.org/drawingml/2006/main" xmlns:r="http://schemas.openxmlformats.org/officeDocument/2006/relationships" xmlns:p="http://schemas.openxmlformats.org/presentationml/2006/main">
+  <p:cSld name="Slide 8">
+    <p:bg>
+      <p:bgPr>
+        <a:solidFill>
+          <a:srgbClr val="F6F1E7"/>
+        </a:solidFill>
+        <a:effectLst/>
+      </p:bgPr>
+    </p:bg>
+    <p:spTree>
+      <p:nvGrpSpPr>
+        <p:cNvPr id="1" name=""/>
+        <p:cNvGrpSpPr/>
+        <p:nvPr/>
+      </p:nvGrpSpPr>
+      <p:grpSpPr>
+        <a:xfrm>
+          <a:off x="0" y="0"/>
+          <a:ext cx="0" cy="0"/>
+          <a:chOff x="0" y="0"/>
+          <a:chExt cx="0" cy="0"/>
+        </a:xfrm>
+      </p:grpSpPr>
+      <p:sp>
+        <p:nvSpPr>
+          <p:cNvPr id="2" name="Text 0"/>
+          <p:cNvSpPr/>
+          <p:nvPr/>
+        </p:nvSpPr>
+        <p:spPr>
+          <a:xfrm>
+            <a:off x="502920" y="347472"/>
+            <a:ext cx="10972800" cy="457200"/>
+          </a:xfrm>
+          <a:prstGeom prst="rect">
+            <a:avLst/>
+          </a:prstGeom>
+          <a:noFill/>
+          <a:ln/>
+        </p:spPr>
+        <p:txBody>
+          <a:bodyPr wrap="square" lIns="0" tIns="0" rIns="0" bIns="0" rtlCol="0" anchor="ctr"/>
+          <a:lstStyle/>
+          <a:p>
+            <a:pPr marL="0" indent="0">
+              <a:buNone/>
+            </a:pPr>
+            <a:r>
+              <a:rPr lang="en-US" sz="3200" dirty="0">
+                <a:solidFill>
+                  <a:srgbClr val="1C3A32"/>
+                </a:solidFill>
+                <a:latin typeface="Georgia" pitchFamily="34" charset="0"/>
+                <a:ea typeface="Georgia" pitchFamily="34" charset="-122"/>
+                <a:cs typeface="Georgia" pitchFamily="34" charset="-120"/>
+              </a:rPr>
+              <a:t>The simple version</a:t>
+            </a:r>
+            <a:endParaRPr lang="en-US" sz="3200" dirty="0"/>
+          </a:p>
+        </p:txBody>
+      </p:sp>
+      <p:sp>
+        <p:nvSpPr>
+          <p:cNvPr id="3" name="Text 1"/>
+          <p:cNvSpPr/>
+          <p:nvPr/>
+        </p:nvSpPr>
+        <p:spPr>
+          <a:xfrm>
+            <a:off x="502920" y="1005840"/>
+            <a:ext cx="3749040" cy="777240"/>
+          </a:xfrm>
+          <a:prstGeom prst="rect">
+            <a:avLst/>
+          </a:prstGeom>
+          <a:noFill/>
+          <a:ln/>
+        </p:spPr>
+        <p:txBody>
+          <a:bodyPr wrap="square" lIns="0" tIns="0" rIns="0" bIns="0" rtlCol="0" anchor="t"/>
+          <a:lstStyle/>
+          <a:p>
+            <a:pPr marL="0" indent="0">
+              <a:buNone/>
+            </a:pPr>
+            <a:r>
+              <a:rPr lang="en-US" sz="1600" dirty="0">
+                <a:solidFill>
+                  <a:srgbClr val="1C3A32"/>
+                </a:solidFill>
+                <a:latin typeface="Georgia" pitchFamily="34" charset="0"/>
+                <a:ea typeface="Georgia" pitchFamily="34" charset="-122"/>
+                <a:cs typeface="Georgia" pitchFamily="34" charset="-120"/>
+              </a:rPr>
+              <a:t>Tina CMS is free for two people.</a:t>
+            </a:r>
+            <a:endParaRPr lang="en-US" sz="1600" dirty="0"/>
+          </a:p>
+        </p:txBody>
+      </p:sp>
+      <p:sp>
+        <p:nvSpPr>
+          <p:cNvPr id="4" name="Text 2"/>
+          <p:cNvSpPr/>
+          <p:nvPr/>
+        </p:nvSpPr>
+        <p:spPr>
+          <a:xfrm>
+            <a:off x="4389120" y="1005840"/>
+            <a:ext cx="7223760" cy="822960"/>
+          </a:xfrm>
+          <a:prstGeom prst="rect">
+            <a:avLst/>
+          </a:prstGeom>
+          <a:noFill/>
+          <a:ln/>
+        </p:spPr>
+        <p:txBody>
+          <a:bodyPr wrap="square" lIns="0" tIns="0" rIns="0" bIns="0" rtlCol="0" anchor="t"/>
+          <a:lstStyle/>
+          <a:p>
+            <a:pPr marL="0" indent="0">
+              <a:buNone/>
+            </a:pPr>
+            <a:r>
+              <a:rPr lang="en-US" sz="1500" dirty="0">
+                <a:solidFill>
+                  <a:srgbClr val="1E2A26"/>
+                </a:solidFill>
+                <a:latin typeface="Calibri" pitchFamily="34" charset="0"/>
+                <a:ea typeface="Calibri" pitchFamily="34" charset="-122"/>
+                <a:cs typeface="Calibri" pitchFamily="34" charset="-120"/>
+              </a:rPr>
+              <a:t>Two staff can each have a login. A third person would cost extra, and we are not planning that.</a:t>
+            </a:r>
+            <a:endParaRPr lang="en-US" sz="1500" dirty="0"/>
+          </a:p>
+        </p:txBody>
+      </p:sp>
+      <p:sp>
+        <p:nvSpPr>
+          <p:cNvPr id="5" name="Text 3"/>
+          <p:cNvSpPr/>
+          <p:nvPr/>
+        </p:nvSpPr>
+        <p:spPr>
+          <a:xfrm>
+            <a:off x="502920" y="1965960"/>
+            <a:ext cx="3749040" cy="777240"/>
+          </a:xfrm>
+          <a:prstGeom prst="rect">
+            <a:avLst/>
+          </a:prstGeom>
+          <a:noFill/>
+          <a:ln/>
+        </p:spPr>
+        <p:txBody>
+          <a:bodyPr wrap="square" lIns="0" tIns="0" rIns="0" bIns="0" rtlCol="0" anchor="t"/>
+          <a:lstStyle/>
+          <a:p>
+            <a:pPr marL="0" indent="0">
+              <a:buNone/>
+            </a:pPr>
+            <a:r>
+              <a:rPr lang="en-US" sz="1600" dirty="0">
+                <a:solidFill>
+                  <a:srgbClr val="1C3A32"/>
+                </a:solidFill>
+                <a:latin typeface="Georgia" pitchFamily="34" charset="0"/>
+                <a:ea typeface="Georgia" pitchFamily="34" charset="-122"/>
+                <a:cs typeface="Georgia" pitchFamily="34" charset="-120"/>
+              </a:rPr>
+              <a:t>SnapPages is already in our account.</a:t>
+            </a:r>
+            <a:endParaRPr lang="en-US" sz="1600" dirty="0"/>
+          </a:p>
+        </p:txBody>
+      </p:sp>
+      <p:sp>
+        <p:nvSpPr>
+          <p:cNvPr id="6" name="Text 4"/>
+          <p:cNvSpPr/>
+          <p:nvPr/>
+        </p:nvSpPr>
+        <p:spPr>
+          <a:xfrm>
+            <a:off x="4389120" y="1965960"/>
+            <a:ext cx="7223760" cy="822960"/>
+          </a:xfrm>
+          <a:prstGeom prst="rect">
+            <a:avLst/>
+          </a:prstGeom>
+          <a:noFill/>
+          <a:ln/>
+        </p:spPr>
+        <p:txBody>
+          <a:bodyPr wrap="square" lIns="0" tIns="0" rIns="0" bIns="0" rtlCol="0" anchor="t"/>
+          <a:lstStyle/>
+          <a:p>
+            <a:pPr marL="0" indent="0">
+              <a:buNone/>
+            </a:pPr>
+            <a:r>
+              <a:rPr lang="en-US" sz="1500" dirty="0">
+                <a:solidFill>
+                  <a:srgbClr val="1E2A26"/>
+                </a:solidFill>
+                <a:latin typeface="Calibri" pitchFamily="34" charset="0"/>
+                <a:ea typeface="Calibri" pitchFamily="34" charset="-122"/>
+                <a:cs typeface="Calibri" pitchFamily="34" charset="-120"/>
+              </a:rPr>
+              <a:t>A practice website is already started in Subsplash. They do not list a public price. Check our bill before adding a new website charge.</a:t>
+            </a:r>
+            <a:endParaRPr lang="en-US" sz="1500" dirty="0"/>
+          </a:p>
+        </p:txBody>
+      </p:sp>
+      <p:sp>
+        <p:nvSpPr>
+          <p:cNvPr id="7" name="Text 5"/>
+          <p:cNvSpPr/>
+          <p:nvPr/>
+        </p:nvSpPr>
+        <p:spPr>
+          <a:xfrm>
+            <a:off x="502920" y="2926080"/>
+            <a:ext cx="3749040" cy="777240"/>
+          </a:xfrm>
+          <a:prstGeom prst="rect">
+            <a:avLst/>
+          </a:prstGeom>
+          <a:noFill/>
+          <a:ln/>
+        </p:spPr>
+        <p:txBody>
+          <a:bodyPr wrap="square" lIns="0" tIns="0" rIns="0" bIns="0" rtlCol="0" anchor="t"/>
+          <a:lstStyle/>
+          <a:p>
+            <a:pPr marL="0" indent="0">
+              <a:buNone/>
+            </a:pPr>
+            <a:r>
+              <a:rPr lang="en-US" sz="1600" dirty="0">
+                <a:solidFill>
+                  <a:srgbClr val="1C3A32"/>
+                </a:solidFill>
+                <a:latin typeface="Georgia" pitchFamily="34" charset="0"/>
+                <a:ea typeface="Georgia" pitchFamily="34" charset="-122"/>
+                <a:cs typeface="Georgia" pitchFamily="34" charset="-120"/>
+              </a:rPr>
+              <a:t>We still pay Subsplash.</a:t>
+            </a:r>
+            <a:endParaRPr lang="en-US" sz="1600" dirty="0"/>
+          </a:p>
+        </p:txBody>
+      </p:sp>
+      <p:sp>
+        <p:nvSpPr>
+          <p:cNvPr id="8" name="Text 6"/>
+          <p:cNvSpPr/>
+          <p:nvPr/>
+        </p:nvSpPr>
+        <p:spPr>
+          <a:xfrm>
+            <a:off x="4389120" y="2926080"/>
+            <a:ext cx="7223760" cy="822960"/>
+          </a:xfrm>
+          <a:prstGeom prst="rect">
+            <a:avLst/>
+          </a:prstGeom>
+          <a:noFill/>
+          <a:ln/>
+        </p:spPr>
+        <p:txBody>
+          <a:bodyPr wrap="square" lIns="0" tIns="0" rIns="0" bIns="0" rtlCol="0" anchor="t"/>
+          <a:lstStyle/>
+          <a:p>
+            <a:pPr marL="0" indent="0">
+              <a:buNone/>
+            </a:pPr>
+            <a:r>
+              <a:rPr lang="en-US" sz="1500" dirty="0">
+                <a:solidFill>
+                  <a:srgbClr val="1E2A26"/>
+                </a:solidFill>
+                <a:latin typeface="Calibri" pitchFamily="34" charset="0"/>
+                <a:ea typeface="Calibri" pitchFamily="34" charset="-122"/>
+                <a:cs typeface="Calibri" pitchFamily="34" charset="-120"/>
+              </a:rPr>
+              <a:t>Choosing Tina CMS does not cancel the app, giving, or sermons. If the website is part of our package, that part of the bill may stay.</a:t>
+            </a:r>
+            <a:endParaRPr lang="en-US" sz="1500" dirty="0"/>
+          </a:p>
+        </p:txBody>
+      </p:sp>
+      <p:sp>
+        <p:nvSpPr>
+          <p:cNvPr id="9" name="Text 7"/>
+          <p:cNvSpPr/>
+          <p:nvPr/>
+        </p:nvSpPr>
+        <p:spPr>
+          <a:xfrm>
+            <a:off x="502920" y="3886200"/>
+            <a:ext cx="3749040" cy="777240"/>
+          </a:xfrm>
+          <a:prstGeom prst="rect">
+            <a:avLst/>
+          </a:prstGeom>
+          <a:noFill/>
+          <a:ln/>
+        </p:spPr>
+        <p:txBody>
+          <a:bodyPr wrap="square" lIns="0" tIns="0" rIns="0" bIns="0" rtlCol="0" anchor="t"/>
+          <a:lstStyle/>
+          <a:p>
+            <a:pPr marL="0" indent="0">
+              <a:buNone/>
+            </a:pPr>
+            <a:r>
+              <a:rPr lang="en-US" sz="1600" dirty="0">
+                <a:solidFill>
+                  <a:srgbClr val="1C3A32"/>
+                </a:solidFill>
+                <a:latin typeface="Georgia" pitchFamily="34" charset="0"/>
+                <a:ea typeface="Georgia" pitchFamily="34" charset="-122"/>
+                <a:cs typeface="Georgia" pitchFamily="34" charset="-120"/>
+              </a:rPr>
+              <a:t>Giving fees stay the same.</a:t>
+            </a:r>
+            <a:endParaRPr lang="en-US" sz="1600" dirty="0"/>
+          </a:p>
+        </p:txBody>
+      </p:sp>
+      <p:sp>
+        <p:nvSpPr>
+          <p:cNvPr id="10" name="Text 8"/>
+          <p:cNvSpPr/>
+          <p:nvPr/>
+        </p:nvSpPr>
+        <p:spPr>
+          <a:xfrm>
+            <a:off x="4389120" y="3886200"/>
+            <a:ext cx="7223760" cy="822960"/>
+          </a:xfrm>
+          <a:prstGeom prst="rect">
+            <a:avLst/>
+          </a:prstGeom>
+          <a:noFill/>
+          <a:ln/>
+        </p:spPr>
+        <p:txBody>
+          <a:bodyPr wrap="square" lIns="0" tIns="0" rIns="0" bIns="0" rtlCol="0" anchor="t"/>
+          <a:lstStyle/>
+          <a:p>
+            <a:pPr marL="0" indent="0">
+              <a:buNone/>
+            </a:pPr>
+            <a:r>
+              <a:rPr lang="en-US" sz="1500" dirty="0">
+                <a:solidFill>
+                  <a:srgbClr val="1E2A26"/>
+                </a:solidFill>
+                <a:latin typeface="Calibri" pitchFamily="34" charset="0"/>
+                <a:ea typeface="Calibri" pitchFamily="34" charset="-122"/>
+                <a:cs typeface="Calibri" pitchFamily="34" charset="-120"/>
+              </a:rPr>
+              <a:t>A card gift is 2.3% plus 30 cents. A bank gift is 1%. Both choices keep Subsplash for giving.</a:t>
+            </a:r>
+            <a:endParaRPr lang="en-US" sz="1500" dirty="0"/>
+          </a:p>
+        </p:txBody>
+      </p:sp>
+      <p:sp>
+        <p:nvSpPr>
+          <p:cNvPr id="11" name="Text 9"/>
+          <p:cNvSpPr/>
+          <p:nvPr/>
+        </p:nvSpPr>
+        <p:spPr>
+          <a:xfrm>
+            <a:off x="502920" y="4846320"/>
+            <a:ext cx="3749040" cy="777240"/>
+          </a:xfrm>
+          <a:prstGeom prst="rect">
+            <a:avLst/>
+          </a:prstGeom>
+          <a:noFill/>
+          <a:ln/>
+        </p:spPr>
+        <p:txBody>
+          <a:bodyPr wrap="square" lIns="0" tIns="0" rIns="0" bIns="0" rtlCol="0" anchor="t"/>
+          <a:lstStyle/>
+          <a:p>
+            <a:pPr marL="0" indent="0">
+              <a:buNone/>
+            </a:pPr>
+            <a:r>
+              <a:rPr lang="en-US" sz="1600" dirty="0">
+                <a:solidFill>
+                  <a:srgbClr val="1C3A32"/>
+                </a:solidFill>
+                <a:latin typeface="Georgia" pitchFamily="34" charset="0"/>
+                <a:ea typeface="Georgia" pitchFamily="34" charset="-122"/>
+                <a:cs typeface="Georgia" pitchFamily="34" charset="-120"/>
+              </a:rPr>
+              <a:t>The real choice</a:t>
+            </a:r>
+            <a:endParaRPr lang="en-US" sz="1600" dirty="0"/>
+          </a:p>
+        </p:txBody>
+      </p:sp>
+      <p:sp>
+        <p:nvSpPr>
+          <p:cNvPr id="12" name="Text 10"/>
+          <p:cNvSpPr/>
+          <p:nvPr/>
+        </p:nvSpPr>
+        <p:spPr>
+          <a:xfrm>
+            <a:off x="4389120" y="4846320"/>
+            <a:ext cx="7223760" cy="822960"/>
+          </a:xfrm>
+          <a:prstGeom prst="rect">
+            <a:avLst/>
+          </a:prstGeom>
+          <a:noFill/>
+          <a:ln/>
+        </p:spPr>
+        <p:txBody>
+          <a:bodyPr wrap="square" lIns="0" tIns="0" rIns="0" bIns="0" rtlCol="0" anchor="t"/>
+          <a:lstStyle/>
+          <a:p>
+            <a:pPr marL="0" indent="0">
+              <a:buNone/>
+            </a:pPr>
+            <a:r>
+              <a:rPr lang="en-US" sz="1500" dirty="0">
+                <a:solidFill>
+                  <a:srgbClr val="1E2A26"/>
+                </a:solidFill>
+                <a:latin typeface="Calibri" pitchFamily="34" charset="0"/>
+                <a:ea typeface="Calibri" pitchFamily="34" charset="-122"/>
+                <a:cs typeface="Calibri" pitchFamily="34" charset="-120"/>
+              </a:rPr>
+              <a:t>Option 1 keeps the website we have already designed, at no editor cost for two people. Option 2 rebuilds it inside the Subsplash login the office already knows.</a:t>
+            </a:r>
+            <a:endParaRPr lang="en-US" sz="1500" dirty="0"/>
+          </a:p>
+        </p:txBody>
+      </p:sp>
+      <p:sp>
+        <p:nvSpPr>
+          <p:cNvPr id="13" name="Text 11"/>
+          <p:cNvSpPr/>
+          <p:nvPr/>
+        </p:nvSpPr>
+        <p:spPr>
+          <a:xfrm>
+            <a:off x="502920" y="6510528"/>
+            <a:ext cx="9326880" cy="219456"/>
+          </a:xfrm>
+          <a:prstGeom prst="rect">
+            <a:avLst/>
+          </a:prstGeom>
+          <a:noFill/>
+          <a:ln/>
+        </p:spPr>
+        <p:txBody>
+          <a:bodyPr wrap="square" lIns="0" tIns="0" rIns="0" bIns="0" rtlCol="0" anchor="ctr"/>
+          <a:lstStyle/>
+          <a:p>
+            <a:pPr marL="0" indent="0">
+              <a:buNone/>
+            </a:pPr>
+            <a:r>
+              <a:rPr lang="en-US" sz="1100" dirty="0">
+                <a:solidFill>
+                  <a:srgbClr val="5C6B64"/>
+                </a:solidFill>
+                <a:latin typeface="Calibri" pitchFamily="34" charset="0"/>
+                <a:ea typeface="Calibri" pitchFamily="34" charset="-122"/>
+                <a:cs typeface="Calibri" pitchFamily="34" charset="-120"/>
+              </a:rPr>
+              <a:t>For Pastor Dave and Pastor Shawn  ·  28 September 2026</a:t>
+            </a:r>
+            <a:endParaRPr lang="en-US" sz="1100" dirty="0"/>
+          </a:p>
+        </p:txBody>
+      </p:sp>
+      <p:sp>
+        <p:nvSpPr>
+          <p:cNvPr id="14" name="Text 12"/>
+          <p:cNvSpPr/>
+          <p:nvPr/>
+        </p:nvSpPr>
+        <p:spPr>
+          <a:xfrm>
+            <a:off x="11155680" y="6510528"/>
+            <a:ext cx="502920" cy="219456"/>
+          </a:xfrm>
+          <a:prstGeom prst="rect">
+            <a:avLst/>
+          </a:prstGeom>
+          <a:noFill/>
+          <a:ln/>
+        </p:spPr>
+        <p:txBody>
+          <a:bodyPr wrap="square" lIns="0" tIns="0" rIns="0" bIns="0" rtlCol="0" anchor="ctr"/>
+          <a:lstStyle/>
+          <a:p>
+            <a:pPr marL="0" indent="0" algn="r">
+              <a:buNone/>
+            </a:pPr>
+            <a:r>
+              <a:rPr lang="en-US" sz="1100" dirty="0">
+                <a:solidFill>
+                  <a:srgbClr val="5C6B64"/>
+                </a:solidFill>
+                <a:latin typeface="Calibri" pitchFamily="34" charset="0"/>
+                <a:ea typeface="Calibri" pitchFamily="34" charset="-122"/>
+                <a:cs typeface="Calibri" pitchFamily="34" charset="-120"/>
+              </a:rPr>
+              <a:t>10</a:t>
+            </a:r>
+            <a:endParaRPr lang="en-US" sz="1100" dirty="0"/>
           </a:p>
         </p:txBody>
       </p:sp>
@@ -1707,6 +2011,7 @@
         <a:solidFill>
           <a:srgbClr val="F6F1E7"/>
         </a:solidFill>
+        <a:effectLst/>
       </p:bgPr>
     </p:bg>
     <p:spTree>
@@ -1744,7 +2049,7 @@
           <a:bodyPr wrap="square" lIns="0" tIns="0" rIns="0" bIns="0" rtlCol="0" anchor="ctr"/>
           <a:lstStyle/>
           <a:p>
-            <a:pPr indent="0" marL="0">
+            <a:pPr marL="0" indent="0">
               <a:buNone/>
             </a:pPr>
             <a:r>
@@ -1783,7 +2088,7 @@
           <a:bodyPr wrap="square" lIns="0" tIns="0" rIns="0" bIns="0" rtlCol="0" anchor="ctr"/>
           <a:lstStyle/>
           <a:p>
-            <a:pPr indent="0" marL="0">
+            <a:pPr marL="0" indent="0">
               <a:buNone/>
             </a:pPr>
             <a:r>
@@ -1820,13 +2125,20 @@
           </a:solidFill>
           <a:ln/>
           <a:effectLst>
-            <a:outerShdw sx="100000" sy="100000" kx="0" ky="0" algn="bl" rotWithShape="0" blurRad="177800" dist="38100" dir="8100000">
+            <a:outerShdw blurRad="177800" dist="38100" dir="8100000" algn="bl" rotWithShape="0">
               <a:srgbClr val="1C3A32">
                 <a:alpha val="8000"/>
               </a:srgbClr>
             </a:outerShdw>
           </a:effectLst>
         </p:spPr>
+        <p:txBody>
+          <a:bodyPr/>
+          <a:lstStyle/>
+          <a:p>
+            <a:endParaRPr lang="en-US"/>
+          </a:p>
+        </p:txBody>
       </p:sp>
       <p:sp>
         <p:nvSpPr>
@@ -1847,6 +2159,13 @@
           </a:solidFill>
           <a:ln/>
         </p:spPr>
+        <p:txBody>
+          <a:bodyPr/>
+          <a:lstStyle/>
+          <a:p>
+            <a:endParaRPr lang="en-US"/>
+          </a:p>
+        </p:txBody>
       </p:sp>
       <p:sp>
         <p:nvSpPr>
@@ -1869,11 +2188,11 @@
           <a:bodyPr wrap="square" lIns="0" tIns="0" rIns="0" bIns="0" rtlCol="0" anchor="ctr"/>
           <a:lstStyle/>
           <a:p>
-            <a:pPr indent="0" marL="0">
+            <a:pPr marL="0" indent="0">
               <a:buNone/>
             </a:pPr>
             <a:r>
-              <a:rPr lang="en-US" sz="1300" spc="140" kern="0" dirty="0">
+              <a:rPr lang="en-US" sz="1300" kern="0" spc="140" dirty="0">
                 <a:solidFill>
                   <a:srgbClr val="A68445"/>
                 </a:solidFill>
@@ -1908,7 +2227,7 @@
           <a:bodyPr wrap="square" lIns="0" tIns="0" rIns="0" bIns="0" rtlCol="0" anchor="ctr"/>
           <a:lstStyle/>
           <a:p>
-            <a:pPr indent="0" marL="0">
+            <a:pPr marL="0" indent="0">
               <a:buNone/>
             </a:pPr>
             <a:r>
@@ -1920,7 +2239,7 @@
                 <a:ea typeface="Georgia" pitchFamily="34" charset="-122"/>
                 <a:cs typeface="Georgia" pitchFamily="34" charset="-120"/>
               </a:rPr>
-              <a:t>Keep the new website. Edit it in Tina.</a:t>
+              <a:t>Keep the new website. Edit it in Tina CMS</a:t>
             </a:r>
             <a:endParaRPr lang="en-US" sz="2600" dirty="0"/>
           </a:p>
@@ -1947,7 +2266,7 @@
           <a:bodyPr wrap="square" lIns="0" tIns="0" rIns="0" bIns="0" rtlCol="0" anchor="ctr"/>
           <a:lstStyle/>
           <a:p>
-            <a:pPr indent="0" marL="0">
+            <a:pPr marL="0" indent="0">
               <a:buNone/>
             </a:pPr>
             <a:r>
@@ -1959,7 +2278,7 @@
                 <a:ea typeface="Calibri" pitchFamily="34" charset="-122"/>
                 <a:cs typeface="Calibri" pitchFamily="34" charset="-120"/>
               </a:rPr>
-              <a:t>The website we have been designing stays. The office clicks the words on the page and changes them. Sermons, giving, and the app stay in Subsplash, just as they are now.</a:t>
+              <a:t>Tina CMS (Content Management System) is a simple screen for changing the words. The office clicks the page and types. Sermons, giving, and the Church app stay in Subsplash.</a:t>
             </a:r>
             <a:endParaRPr lang="en-US" sz="1600" dirty="0"/>
           </a:p>
@@ -1986,7 +2305,7 @@
           <a:bodyPr wrap="square" lIns="0" tIns="0" rIns="0" bIns="0" rtlCol="0" anchor="ctr"/>
           <a:lstStyle/>
           <a:p>
-            <a:pPr indent="0" marL="0">
+            <a:pPr marL="0" indent="0">
               <a:buNone/>
             </a:pPr>
             <a:r>
@@ -2003,7 +2322,7 @@
             <a:endParaRPr lang="en-US" sz="1500" dirty="0"/>
           </a:p>
           <a:p>
-            <a:pPr indent="0" marL="0">
+            <a:pPr marL="0" indent="0">
               <a:buNone/>
             </a:pPr>
             <a:r>
@@ -2040,13 +2359,20 @@
           </a:solidFill>
           <a:ln/>
           <a:effectLst>
-            <a:outerShdw sx="100000" sy="100000" kx="0" ky="0" algn="bl" rotWithShape="0" blurRad="177800" dist="38100" dir="8100000">
+            <a:outerShdw blurRad="177800" dist="38100" dir="8100000" algn="bl" rotWithShape="0">
               <a:srgbClr val="1C3A32">
                 <a:alpha val="8000"/>
               </a:srgbClr>
             </a:outerShdw>
           </a:effectLst>
         </p:spPr>
+        <p:txBody>
+          <a:bodyPr/>
+          <a:lstStyle/>
+          <a:p>
+            <a:endParaRPr lang="en-US"/>
+          </a:p>
+        </p:txBody>
       </p:sp>
       <p:sp>
         <p:nvSpPr>
@@ -2067,6 +2393,13 @@
           </a:solidFill>
           <a:ln/>
         </p:spPr>
+        <p:txBody>
+          <a:bodyPr/>
+          <a:lstStyle/>
+          <a:p>
+            <a:endParaRPr lang="en-US"/>
+          </a:p>
+        </p:txBody>
       </p:sp>
       <p:sp>
         <p:nvSpPr>
@@ -2089,11 +2422,11 @@
           <a:bodyPr wrap="square" lIns="0" tIns="0" rIns="0" bIns="0" rtlCol="0" anchor="ctr"/>
           <a:lstStyle/>
           <a:p>
-            <a:pPr indent="0" marL="0">
+            <a:pPr marL="0" indent="0">
               <a:buNone/>
             </a:pPr>
             <a:r>
-              <a:rPr lang="en-US" sz="1300" spc="140" kern="0" dirty="0">
+              <a:rPr lang="en-US" sz="1300" kern="0" spc="140" dirty="0">
                 <a:solidFill>
                   <a:srgbClr val="A68445"/>
                 </a:solidFill>
@@ -2128,7 +2461,7 @@
           <a:bodyPr wrap="square" lIns="0" tIns="0" rIns="0" bIns="0" rtlCol="0" anchor="ctr"/>
           <a:lstStyle/>
           <a:p>
-            <a:pPr indent="0" marL="0">
+            <a:pPr marL="0" indent="0">
               <a:buNone/>
             </a:pPr>
             <a:r>
@@ -2167,7 +2500,7 @@
           <a:bodyPr wrap="square" lIns="0" tIns="0" rIns="0" bIns="0" rtlCol="0" anchor="ctr"/>
           <a:lstStyle/>
           <a:p>
-            <a:pPr indent="0" marL="0">
+            <a:pPr marL="0" indent="0">
               <a:buNone/>
             </a:pPr>
             <a:r>
@@ -2206,7 +2539,7 @@
           <a:bodyPr wrap="square" lIns="0" tIns="0" rIns="0" bIns="0" rtlCol="0" anchor="ctr"/>
           <a:lstStyle/>
           <a:p>
-            <a:pPr indent="0" marL="0">
+            <a:pPr marL="0" indent="0">
               <a:buNone/>
             </a:pPr>
             <a:r>
@@ -2223,7 +2556,7 @@
             <a:endParaRPr lang="en-US" sz="1500" dirty="0"/>
           </a:p>
           <a:p>
-            <a:pPr indent="0" marL="0">
+            <a:pPr marL="0" indent="0">
               <a:buNone/>
             </a:pPr>
             <a:r>
@@ -2262,7 +2595,7 @@
           <a:bodyPr wrap="square" lIns="0" tIns="0" rIns="0" bIns="0" rtlCol="0" anchor="ctr"/>
           <a:lstStyle/>
           <a:p>
-            <a:pPr indent="0" marL="0">
+            <a:pPr marL="0" indent="0">
               <a:buNone/>
             </a:pPr>
             <a:r>
@@ -2301,7 +2634,7 @@
           <a:bodyPr wrap="square" lIns="0" tIns="0" rIns="0" bIns="0" rtlCol="0" anchor="ctr"/>
           <a:lstStyle/>
           <a:p>
-            <a:pPr algn="r" indent="0" marL="0">
+            <a:pPr marL="0" indent="0" algn="r">
               <a:buNone/>
             </a:pPr>
             <a:r>
@@ -2335,6 +2668,7 @@
         <a:solidFill>
           <a:srgbClr val="F6F1E7"/>
         </a:solidFill>
+        <a:effectLst/>
       </p:bgPr>
     </p:bg>
     <p:spTree>
@@ -2372,7 +2706,7 @@
           <a:bodyPr wrap="square" lIns="0" tIns="0" rIns="0" bIns="0" rtlCol="0" anchor="ctr"/>
           <a:lstStyle/>
           <a:p>
-            <a:pPr indent="0" marL="0">
+            <a:pPr marL="0" indent="0">
               <a:buNone/>
             </a:pPr>
             <a:r>
@@ -2411,7 +2745,7 @@
           <a:bodyPr wrap="square" lIns="0" tIns="0" rIns="0" bIns="0" rtlCol="0" anchor="ctr"/>
           <a:lstStyle/>
           <a:p>
-            <a:pPr indent="0" marL="0">
+            <a:pPr marL="0" indent="0">
               <a:buNone/>
             </a:pPr>
             <a:r>
@@ -2448,6 +2782,13 @@
           </a:solidFill>
           <a:ln/>
         </p:spPr>
+        <p:txBody>
+          <a:bodyPr/>
+          <a:lstStyle/>
+          <a:p>
+            <a:endParaRPr lang="en-US"/>
+          </a:p>
+        </p:txBody>
       </p:sp>
       <p:sp>
         <p:nvSpPr>
@@ -2470,7 +2811,7 @@
           <a:bodyPr wrap="square" lIns="0" tIns="0" rIns="0" bIns="0" rtlCol="0" anchor="ctr"/>
           <a:lstStyle/>
           <a:p>
-            <a:pPr indent="0" marL="0">
+            <a:pPr marL="0" indent="0">
               <a:buNone/>
             </a:pPr>
             <a:r>
@@ -2509,7 +2850,7 @@
           <a:bodyPr wrap="square" lIns="0" tIns="0" rIns="0" bIns="0" rtlCol="0" anchor="ctr"/>
           <a:lstStyle/>
           <a:p>
-            <a:pPr indent="0" marL="0">
+            <a:pPr marL="0" indent="0">
               <a:buNone/>
             </a:pPr>
             <a:r>
@@ -2546,6 +2887,13 @@
           </a:solidFill>
           <a:ln/>
         </p:spPr>
+        <p:txBody>
+          <a:bodyPr/>
+          <a:lstStyle/>
+          <a:p>
+            <a:endParaRPr lang="en-US"/>
+          </a:p>
+        </p:txBody>
       </p:sp>
       <p:sp>
         <p:nvSpPr>
@@ -2568,7 +2916,7 @@
           <a:bodyPr wrap="square" lIns="0" tIns="0" rIns="0" bIns="0" rtlCol="0" anchor="ctr"/>
           <a:lstStyle/>
           <a:p>
-            <a:pPr indent="0" marL="0">
+            <a:pPr marL="0" indent="0">
               <a:buNone/>
             </a:pPr>
             <a:r>
@@ -2607,7 +2955,7 @@
           <a:bodyPr wrap="square" lIns="0" tIns="0" rIns="0" bIns="0" rtlCol="0" anchor="ctr"/>
           <a:lstStyle/>
           <a:p>
-            <a:pPr indent="0" marL="0">
+            <a:pPr marL="0" indent="0">
               <a:buNone/>
             </a:pPr>
             <a:r>
@@ -2644,6 +2992,13 @@
           </a:solidFill>
           <a:ln/>
         </p:spPr>
+        <p:txBody>
+          <a:bodyPr/>
+          <a:lstStyle/>
+          <a:p>
+            <a:endParaRPr lang="en-US"/>
+          </a:p>
+        </p:txBody>
       </p:sp>
       <p:sp>
         <p:nvSpPr>
@@ -2666,7 +3021,7 @@
           <a:bodyPr wrap="square" lIns="0" tIns="0" rIns="0" bIns="0" rtlCol="0" anchor="ctr"/>
           <a:lstStyle/>
           <a:p>
-            <a:pPr indent="0" marL="0">
+            <a:pPr marL="0" indent="0">
               <a:buNone/>
             </a:pPr>
             <a:r>
@@ -2705,7 +3060,7 @@
           <a:bodyPr wrap="square" lIns="0" tIns="0" rIns="0" bIns="0" rtlCol="0" anchor="ctr"/>
           <a:lstStyle/>
           <a:p>
-            <a:pPr indent="0" marL="0">
+            <a:pPr marL="0" indent="0">
               <a:buNone/>
             </a:pPr>
             <a:r>
@@ -2742,6 +3097,13 @@
           </a:solidFill>
           <a:ln/>
         </p:spPr>
+        <p:txBody>
+          <a:bodyPr/>
+          <a:lstStyle/>
+          <a:p>
+            <a:endParaRPr lang="en-US"/>
+          </a:p>
+        </p:txBody>
       </p:sp>
       <p:sp>
         <p:nvSpPr>
@@ -2764,7 +3126,7 @@
           <a:bodyPr wrap="square" lIns="0" tIns="0" rIns="0" bIns="0" rtlCol="0" anchor="ctr"/>
           <a:lstStyle/>
           <a:p>
-            <a:pPr indent="0" marL="0">
+            <a:pPr marL="0" indent="0">
               <a:buNone/>
             </a:pPr>
             <a:r>
@@ -2803,7 +3165,7 @@
           <a:bodyPr wrap="square" lIns="0" tIns="0" rIns="0" bIns="0" rtlCol="0" anchor="ctr"/>
           <a:lstStyle/>
           <a:p>
-            <a:pPr indent="0" marL="0">
+            <a:pPr marL="0" indent="0">
               <a:buNone/>
             </a:pPr>
             <a:r>
@@ -2840,6 +3202,13 @@
           </a:solidFill>
           <a:ln/>
         </p:spPr>
+        <p:txBody>
+          <a:bodyPr/>
+          <a:lstStyle/>
+          <a:p>
+            <a:endParaRPr lang="en-US"/>
+          </a:p>
+        </p:txBody>
       </p:sp>
       <p:sp>
         <p:nvSpPr>
@@ -2862,7 +3231,7 @@
           <a:bodyPr wrap="square" lIns="0" tIns="0" rIns="0" bIns="0" rtlCol="0" anchor="ctr"/>
           <a:lstStyle/>
           <a:p>
-            <a:pPr indent="0" marL="0">
+            <a:pPr marL="0" indent="0">
               <a:buNone/>
             </a:pPr>
             <a:r>
@@ -2901,7 +3270,7 @@
           <a:bodyPr wrap="square" lIns="0" tIns="0" rIns="0" bIns="0" rtlCol="0" anchor="ctr"/>
           <a:lstStyle/>
           <a:p>
-            <a:pPr indent="0" marL="0">
+            <a:pPr marL="0" indent="0">
               <a:buNone/>
             </a:pPr>
             <a:r>
@@ -2940,7 +3309,7 @@
           <a:bodyPr wrap="square" lIns="0" tIns="0" rIns="0" bIns="0" rtlCol="0" anchor="ctr"/>
           <a:lstStyle/>
           <a:p>
-            <a:pPr indent="0" marL="0">
+            <a:pPr marL="0" indent="0">
               <a:buNone/>
             </a:pPr>
             <a:r>
@@ -2979,7 +3348,7 @@
           <a:bodyPr wrap="square" lIns="0" tIns="0" rIns="0" bIns="0" rtlCol="0" anchor="ctr"/>
           <a:lstStyle/>
           <a:p>
-            <a:pPr algn="r" indent="0" marL="0">
+            <a:pPr marL="0" indent="0" algn="r">
               <a:buNone/>
             </a:pPr>
             <a:r>
@@ -3013,6 +3382,7 @@
         <a:solidFill>
           <a:srgbClr val="F6F1E7"/>
         </a:solidFill>
+        <a:effectLst/>
       </p:bgPr>
     </p:bg>
     <p:spTree>
@@ -3050,7 +3420,7 @@
           <a:bodyPr wrap="square" lIns="0" tIns="0" rIns="0" bIns="0" rtlCol="0" anchor="ctr"/>
           <a:lstStyle/>
           <a:p>
-            <a:pPr indent="0" marL="0">
+            <a:pPr marL="0" indent="0">
               <a:buNone/>
             </a:pPr>
             <a:r>
@@ -3062,7 +3432,7 @@
                 <a:ea typeface="Georgia" pitchFamily="34" charset="-122"/>
                 <a:cs typeface="Georgia" pitchFamily="34" charset="-120"/>
               </a:rPr>
-              <a:t>Option 1. Tina</a:t>
+              <a:t>Option 1. Tina CMS</a:t>
             </a:r>
             <a:endParaRPr lang="en-US" sz="3200" dirty="0"/>
           </a:p>
@@ -3089,7 +3459,7 @@
           <a:bodyPr wrap="square" lIns="0" tIns="0" rIns="0" bIns="0" rtlCol="0" anchor="ctr"/>
           <a:lstStyle/>
           <a:p>
-            <a:pPr indent="0" marL="0">
+            <a:pPr marL="0" indent="0">
               <a:buNone/>
             </a:pPr>
             <a:r>
@@ -3101,7 +3471,7 @@
                 <a:ea typeface="Calibri" pitchFamily="34" charset="-122"/>
                 <a:cs typeface="Calibri" pitchFamily="34" charset="-120"/>
               </a:rPr>
-              <a:t>The office sees the page while they type. They do not need to learn code.</a:t>
+              <a:t>Content Management System means a screen for the words. The office sees the page while they type.</a:t>
             </a:r>
             <a:endParaRPr lang="en-US" sz="1600" dirty="0"/>
           </a:p>
@@ -3126,6 +3496,13 @@
           </a:solidFill>
           <a:ln/>
         </p:spPr>
+        <p:txBody>
+          <a:bodyPr/>
+          <a:lstStyle/>
+          <a:p>
+            <a:endParaRPr lang="en-US"/>
+          </a:p>
+        </p:txBody>
       </p:sp>
       <p:sp>
         <p:nvSpPr>
@@ -3148,7 +3525,7 @@
           <a:bodyPr wrap="square" lIns="0" tIns="0" rIns="0" bIns="0" rtlCol="0" anchor="ctr"/>
           <a:lstStyle/>
           <a:p>
-            <a:pPr indent="0" marL="0">
+            <a:pPr marL="0" indent="0">
               <a:buNone/>
             </a:pPr>
             <a:r>
@@ -3187,7 +3564,7 @@
           <a:bodyPr wrap="square" lIns="0" tIns="0" rIns="0" bIns="0" rtlCol="0" anchor="ctr"/>
           <a:lstStyle/>
           <a:p>
-            <a:pPr indent="0" marL="0">
+            <a:pPr marL="0" indent="0">
               <a:buNone/>
             </a:pPr>
             <a:r>
@@ -3199,7 +3576,7 @@
                 <a:ea typeface="Calibri" pitchFamily="34" charset="-122"/>
                 <a:cs typeface="Calibri" pitchFamily="34" charset="-120"/>
               </a:rPr>
-              <a:t>They open Tina, click the words on the page, type the new words, and save.</a:t>
+              <a:t>They open Tina CMS, click the words on the page, type the new words, and save.</a:t>
             </a:r>
             <a:endParaRPr lang="en-US" sz="1500" dirty="0"/>
           </a:p>
@@ -3224,6 +3601,13 @@
           </a:solidFill>
           <a:ln/>
         </p:spPr>
+        <p:txBody>
+          <a:bodyPr/>
+          <a:lstStyle/>
+          <a:p>
+            <a:endParaRPr lang="en-US"/>
+          </a:p>
+        </p:txBody>
       </p:sp>
       <p:sp>
         <p:nvSpPr>
@@ -3246,7 +3630,7 @@
           <a:bodyPr wrap="square" lIns="0" tIns="0" rIns="0" bIns="0" rtlCol="0" anchor="ctr"/>
           <a:lstStyle/>
           <a:p>
-            <a:pPr indent="0" marL="0">
+            <a:pPr marL="0" indent="0">
               <a:buNone/>
             </a:pPr>
             <a:r>
@@ -3285,7 +3669,7 @@
           <a:bodyPr wrap="square" lIns="0" tIns="0" rIns="0" bIns="0" rtlCol="0" anchor="ctr"/>
           <a:lstStyle/>
           <a:p>
-            <a:pPr indent="0" marL="0">
+            <a:pPr marL="0" indent="0">
               <a:buNone/>
             </a:pPr>
             <a:r>
@@ -3322,6 +3706,13 @@
           </a:solidFill>
           <a:ln/>
         </p:spPr>
+        <p:txBody>
+          <a:bodyPr/>
+          <a:lstStyle/>
+          <a:p>
+            <a:endParaRPr lang="en-US"/>
+          </a:p>
+        </p:txBody>
       </p:sp>
       <p:sp>
         <p:nvSpPr>
@@ -3344,7 +3735,7 @@
           <a:bodyPr wrap="square" lIns="0" tIns="0" rIns="0" bIns="0" rtlCol="0" anchor="ctr"/>
           <a:lstStyle/>
           <a:p>
-            <a:pPr indent="0" marL="0">
+            <a:pPr marL="0" indent="0">
               <a:buNone/>
             </a:pPr>
             <a:r>
@@ -3383,7 +3774,7 @@
           <a:bodyPr wrap="square" lIns="0" tIns="0" rIns="0" bIns="0" rtlCol="0" anchor="ctr"/>
           <a:lstStyle/>
           <a:p>
-            <a:pPr indent="0" marL="0">
+            <a:pPr marL="0" indent="0">
               <a:buNone/>
             </a:pPr>
             <a:r>
@@ -3420,6 +3811,13 @@
           </a:solidFill>
           <a:ln/>
         </p:spPr>
+        <p:txBody>
+          <a:bodyPr/>
+          <a:lstStyle/>
+          <a:p>
+            <a:endParaRPr lang="en-US"/>
+          </a:p>
+        </p:txBody>
       </p:sp>
       <p:sp>
         <p:nvSpPr>
@@ -3442,7 +3840,7 @@
           <a:bodyPr wrap="square" lIns="0" tIns="0" rIns="0" bIns="0" rtlCol="0" anchor="ctr"/>
           <a:lstStyle/>
           <a:p>
-            <a:pPr indent="0" marL="0">
+            <a:pPr marL="0" indent="0">
               <a:buNone/>
             </a:pPr>
             <a:r>
@@ -3481,7 +3879,7 @@
           <a:bodyPr wrap="square" lIns="0" tIns="0" rIns="0" bIns="0" rtlCol="0" anchor="ctr"/>
           <a:lstStyle/>
           <a:p>
-            <a:pPr indent="0" marL="0">
+            <a:pPr marL="0" indent="0">
               <a:buNone/>
             </a:pPr>
             <a:r>
@@ -3518,6 +3916,13 @@
           </a:solidFill>
           <a:ln/>
         </p:spPr>
+        <p:txBody>
+          <a:bodyPr/>
+          <a:lstStyle/>
+          <a:p>
+            <a:endParaRPr lang="en-US"/>
+          </a:p>
+        </p:txBody>
       </p:sp>
       <p:sp>
         <p:nvSpPr>
@@ -3540,7 +3945,7 @@
           <a:bodyPr wrap="square" lIns="0" tIns="0" rIns="0" bIns="0" rtlCol="0" anchor="ctr"/>
           <a:lstStyle/>
           <a:p>
-            <a:pPr indent="0" marL="0">
+            <a:pPr marL="0" indent="0">
               <a:buNone/>
             </a:pPr>
             <a:r>
@@ -3579,7 +3984,7 @@
           <a:bodyPr wrap="square" lIns="0" tIns="0" rIns="0" bIns="0" rtlCol="0" anchor="ctr"/>
           <a:lstStyle/>
           <a:p>
-            <a:pPr indent="0" marL="0">
+            <a:pPr marL="0" indent="0">
               <a:buNone/>
             </a:pPr>
             <a:r>
@@ -3591,7 +3996,7 @@
                 <a:ea typeface="Calibri" pitchFamily="34" charset="-122"/>
                 <a:cs typeface="Calibri" pitchFamily="34" charset="-120"/>
               </a:rPr>
-              <a:t>Two logins. The website is Tina. Sermons, giving, and the app are Subsplash. The Watch button still plays the sermon from Subsplash.</a:t>
+              <a:t>Two logins. The website is Tina CMS. Sermons, giving, and the app are Subsplash. The Watch button still plays the sermon from Subsplash.</a:t>
             </a:r>
             <a:endParaRPr lang="en-US" sz="1500" dirty="0"/>
           </a:p>
@@ -3618,7 +4023,7 @@
           <a:bodyPr wrap="square" lIns="0" tIns="0" rIns="0" bIns="0" rtlCol="0" anchor="ctr"/>
           <a:lstStyle/>
           <a:p>
-            <a:pPr indent="0" marL="0">
+            <a:pPr marL="0" indent="0">
               <a:buNone/>
             </a:pPr>
             <a:r>
@@ -3657,7 +4062,7 @@
           <a:bodyPr wrap="square" lIns="0" tIns="0" rIns="0" bIns="0" rtlCol="0" anchor="ctr"/>
           <a:lstStyle/>
           <a:p>
-            <a:pPr algn="r" indent="0" marL="0">
+            <a:pPr marL="0" indent="0" algn="r">
               <a:buNone/>
             </a:pPr>
             <a:r>
@@ -3685,12 +4090,13 @@
 
 <file path=ppt/slides/slide5.xml><?xml version="1.0" encoding="utf-8"?>
 <p:sld xmlns:a="http://schemas.openxmlformats.org/drawingml/2006/main" xmlns:r="http://schemas.openxmlformats.org/officeDocument/2006/relationships" xmlns:p="http://schemas.openxmlformats.org/presentationml/2006/main">
-  <p:cSld name="Slide 5">
+  <p:cSld>
     <p:bg>
       <p:bgPr>
         <a:solidFill>
           <a:srgbClr val="F6F1E7"/>
         </a:solidFill>
+        <a:effectLst/>
       </p:bgPr>
     </p:bg>
     <p:spTree>
@@ -3709,647 +4115,127 @@
       </p:grpSpPr>
       <p:sp>
         <p:nvSpPr>
-          <p:cNvPr id="2" name="Text 0"/>
-          <p:cNvSpPr/>
-          <p:nvPr/>
-        </p:nvSpPr>
-        <p:spPr>
-          <a:xfrm>
-            <a:off x="502920" y="320040"/>
-            <a:ext cx="10972800" cy="438912"/>
+          <p:cNvPr id="2" name="TextBox 1"/>
+          <p:cNvSpPr txBox="1"/>
+          <p:nvPr/>
+        </p:nvSpPr>
+        <p:spPr>
+          <a:xfrm>
+            <a:off x="502920" y="256032"/>
+            <a:ext cx="11155680" cy="384048"/>
           </a:xfrm>
           <a:prstGeom prst="rect">
             <a:avLst/>
           </a:prstGeom>
           <a:noFill/>
-          <a:ln/>
-        </p:spPr>
-        <p:txBody>
-          <a:bodyPr wrap="square" lIns="0" tIns="0" rIns="0" bIns="0" rtlCol="0" anchor="ctr"/>
-          <a:lstStyle/>
-          <a:p>
-            <a:pPr indent="0" marL="0">
-              <a:buNone/>
-            </a:pPr>
+        </p:spPr>
+        <p:txBody>
+          <a:bodyPr wrap="none">
+            <a:spAutoFit/>
+          </a:bodyPr>
+          <a:lstStyle/>
+          <a:p>
             <a:r>
-              <a:rPr lang="en-US" sz="3200" dirty="0">
+              <a:rPr sz="2800" b="0">
                 <a:solidFill>
                   <a:srgbClr val="1C3A32"/>
                 </a:solidFill>
-                <a:latin typeface="Georgia" pitchFamily="34" charset="0"/>
-                <a:ea typeface="Georgia" pitchFamily="34" charset="-122"/>
-                <a:cs typeface="Georgia" pitchFamily="34" charset="-120"/>
+                <a:latin typeface="Georgia"/>
               </a:rPr>
-              <a:t>Option 2. SnapPages</a:t>
+              <a:t>What Tina CMS looks like</a:t>
             </a:r>
-            <a:endParaRPr lang="en-US" sz="3200" dirty="0"/>
-          </a:p>
-        </p:txBody>
-      </p:sp>
-      <p:sp>
-        <p:nvSpPr>
-          <p:cNvPr id="3" name="Text 1"/>
-          <p:cNvSpPr/>
-          <p:nvPr/>
-        </p:nvSpPr>
-        <p:spPr>
-          <a:xfrm>
-            <a:off x="502920" y="868680"/>
-            <a:ext cx="11155680" cy="411480"/>
+          </a:p>
+        </p:txBody>
+      </p:sp>
+      <p:sp>
+        <p:nvSpPr>
+          <p:cNvPr id="3" name="TextBox 2"/>
+          <p:cNvSpPr txBox="1"/>
+          <p:nvPr/>
+        </p:nvSpPr>
+        <p:spPr>
+          <a:xfrm>
+            <a:off x="502920" y="658368"/>
+            <a:ext cx="11155680" cy="329184"/>
           </a:xfrm>
           <a:prstGeom prst="rect">
             <a:avLst/>
           </a:prstGeom>
           <a:noFill/>
-          <a:ln/>
-        </p:spPr>
-        <p:txBody>
-          <a:bodyPr wrap="square" lIns="0" tIns="0" rIns="0" bIns="0" rtlCol="0" anchor="ctr"/>
-          <a:lstStyle/>
-          <a:p>
-            <a:pPr indent="0" marL="0">
-              <a:buNone/>
-            </a:pPr>
+        </p:spPr>
+        <p:txBody>
+          <a:bodyPr wrap="none">
+            <a:spAutoFit/>
+          </a:bodyPr>
+          <a:lstStyle/>
+          <a:p>
             <a:r>
-              <a:rPr lang="en-US" sz="1600" dirty="0">
+              <a:rPr sz="1500">
                 <a:solidFill>
                   <a:srgbClr val="1E2A26"/>
                 </a:solidFill>
-                <a:latin typeface="Calibri" pitchFamily="34" charset="0"/>
-                <a:ea typeface="Calibri" pitchFamily="34" charset="-122"/>
-                <a:cs typeface="Calibri" pitchFamily="34" charset="-120"/>
+                <a:latin typeface="Calibri"/>
               </a:rPr>
-              <a:t>This is Subsplash’s own website builder. A practice site is already started. A lot of the writing on it is still filler.</a:t>
+              <a:t>The real homepage is on the right. The boxes on the left are the words. Click the big headline, type, and the page changes.</a:t>
             </a:r>
-            <a:endParaRPr lang="en-US" sz="1600" dirty="0"/>
-          </a:p>
-        </p:txBody>
-      </p:sp>
-      <p:sp>
-        <p:nvSpPr>
-          <p:cNvPr id="4" name="Shape 2"/>
-          <p:cNvSpPr/>
-          <p:nvPr/>
-        </p:nvSpPr>
-        <p:spPr>
-          <a:xfrm>
-            <a:off x="502920" y="1417320"/>
-            <a:ext cx="11155680" cy="841248"/>
-          </a:xfrm>
-          <a:prstGeom prst="rect">
-            <a:avLst/>
-          </a:prstGeom>
-          <a:solidFill>
-            <a:srgbClr val="FFFFFF"/>
-          </a:solidFill>
-          <a:ln/>
-        </p:spPr>
-      </p:sp>
-      <p:sp>
-        <p:nvSpPr>
-          <p:cNvPr id="5" name="Text 3"/>
-          <p:cNvSpPr/>
-          <p:nvPr/>
-        </p:nvSpPr>
-        <p:spPr>
-          <a:xfrm>
-            <a:off x="731520" y="1527048"/>
-            <a:ext cx="3017520" cy="621792"/>
+          </a:p>
+        </p:txBody>
+      </p:sp>
+      <p:pic>
+        <p:nvPicPr>
+          <p:cNvPr id="4" name="Picture 3" descr="tina-editor-home.png"/>
+          <p:cNvPicPr>
+            <a:picLocks noChangeAspect="1"/>
+          </p:cNvPicPr>
+          <p:nvPr/>
+        </p:nvPicPr>
+        <p:blipFill>
+          <a:blip r:embed="rId2"/>
+          <a:stretch>
+            <a:fillRect/>
+          </a:stretch>
+        </p:blipFill>
+        <p:spPr>
+          <a:xfrm>
+            <a:off x="2036064" y="1051560"/>
+            <a:ext cx="8119872" cy="5074920"/>
+          </a:xfrm>
+          <a:prstGeom prst="rect">
+            <a:avLst/>
+          </a:prstGeom>
+        </p:spPr>
+      </p:pic>
+      <p:sp>
+        <p:nvSpPr>
+          <p:cNvPr id="5" name="TextBox 4"/>
+          <p:cNvSpPr txBox="1"/>
+          <p:nvPr/>
+        </p:nvSpPr>
+        <p:spPr>
+          <a:xfrm>
+            <a:off x="502920" y="6510528"/>
+            <a:ext cx="9601200" cy="219456"/>
           </a:xfrm>
           <a:prstGeom prst="rect">
             <a:avLst/>
           </a:prstGeom>
           <a:noFill/>
-          <a:ln/>
-        </p:spPr>
-        <p:txBody>
-          <a:bodyPr wrap="square" lIns="0" tIns="0" rIns="0" bIns="0" rtlCol="0" anchor="ctr"/>
-          <a:lstStyle/>
-          <a:p>
-            <a:pPr indent="0" marL="0">
-              <a:buNone/>
-            </a:pPr>
+        </p:spPr>
+        <p:txBody>
+          <a:bodyPr wrap="none">
+            <a:spAutoFit/>
+          </a:bodyPr>
+          <a:lstStyle/>
+          <a:p>
             <a:r>
-              <a:rPr lang="en-US" sz="1600" dirty="0">
-                <a:solidFill>
-                  <a:srgbClr val="1C3A32"/>
-                </a:solidFill>
-                <a:latin typeface="Georgia" pitchFamily="34" charset="0"/>
-                <a:ea typeface="Georgia" pitchFamily="34" charset="-122"/>
-                <a:cs typeface="Georgia" pitchFamily="34" charset="-120"/>
-              </a:rPr>
-              <a:t>What the office does</a:t>
-            </a:r>
-            <a:endParaRPr lang="en-US" sz="1600" dirty="0"/>
-          </a:p>
-        </p:txBody>
-      </p:sp>
-      <p:sp>
-        <p:nvSpPr>
-          <p:cNvPr id="6" name="Text 4"/>
-          <p:cNvSpPr/>
-          <p:nvPr/>
-        </p:nvSpPr>
-        <p:spPr>
-          <a:xfrm>
-            <a:off x="3840480" y="1527048"/>
-            <a:ext cx="7498080" cy="621792"/>
-          </a:xfrm>
-          <a:prstGeom prst="rect">
-            <a:avLst/>
-          </a:prstGeom>
-          <a:noFill/>
-          <a:ln/>
-        </p:spPr>
-        <p:txBody>
-          <a:bodyPr wrap="square" lIns="0" tIns="0" rIns="0" bIns="0" rtlCol="0" anchor="ctr"/>
-          <a:lstStyle/>
-          <a:p>
-            <a:pPr indent="0" marL="0">
-              <a:buNone/>
-            </a:pPr>
-            <a:r>
-              <a:rPr lang="en-US" sz="1500" dirty="0">
-                <a:solidFill>
-                  <a:srgbClr val="1E2A26"/>
-                </a:solidFill>
-                <a:latin typeface="Calibri" pitchFamily="34" charset="0"/>
-                <a:ea typeface="Calibri" pitchFamily="34" charset="-122"/>
-                <a:cs typeface="Calibri" pitchFamily="34" charset="-120"/>
-              </a:rPr>
-              <a:t>They log into Subsplash and change the words on the page. One login covers the website, the app, and giving.</a:t>
-            </a:r>
-            <a:endParaRPr lang="en-US" sz="1500" dirty="0"/>
-          </a:p>
-        </p:txBody>
-      </p:sp>
-      <p:sp>
-        <p:nvSpPr>
-          <p:cNvPr id="7" name="Shape 5"/>
-          <p:cNvSpPr/>
-          <p:nvPr/>
-        </p:nvSpPr>
-        <p:spPr>
-          <a:xfrm>
-            <a:off x="502920" y="2350008"/>
-            <a:ext cx="11155680" cy="841248"/>
-          </a:xfrm>
-          <a:prstGeom prst="rect">
-            <a:avLst/>
-          </a:prstGeom>
-          <a:solidFill>
-            <a:srgbClr val="FFFFFF"/>
-          </a:solidFill>
-          <a:ln/>
-        </p:spPr>
-      </p:sp>
-      <p:sp>
-        <p:nvSpPr>
-          <p:cNvPr id="8" name="Text 6"/>
-          <p:cNvSpPr/>
-          <p:nvPr/>
-        </p:nvSpPr>
-        <p:spPr>
-          <a:xfrm>
-            <a:off x="731520" y="2459736"/>
-            <a:ext cx="3017520" cy="621792"/>
-          </a:xfrm>
-          <a:prstGeom prst="rect">
-            <a:avLst/>
-          </a:prstGeom>
-          <a:noFill/>
-          <a:ln/>
-        </p:spPr>
-        <p:txBody>
-          <a:bodyPr wrap="square" lIns="0" tIns="0" rIns="0" bIns="0" rtlCol="0" anchor="ctr"/>
-          <a:lstStyle/>
-          <a:p>
-            <a:pPr indent="0" marL="0">
-              <a:buNone/>
-            </a:pPr>
-            <a:r>
-              <a:rPr lang="en-US" sz="1600" dirty="0">
-                <a:solidFill>
-                  <a:srgbClr val="1C3A32"/>
-                </a:solidFill>
-                <a:latin typeface="Georgia" pitchFamily="34" charset="0"/>
-                <a:ea typeface="Georgia" pitchFamily="34" charset="-122"/>
-                <a:cs typeface="Georgia" pitchFamily="34" charset="-120"/>
-              </a:rPr>
-              <a:t>What they can change</a:t>
-            </a:r>
-            <a:endParaRPr lang="en-US" sz="1600" dirty="0"/>
-          </a:p>
-        </p:txBody>
-      </p:sp>
-      <p:sp>
-        <p:nvSpPr>
-          <p:cNvPr id="9" name="Text 7"/>
-          <p:cNvSpPr/>
-          <p:nvPr/>
-        </p:nvSpPr>
-        <p:spPr>
-          <a:xfrm>
-            <a:off x="3840480" y="2459736"/>
-            <a:ext cx="7498080" cy="621792"/>
-          </a:xfrm>
-          <a:prstGeom prst="rect">
-            <a:avLst/>
-          </a:prstGeom>
-          <a:noFill/>
-          <a:ln/>
-        </p:spPr>
-        <p:txBody>
-          <a:bodyPr wrap="square" lIns="0" tIns="0" rIns="0" bIns="0" rtlCol="0" anchor="ctr"/>
-          <a:lstStyle/>
-          <a:p>
-            <a:pPr indent="0" marL="0">
-              <a:buNone/>
-            </a:pPr>
-            <a:r>
-              <a:rPr lang="en-US" sz="1500" dirty="0">
-                <a:solidFill>
-                  <a:srgbClr val="1E2A26"/>
-                </a:solidFill>
-                <a:latin typeface="Calibri" pitchFamily="34" charset="0"/>
-                <a:ea typeface="Calibri" pitchFamily="34" charset="-122"/>
-                <a:cs typeface="Calibri" pitchFamily="34" charset="-120"/>
-              </a:rPr>
-              <a:t>Words, photos, and sections, inside Subsplash’s design.</a:t>
-            </a:r>
-            <a:endParaRPr lang="en-US" sz="1500" dirty="0"/>
-          </a:p>
-        </p:txBody>
-      </p:sp>
-      <p:sp>
-        <p:nvSpPr>
-          <p:cNvPr id="10" name="Shape 8"/>
-          <p:cNvSpPr/>
-          <p:nvPr/>
-        </p:nvSpPr>
-        <p:spPr>
-          <a:xfrm>
-            <a:off x="502920" y="3282696"/>
-            <a:ext cx="11155680" cy="841248"/>
-          </a:xfrm>
-          <a:prstGeom prst="rect">
-            <a:avLst/>
-          </a:prstGeom>
-          <a:solidFill>
-            <a:srgbClr val="FFFFFF"/>
-          </a:solidFill>
-          <a:ln/>
-        </p:spPr>
-      </p:sp>
-      <p:sp>
-        <p:nvSpPr>
-          <p:cNvPr id="11" name="Text 9"/>
-          <p:cNvSpPr/>
-          <p:nvPr/>
-        </p:nvSpPr>
-        <p:spPr>
-          <a:xfrm>
-            <a:off x="731520" y="3392424"/>
-            <a:ext cx="3017520" cy="621792"/>
-          </a:xfrm>
-          <a:prstGeom prst="rect">
-            <a:avLst/>
-          </a:prstGeom>
-          <a:noFill/>
-          <a:ln/>
-        </p:spPr>
-        <p:txBody>
-          <a:bodyPr wrap="square" lIns="0" tIns="0" rIns="0" bIns="0" rtlCol="0" anchor="ctr"/>
-          <a:lstStyle/>
-          <a:p>
-            <a:pPr indent="0" marL="0">
-              <a:buNone/>
-            </a:pPr>
-            <a:r>
-              <a:rPr lang="en-US" sz="1600" dirty="0">
-                <a:solidFill>
-                  <a:srgbClr val="1C3A32"/>
-                </a:solidFill>
-                <a:latin typeface="Georgia" pitchFamily="34" charset="0"/>
-                <a:ea typeface="Georgia" pitchFamily="34" charset="-122"/>
-                <a:cs typeface="Georgia" pitchFamily="34" charset="-120"/>
-              </a:rPr>
-              <a:t>What we would rebuild</a:t>
-            </a:r>
-            <a:endParaRPr lang="en-US" sz="1600" dirty="0"/>
-          </a:p>
-        </p:txBody>
-      </p:sp>
-      <p:sp>
-        <p:nvSpPr>
-          <p:cNvPr id="12" name="Text 10"/>
-          <p:cNvSpPr/>
-          <p:nvPr/>
-        </p:nvSpPr>
-        <p:spPr>
-          <a:xfrm>
-            <a:off x="3840480" y="3392424"/>
-            <a:ext cx="7498080" cy="621792"/>
-          </a:xfrm>
-          <a:prstGeom prst="rect">
-            <a:avLst/>
-          </a:prstGeom>
-          <a:noFill/>
-          <a:ln/>
-        </p:spPr>
-        <p:txBody>
-          <a:bodyPr wrap="square" lIns="0" tIns="0" rIns="0" bIns="0" rtlCol="0" anchor="ctr"/>
-          <a:lstStyle/>
-          <a:p>
-            <a:pPr indent="0" marL="0">
-              <a:buNone/>
-            </a:pPr>
-            <a:r>
-              <a:rPr lang="en-US" sz="1500" dirty="0">
-                <a:solidFill>
-                  <a:srgbClr val="1E2A26"/>
-                </a:solidFill>
-                <a:latin typeface="Calibri" pitchFamily="34" charset="0"/>
-                <a:ea typeface="Calibri" pitchFamily="34" charset="-122"/>
-                <a:cs typeface="Calibri" pitchFamily="34" charset="-120"/>
-              </a:rPr>
-              <a:t>Home, Visit, the ministry pages, the sermons page, and the giving page. We cannot move the new site over. We build it again.</a:t>
-            </a:r>
-            <a:endParaRPr lang="en-US" sz="1500" dirty="0"/>
-          </a:p>
-        </p:txBody>
-      </p:sp>
-      <p:sp>
-        <p:nvSpPr>
-          <p:cNvPr id="13" name="Shape 11"/>
-          <p:cNvSpPr/>
-          <p:nvPr/>
-        </p:nvSpPr>
-        <p:spPr>
-          <a:xfrm>
-            <a:off x="502920" y="4215384"/>
-            <a:ext cx="11155680" cy="841248"/>
-          </a:xfrm>
-          <a:prstGeom prst="rect">
-            <a:avLst/>
-          </a:prstGeom>
-          <a:solidFill>
-            <a:srgbClr val="FFFFFF"/>
-          </a:solidFill>
-          <a:ln/>
-        </p:spPr>
-      </p:sp>
-      <p:sp>
-        <p:nvSpPr>
-          <p:cNvPr id="14" name="Text 12"/>
-          <p:cNvSpPr/>
-          <p:nvPr/>
-        </p:nvSpPr>
-        <p:spPr>
-          <a:xfrm>
-            <a:off x="731520" y="4325112"/>
-            <a:ext cx="3017520" cy="621792"/>
-          </a:xfrm>
-          <a:prstGeom prst="rect">
-            <a:avLst/>
-          </a:prstGeom>
-          <a:noFill/>
-          <a:ln/>
-        </p:spPr>
-        <p:txBody>
-          <a:bodyPr wrap="square" lIns="0" tIns="0" rIns="0" bIns="0" rtlCol="0" anchor="ctr"/>
-          <a:lstStyle/>
-          <a:p>
-            <a:pPr indent="0" marL="0">
-              <a:buNone/>
-            </a:pPr>
-            <a:r>
-              <a:rPr lang="en-US" sz="1600" dirty="0">
-                <a:solidFill>
-                  <a:srgbClr val="1C3A32"/>
-                </a:solidFill>
-                <a:latin typeface="Georgia" pitchFamily="34" charset="0"/>
-                <a:ea typeface="Georgia" pitchFamily="34" charset="-122"/>
-                <a:cs typeface="Georgia" pitchFamily="34" charset="-120"/>
-              </a:rPr>
-              <a:t>What we would give up</a:t>
-            </a:r>
-            <a:endParaRPr lang="en-US" sz="1600" dirty="0"/>
-          </a:p>
-        </p:txBody>
-      </p:sp>
-      <p:sp>
-        <p:nvSpPr>
-          <p:cNvPr id="15" name="Text 13"/>
-          <p:cNvSpPr/>
-          <p:nvPr/>
-        </p:nvSpPr>
-        <p:spPr>
-          <a:xfrm>
-            <a:off x="3840480" y="4325112"/>
-            <a:ext cx="7498080" cy="621792"/>
-          </a:xfrm>
-          <a:prstGeom prst="rect">
-            <a:avLst/>
-          </a:prstGeom>
-          <a:noFill/>
-          <a:ln/>
-        </p:spPr>
-        <p:txBody>
-          <a:bodyPr wrap="square" lIns="0" tIns="0" rIns="0" bIns="0" rtlCol="0" anchor="ctr"/>
-          <a:lstStyle/>
-          <a:p>
-            <a:pPr indent="0" marL="0">
-              <a:buNone/>
-            </a:pPr>
-            <a:r>
-              <a:rPr lang="en-US" sz="1500" dirty="0">
-                <a:solidFill>
-                  <a:srgbClr val="1E2A26"/>
-                </a:solidFill>
-                <a:latin typeface="Calibri" pitchFamily="34" charset="0"/>
-                <a:ea typeface="Calibri" pitchFamily="34" charset="-122"/>
-                <a:cs typeface="Calibri" pitchFamily="34" charset="-120"/>
-              </a:rPr>
-              <a:t>The exact look of the new site. Subsplash sets the layout. We can change colors and words. We cannot freely redesign the page.</a:t>
-            </a:r>
-            <a:endParaRPr lang="en-US" sz="1500" dirty="0"/>
-          </a:p>
-        </p:txBody>
-      </p:sp>
-      <p:sp>
-        <p:nvSpPr>
-          <p:cNvPr id="16" name="Shape 14"/>
-          <p:cNvSpPr/>
-          <p:nvPr/>
-        </p:nvSpPr>
-        <p:spPr>
-          <a:xfrm>
-            <a:off x="502920" y="5148072"/>
-            <a:ext cx="11155680" cy="841248"/>
-          </a:xfrm>
-          <a:prstGeom prst="rect">
-            <a:avLst/>
-          </a:prstGeom>
-          <a:solidFill>
-            <a:srgbClr val="FFFFFF"/>
-          </a:solidFill>
-          <a:ln/>
-        </p:spPr>
-      </p:sp>
-      <p:sp>
-        <p:nvSpPr>
-          <p:cNvPr id="17" name="Text 15"/>
-          <p:cNvSpPr/>
-          <p:nvPr/>
-        </p:nvSpPr>
-        <p:spPr>
-          <a:xfrm>
-            <a:off x="731520" y="5257800"/>
-            <a:ext cx="3017520" cy="621792"/>
-          </a:xfrm>
-          <a:prstGeom prst="rect">
-            <a:avLst/>
-          </a:prstGeom>
-          <a:noFill/>
-          <a:ln/>
-        </p:spPr>
-        <p:txBody>
-          <a:bodyPr wrap="square" lIns="0" tIns="0" rIns="0" bIns="0" rtlCol="0" anchor="ctr"/>
-          <a:lstStyle/>
-          <a:p>
-            <a:pPr indent="0" marL="0">
-              <a:buNone/>
-            </a:pPr>
-            <a:r>
-              <a:rPr lang="en-US" sz="1600" dirty="0">
-                <a:solidFill>
-                  <a:srgbClr val="1C3A32"/>
-                </a:solidFill>
-                <a:latin typeface="Georgia" pitchFamily="34" charset="0"/>
-                <a:ea typeface="Georgia" pitchFamily="34" charset="-122"/>
-                <a:cs typeface="Georgia" pitchFamily="34" charset="-120"/>
-              </a:rPr>
-              <a:t>The tradeoff</a:t>
-            </a:r>
-            <a:endParaRPr lang="en-US" sz="1600" dirty="0"/>
-          </a:p>
-        </p:txBody>
-      </p:sp>
-      <p:sp>
-        <p:nvSpPr>
-          <p:cNvPr id="18" name="Text 16"/>
-          <p:cNvSpPr/>
-          <p:nvPr/>
-        </p:nvSpPr>
-        <p:spPr>
-          <a:xfrm>
-            <a:off x="3840480" y="5257800"/>
-            <a:ext cx="7498080" cy="621792"/>
-          </a:xfrm>
-          <a:prstGeom prst="rect">
-            <a:avLst/>
-          </a:prstGeom>
-          <a:noFill/>
-          <a:ln/>
-        </p:spPr>
-        <p:txBody>
-          <a:bodyPr wrap="square" lIns="0" tIns="0" rIns="0" bIns="0" rtlCol="0" anchor="ctr"/>
-          <a:lstStyle/>
-          <a:p>
-            <a:pPr indent="0" marL="0">
-              <a:buNone/>
-            </a:pPr>
-            <a:r>
-              <a:rPr lang="en-US" sz="1500" dirty="0">
-                <a:solidFill>
-                  <a:srgbClr val="1E2A26"/>
-                </a:solidFill>
-                <a:latin typeface="Calibri" pitchFamily="34" charset="0"/>
-                <a:ea typeface="Calibri" pitchFamily="34" charset="-122"/>
-                <a:cs typeface="Calibri" pitchFamily="34" charset="-120"/>
-              </a:rPr>
-              <a:t>Easier if the office wants one church login. The finished site will look like a Subsplash site, not the one already designed.</a:t>
-            </a:r>
-            <a:endParaRPr lang="en-US" sz="1500" dirty="0"/>
-          </a:p>
-        </p:txBody>
-      </p:sp>
-      <p:sp>
-        <p:nvSpPr>
-          <p:cNvPr id="19" name="Text 17"/>
-          <p:cNvSpPr/>
-          <p:nvPr/>
-        </p:nvSpPr>
-        <p:spPr>
-          <a:xfrm>
-            <a:off x="502920" y="6510528"/>
-            <a:ext cx="9326880" cy="219456"/>
-          </a:xfrm>
-          <a:prstGeom prst="rect">
-            <a:avLst/>
-          </a:prstGeom>
-          <a:noFill/>
-          <a:ln/>
-        </p:spPr>
-        <p:txBody>
-          <a:bodyPr wrap="square" lIns="0" tIns="0" rIns="0" bIns="0" rtlCol="0" anchor="ctr"/>
-          <a:lstStyle/>
-          <a:p>
-            <a:pPr indent="0" marL="0">
-              <a:buNone/>
-            </a:pPr>
-            <a:r>
-              <a:rPr lang="en-US" sz="1100" dirty="0">
+              <a:rPr sz="1100">
                 <a:solidFill>
                   <a:srgbClr val="5C6B64"/>
                 </a:solidFill>
-                <a:latin typeface="Calibri" pitchFamily="34" charset="0"/>
-                <a:ea typeface="Calibri" pitchFamily="34" charset="-122"/>
-                <a:cs typeface="Calibri" pitchFamily="34" charset="-120"/>
+                <a:latin typeface="Calibri"/>
               </a:rPr>
               <a:t>For Pastor Dave and Pastor Shawn  ·  28 September 2026</a:t>
             </a:r>
-            <a:endParaRPr lang="en-US" sz="1100" dirty="0"/>
-          </a:p>
-        </p:txBody>
-      </p:sp>
-      <p:sp>
-        <p:nvSpPr>
-          <p:cNvPr id="20" name="Text 18"/>
-          <p:cNvSpPr/>
-          <p:nvPr/>
-        </p:nvSpPr>
-        <p:spPr>
-          <a:xfrm>
-            <a:off x="11155680" y="6510528"/>
-            <a:ext cx="502920" cy="219456"/>
-          </a:xfrm>
-          <a:prstGeom prst="rect">
-            <a:avLst/>
-          </a:prstGeom>
-          <a:noFill/>
-          <a:ln/>
-        </p:spPr>
-        <p:txBody>
-          <a:bodyPr wrap="square" lIns="0" tIns="0" rIns="0" bIns="0" rtlCol="0" anchor="ctr"/>
-          <a:lstStyle/>
-          <a:p>
-            <a:pPr algn="r" indent="0" marL="0">
-              <a:buNone/>
-            </a:pPr>
-            <a:r>
-              <a:rPr lang="en-US" sz="1100" dirty="0">
-                <a:solidFill>
-                  <a:srgbClr val="5C6B64"/>
-                </a:solidFill>
-                <a:latin typeface="Calibri" pitchFamily="34" charset="0"/>
-                <a:ea typeface="Calibri" pitchFamily="34" charset="-122"/>
-                <a:cs typeface="Calibri" pitchFamily="34" charset="-120"/>
-              </a:rPr>
-              <a:t>5</a:t>
-            </a:r>
-            <a:endParaRPr lang="en-US" sz="1100" dirty="0"/>
           </a:p>
         </p:txBody>
       </p:sp>
@@ -4363,12 +4249,13 @@
 
 <file path=ppt/slides/slide6.xml><?xml version="1.0" encoding="utf-8"?>
 <p:sld xmlns:a="http://schemas.openxmlformats.org/drawingml/2006/main" xmlns:r="http://schemas.openxmlformats.org/officeDocument/2006/relationships" xmlns:p="http://schemas.openxmlformats.org/presentationml/2006/main">
-  <p:cSld name="Slide 6">
+  <p:cSld>
     <p:bg>
       <p:bgPr>
         <a:solidFill>
           <a:srgbClr val="F6F1E7"/>
         </a:solidFill>
+        <a:effectLst/>
       </p:bgPr>
     </p:bg>
     <p:spTree>
@@ -4387,6 +4274,879 @@
       </p:grpSpPr>
       <p:sp>
         <p:nvSpPr>
+          <p:cNvPr id="2" name="TextBox 1"/>
+          <p:cNvSpPr txBox="1"/>
+          <p:nvPr/>
+        </p:nvSpPr>
+        <p:spPr>
+          <a:xfrm>
+            <a:off x="502920" y="256032"/>
+            <a:ext cx="11155680" cy="384048"/>
+          </a:xfrm>
+          <a:prstGeom prst="rect">
+            <a:avLst/>
+          </a:prstGeom>
+          <a:noFill/>
+        </p:spPr>
+        <p:txBody>
+          <a:bodyPr wrap="none">
+            <a:spAutoFit/>
+          </a:bodyPr>
+          <a:lstStyle/>
+          <a:p>
+            <a:r>
+              <a:rPr sz="2800" b="0">
+                <a:solidFill>
+                  <a:srgbClr val="1C3A32"/>
+                </a:solidFill>
+                <a:latin typeface="Georgia"/>
+              </a:rPr>
+              <a:t>The words they click</a:t>
+            </a:r>
+          </a:p>
+        </p:txBody>
+      </p:sp>
+      <p:sp>
+        <p:nvSpPr>
+          <p:cNvPr id="3" name="TextBox 2"/>
+          <p:cNvSpPr txBox="1"/>
+          <p:nvPr/>
+        </p:nvSpPr>
+        <p:spPr>
+          <a:xfrm>
+            <a:off x="502920" y="658368"/>
+            <a:ext cx="11155680" cy="329184"/>
+          </a:xfrm>
+          <a:prstGeom prst="rect">
+            <a:avLst/>
+          </a:prstGeom>
+          <a:noFill/>
+        </p:spPr>
+        <p:txBody>
+          <a:bodyPr wrap="none">
+            <a:spAutoFit/>
+          </a:bodyPr>
+          <a:lstStyle/>
+          <a:p>
+            <a:r>
+              <a:rPr sz="1500">
+                <a:solidFill>
+                  <a:srgbClr val="1E2A26"/>
+                </a:solidFill>
+                <a:latin typeface="Calibri"/>
+              </a:rPr>
+              <a:t>Headline, vision, phone, and email are ordinary boxes. The dotted line on the picture is the headline they can also click.</a:t>
+            </a:r>
+          </a:p>
+        </p:txBody>
+      </p:sp>
+      <p:pic>
+        <p:nvPicPr>
+          <p:cNvPr id="4" name="Picture 3" descr="tina-editor-close.png"/>
+          <p:cNvPicPr>
+            <a:picLocks noChangeAspect="1"/>
+          </p:cNvPicPr>
+          <p:nvPr/>
+        </p:nvPicPr>
+        <p:blipFill>
+          <a:blip r:embed="rId2"/>
+          <a:stretch>
+            <a:fillRect/>
+          </a:stretch>
+        </p:blipFill>
+        <p:spPr>
+          <a:xfrm>
+            <a:off x="1510229" y="1051560"/>
+            <a:ext cx="9171542" cy="5074920"/>
+          </a:xfrm>
+          <a:prstGeom prst="rect">
+            <a:avLst/>
+          </a:prstGeom>
+        </p:spPr>
+      </p:pic>
+      <p:sp>
+        <p:nvSpPr>
+          <p:cNvPr id="5" name="TextBox 4"/>
+          <p:cNvSpPr txBox="1"/>
+          <p:nvPr/>
+        </p:nvSpPr>
+        <p:spPr>
+          <a:xfrm>
+            <a:off x="502920" y="6510528"/>
+            <a:ext cx="9601200" cy="219456"/>
+          </a:xfrm>
+          <a:prstGeom prst="rect">
+            <a:avLst/>
+          </a:prstGeom>
+          <a:noFill/>
+        </p:spPr>
+        <p:txBody>
+          <a:bodyPr wrap="none">
+            <a:spAutoFit/>
+          </a:bodyPr>
+          <a:lstStyle/>
+          <a:p>
+            <a:r>
+              <a:rPr sz="1100">
+                <a:solidFill>
+                  <a:srgbClr val="5C6B64"/>
+                </a:solidFill>
+                <a:latin typeface="Calibri"/>
+              </a:rPr>
+              <a:t>For Pastor Dave and Pastor Shawn  ·  28 September 2026</a:t>
+            </a:r>
+          </a:p>
+        </p:txBody>
+      </p:sp>
+    </p:spTree>
+  </p:cSld>
+  <p:clrMapOvr>
+    <a:masterClrMapping/>
+  </p:clrMapOvr>
+</p:sld>
+</file>
+
+<file path=ppt/slides/slide7.xml><?xml version="1.0" encoding="utf-8"?>
+<p:sld xmlns:a="http://schemas.openxmlformats.org/drawingml/2006/main" xmlns:r="http://schemas.openxmlformats.org/officeDocument/2006/relationships" xmlns:p="http://schemas.openxmlformats.org/presentationml/2006/main">
+  <p:cSld name="Slide 5">
+    <p:bg>
+      <p:bgPr>
+        <a:solidFill>
+          <a:srgbClr val="F6F1E7"/>
+        </a:solidFill>
+        <a:effectLst/>
+      </p:bgPr>
+    </p:bg>
+    <p:spTree>
+      <p:nvGrpSpPr>
+        <p:cNvPr id="1" name=""/>
+        <p:cNvGrpSpPr/>
+        <p:nvPr/>
+      </p:nvGrpSpPr>
+      <p:grpSpPr>
+        <a:xfrm>
+          <a:off x="0" y="0"/>
+          <a:ext cx="0" cy="0"/>
+          <a:chOff x="0" y="0"/>
+          <a:chExt cx="0" cy="0"/>
+        </a:xfrm>
+      </p:grpSpPr>
+      <p:sp>
+        <p:nvSpPr>
+          <p:cNvPr id="2" name="Text 0"/>
+          <p:cNvSpPr/>
+          <p:nvPr/>
+        </p:nvSpPr>
+        <p:spPr>
+          <a:xfrm>
+            <a:off x="502920" y="320040"/>
+            <a:ext cx="10972800" cy="438912"/>
+          </a:xfrm>
+          <a:prstGeom prst="rect">
+            <a:avLst/>
+          </a:prstGeom>
+          <a:noFill/>
+          <a:ln/>
+        </p:spPr>
+        <p:txBody>
+          <a:bodyPr wrap="square" lIns="0" tIns="0" rIns="0" bIns="0" rtlCol="0" anchor="ctr"/>
+          <a:lstStyle/>
+          <a:p>
+            <a:pPr marL="0" indent="0">
+              <a:buNone/>
+            </a:pPr>
+            <a:r>
+              <a:rPr lang="en-US" sz="3200" dirty="0">
+                <a:solidFill>
+                  <a:srgbClr val="1C3A32"/>
+                </a:solidFill>
+                <a:latin typeface="Georgia" pitchFamily="34" charset="0"/>
+                <a:ea typeface="Georgia" pitchFamily="34" charset="-122"/>
+                <a:cs typeface="Georgia" pitchFamily="34" charset="-120"/>
+              </a:rPr>
+              <a:t>Option 2. SnapPages</a:t>
+            </a:r>
+            <a:endParaRPr lang="en-US" sz="3200" dirty="0"/>
+          </a:p>
+        </p:txBody>
+      </p:sp>
+      <p:sp>
+        <p:nvSpPr>
+          <p:cNvPr id="3" name="Text 1"/>
+          <p:cNvSpPr/>
+          <p:nvPr/>
+        </p:nvSpPr>
+        <p:spPr>
+          <a:xfrm>
+            <a:off x="502920" y="868680"/>
+            <a:ext cx="11155680" cy="411480"/>
+          </a:xfrm>
+          <a:prstGeom prst="rect">
+            <a:avLst/>
+          </a:prstGeom>
+          <a:noFill/>
+          <a:ln/>
+        </p:spPr>
+        <p:txBody>
+          <a:bodyPr wrap="square" lIns="0" tIns="0" rIns="0" bIns="0" rtlCol="0" anchor="ctr"/>
+          <a:lstStyle/>
+          <a:p>
+            <a:pPr marL="0" indent="0">
+              <a:buNone/>
+            </a:pPr>
+            <a:r>
+              <a:rPr lang="en-US" sz="1600" dirty="0">
+                <a:solidFill>
+                  <a:srgbClr val="1E2A26"/>
+                </a:solidFill>
+                <a:latin typeface="Calibri" pitchFamily="34" charset="0"/>
+                <a:ea typeface="Calibri" pitchFamily="34" charset="-122"/>
+                <a:cs typeface="Calibri" pitchFamily="34" charset="-120"/>
+              </a:rPr>
+              <a:t>This is Subsplash’s own website builder. A practice site is already started. A lot of the writing on it is still filler.</a:t>
+            </a:r>
+            <a:endParaRPr lang="en-US" sz="1600" dirty="0"/>
+          </a:p>
+        </p:txBody>
+      </p:sp>
+      <p:sp>
+        <p:nvSpPr>
+          <p:cNvPr id="4" name="Shape 2"/>
+          <p:cNvSpPr/>
+          <p:nvPr/>
+        </p:nvSpPr>
+        <p:spPr>
+          <a:xfrm>
+            <a:off x="502920" y="1417320"/>
+            <a:ext cx="11155680" cy="841248"/>
+          </a:xfrm>
+          <a:prstGeom prst="rect">
+            <a:avLst/>
+          </a:prstGeom>
+          <a:solidFill>
+            <a:srgbClr val="FFFFFF"/>
+          </a:solidFill>
+          <a:ln/>
+        </p:spPr>
+        <p:txBody>
+          <a:bodyPr/>
+          <a:lstStyle/>
+          <a:p>
+            <a:endParaRPr lang="en-US"/>
+          </a:p>
+        </p:txBody>
+      </p:sp>
+      <p:sp>
+        <p:nvSpPr>
+          <p:cNvPr id="5" name="Text 3"/>
+          <p:cNvSpPr/>
+          <p:nvPr/>
+        </p:nvSpPr>
+        <p:spPr>
+          <a:xfrm>
+            <a:off x="731520" y="1527048"/>
+            <a:ext cx="3017520" cy="621792"/>
+          </a:xfrm>
+          <a:prstGeom prst="rect">
+            <a:avLst/>
+          </a:prstGeom>
+          <a:noFill/>
+          <a:ln/>
+        </p:spPr>
+        <p:txBody>
+          <a:bodyPr wrap="square" lIns="0" tIns="0" rIns="0" bIns="0" rtlCol="0" anchor="ctr"/>
+          <a:lstStyle/>
+          <a:p>
+            <a:pPr marL="0" indent="0">
+              <a:buNone/>
+            </a:pPr>
+            <a:r>
+              <a:rPr lang="en-US" sz="1600" dirty="0">
+                <a:solidFill>
+                  <a:srgbClr val="1C3A32"/>
+                </a:solidFill>
+                <a:latin typeface="Georgia" pitchFamily="34" charset="0"/>
+                <a:ea typeface="Georgia" pitchFamily="34" charset="-122"/>
+                <a:cs typeface="Georgia" pitchFamily="34" charset="-120"/>
+              </a:rPr>
+              <a:t>What the office does</a:t>
+            </a:r>
+            <a:endParaRPr lang="en-US" sz="1600" dirty="0"/>
+          </a:p>
+        </p:txBody>
+      </p:sp>
+      <p:sp>
+        <p:nvSpPr>
+          <p:cNvPr id="6" name="Text 4"/>
+          <p:cNvSpPr/>
+          <p:nvPr/>
+        </p:nvSpPr>
+        <p:spPr>
+          <a:xfrm>
+            <a:off x="3840480" y="1527048"/>
+            <a:ext cx="7498080" cy="621792"/>
+          </a:xfrm>
+          <a:prstGeom prst="rect">
+            <a:avLst/>
+          </a:prstGeom>
+          <a:noFill/>
+          <a:ln/>
+        </p:spPr>
+        <p:txBody>
+          <a:bodyPr wrap="square" lIns="0" tIns="0" rIns="0" bIns="0" rtlCol="0" anchor="ctr"/>
+          <a:lstStyle/>
+          <a:p>
+            <a:pPr marL="0" indent="0">
+              <a:buNone/>
+            </a:pPr>
+            <a:r>
+              <a:rPr lang="en-US" sz="1500" dirty="0">
+                <a:solidFill>
+                  <a:srgbClr val="1E2A26"/>
+                </a:solidFill>
+                <a:latin typeface="Calibri" pitchFamily="34" charset="0"/>
+                <a:ea typeface="Calibri" pitchFamily="34" charset="-122"/>
+                <a:cs typeface="Calibri" pitchFamily="34" charset="-120"/>
+              </a:rPr>
+              <a:t>They log into Subsplash and change the words on the page. One login covers the website, the app, and giving.</a:t>
+            </a:r>
+            <a:endParaRPr lang="en-US" sz="1500" dirty="0"/>
+          </a:p>
+        </p:txBody>
+      </p:sp>
+      <p:sp>
+        <p:nvSpPr>
+          <p:cNvPr id="7" name="Shape 5"/>
+          <p:cNvSpPr/>
+          <p:nvPr/>
+        </p:nvSpPr>
+        <p:spPr>
+          <a:xfrm>
+            <a:off x="502920" y="2350008"/>
+            <a:ext cx="11155680" cy="841248"/>
+          </a:xfrm>
+          <a:prstGeom prst="rect">
+            <a:avLst/>
+          </a:prstGeom>
+          <a:solidFill>
+            <a:srgbClr val="FFFFFF"/>
+          </a:solidFill>
+          <a:ln/>
+        </p:spPr>
+        <p:txBody>
+          <a:bodyPr/>
+          <a:lstStyle/>
+          <a:p>
+            <a:endParaRPr lang="en-US"/>
+          </a:p>
+        </p:txBody>
+      </p:sp>
+      <p:sp>
+        <p:nvSpPr>
+          <p:cNvPr id="8" name="Text 6"/>
+          <p:cNvSpPr/>
+          <p:nvPr/>
+        </p:nvSpPr>
+        <p:spPr>
+          <a:xfrm>
+            <a:off x="731520" y="2459736"/>
+            <a:ext cx="3017520" cy="621792"/>
+          </a:xfrm>
+          <a:prstGeom prst="rect">
+            <a:avLst/>
+          </a:prstGeom>
+          <a:noFill/>
+          <a:ln/>
+        </p:spPr>
+        <p:txBody>
+          <a:bodyPr wrap="square" lIns="0" tIns="0" rIns="0" bIns="0" rtlCol="0" anchor="ctr"/>
+          <a:lstStyle/>
+          <a:p>
+            <a:pPr marL="0" indent="0">
+              <a:buNone/>
+            </a:pPr>
+            <a:r>
+              <a:rPr lang="en-US" sz="1600" dirty="0">
+                <a:solidFill>
+                  <a:srgbClr val="1C3A32"/>
+                </a:solidFill>
+                <a:latin typeface="Georgia" pitchFamily="34" charset="0"/>
+                <a:ea typeface="Georgia" pitchFamily="34" charset="-122"/>
+                <a:cs typeface="Georgia" pitchFamily="34" charset="-120"/>
+              </a:rPr>
+              <a:t>What they can change</a:t>
+            </a:r>
+            <a:endParaRPr lang="en-US" sz="1600" dirty="0"/>
+          </a:p>
+        </p:txBody>
+      </p:sp>
+      <p:sp>
+        <p:nvSpPr>
+          <p:cNvPr id="9" name="Text 7"/>
+          <p:cNvSpPr/>
+          <p:nvPr/>
+        </p:nvSpPr>
+        <p:spPr>
+          <a:xfrm>
+            <a:off x="3840480" y="2459736"/>
+            <a:ext cx="7498080" cy="621792"/>
+          </a:xfrm>
+          <a:prstGeom prst="rect">
+            <a:avLst/>
+          </a:prstGeom>
+          <a:noFill/>
+          <a:ln/>
+        </p:spPr>
+        <p:txBody>
+          <a:bodyPr wrap="square" lIns="0" tIns="0" rIns="0" bIns="0" rtlCol="0" anchor="ctr"/>
+          <a:lstStyle/>
+          <a:p>
+            <a:pPr marL="0" indent="0">
+              <a:buNone/>
+            </a:pPr>
+            <a:r>
+              <a:rPr lang="en-US" sz="1500" dirty="0">
+                <a:solidFill>
+                  <a:srgbClr val="1E2A26"/>
+                </a:solidFill>
+                <a:latin typeface="Calibri" pitchFamily="34" charset="0"/>
+                <a:ea typeface="Calibri" pitchFamily="34" charset="-122"/>
+                <a:cs typeface="Calibri" pitchFamily="34" charset="-120"/>
+              </a:rPr>
+              <a:t>Words, photos, and sections, inside Subsplash’s design.</a:t>
+            </a:r>
+            <a:endParaRPr lang="en-US" sz="1500" dirty="0"/>
+          </a:p>
+        </p:txBody>
+      </p:sp>
+      <p:sp>
+        <p:nvSpPr>
+          <p:cNvPr id="10" name="Shape 8"/>
+          <p:cNvSpPr/>
+          <p:nvPr/>
+        </p:nvSpPr>
+        <p:spPr>
+          <a:xfrm>
+            <a:off x="502920" y="3282696"/>
+            <a:ext cx="11155680" cy="841248"/>
+          </a:xfrm>
+          <a:prstGeom prst="rect">
+            <a:avLst/>
+          </a:prstGeom>
+          <a:solidFill>
+            <a:srgbClr val="FFFFFF"/>
+          </a:solidFill>
+          <a:ln/>
+        </p:spPr>
+        <p:txBody>
+          <a:bodyPr/>
+          <a:lstStyle/>
+          <a:p>
+            <a:endParaRPr lang="en-US"/>
+          </a:p>
+        </p:txBody>
+      </p:sp>
+      <p:sp>
+        <p:nvSpPr>
+          <p:cNvPr id="11" name="Text 9"/>
+          <p:cNvSpPr/>
+          <p:nvPr/>
+        </p:nvSpPr>
+        <p:spPr>
+          <a:xfrm>
+            <a:off x="731520" y="3392424"/>
+            <a:ext cx="3017520" cy="621792"/>
+          </a:xfrm>
+          <a:prstGeom prst="rect">
+            <a:avLst/>
+          </a:prstGeom>
+          <a:noFill/>
+          <a:ln/>
+        </p:spPr>
+        <p:txBody>
+          <a:bodyPr wrap="square" lIns="0" tIns="0" rIns="0" bIns="0" rtlCol="0" anchor="ctr"/>
+          <a:lstStyle/>
+          <a:p>
+            <a:pPr marL="0" indent="0">
+              <a:buNone/>
+            </a:pPr>
+            <a:r>
+              <a:rPr lang="en-US" sz="1600" dirty="0">
+                <a:solidFill>
+                  <a:srgbClr val="1C3A32"/>
+                </a:solidFill>
+                <a:latin typeface="Georgia" pitchFamily="34" charset="0"/>
+                <a:ea typeface="Georgia" pitchFamily="34" charset="-122"/>
+                <a:cs typeface="Georgia" pitchFamily="34" charset="-120"/>
+              </a:rPr>
+              <a:t>What we would rebuild</a:t>
+            </a:r>
+            <a:endParaRPr lang="en-US" sz="1600" dirty="0"/>
+          </a:p>
+        </p:txBody>
+      </p:sp>
+      <p:sp>
+        <p:nvSpPr>
+          <p:cNvPr id="12" name="Text 10"/>
+          <p:cNvSpPr/>
+          <p:nvPr/>
+        </p:nvSpPr>
+        <p:spPr>
+          <a:xfrm>
+            <a:off x="3840480" y="3392424"/>
+            <a:ext cx="7498080" cy="621792"/>
+          </a:xfrm>
+          <a:prstGeom prst="rect">
+            <a:avLst/>
+          </a:prstGeom>
+          <a:noFill/>
+          <a:ln/>
+        </p:spPr>
+        <p:txBody>
+          <a:bodyPr wrap="square" lIns="0" tIns="0" rIns="0" bIns="0" rtlCol="0" anchor="ctr"/>
+          <a:lstStyle/>
+          <a:p>
+            <a:pPr marL="0" indent="0">
+              <a:buNone/>
+            </a:pPr>
+            <a:r>
+              <a:rPr lang="en-US" sz="1500" dirty="0">
+                <a:solidFill>
+                  <a:srgbClr val="1E2A26"/>
+                </a:solidFill>
+                <a:latin typeface="Calibri" pitchFamily="34" charset="0"/>
+                <a:ea typeface="Calibri" pitchFamily="34" charset="-122"/>
+                <a:cs typeface="Calibri" pitchFamily="34" charset="-120"/>
+              </a:rPr>
+              <a:t>Home, Visit, the ministry pages, the sermons page, and the giving page. We cannot move the new site over. We build it again.</a:t>
+            </a:r>
+            <a:endParaRPr lang="en-US" sz="1500" dirty="0"/>
+          </a:p>
+        </p:txBody>
+      </p:sp>
+      <p:sp>
+        <p:nvSpPr>
+          <p:cNvPr id="13" name="Shape 11"/>
+          <p:cNvSpPr/>
+          <p:nvPr/>
+        </p:nvSpPr>
+        <p:spPr>
+          <a:xfrm>
+            <a:off x="502920" y="4215384"/>
+            <a:ext cx="11155680" cy="841248"/>
+          </a:xfrm>
+          <a:prstGeom prst="rect">
+            <a:avLst/>
+          </a:prstGeom>
+          <a:solidFill>
+            <a:srgbClr val="FFFFFF"/>
+          </a:solidFill>
+          <a:ln/>
+        </p:spPr>
+        <p:txBody>
+          <a:bodyPr/>
+          <a:lstStyle/>
+          <a:p>
+            <a:endParaRPr lang="en-US"/>
+          </a:p>
+        </p:txBody>
+      </p:sp>
+      <p:sp>
+        <p:nvSpPr>
+          <p:cNvPr id="14" name="Text 12"/>
+          <p:cNvSpPr/>
+          <p:nvPr/>
+        </p:nvSpPr>
+        <p:spPr>
+          <a:xfrm>
+            <a:off x="731520" y="4325112"/>
+            <a:ext cx="3017520" cy="621792"/>
+          </a:xfrm>
+          <a:prstGeom prst="rect">
+            <a:avLst/>
+          </a:prstGeom>
+          <a:noFill/>
+          <a:ln/>
+        </p:spPr>
+        <p:txBody>
+          <a:bodyPr wrap="square" lIns="0" tIns="0" rIns="0" bIns="0" rtlCol="0" anchor="ctr"/>
+          <a:lstStyle/>
+          <a:p>
+            <a:pPr marL="0" indent="0">
+              <a:buNone/>
+            </a:pPr>
+            <a:r>
+              <a:rPr lang="en-US" sz="1600" dirty="0">
+                <a:solidFill>
+                  <a:srgbClr val="1C3A32"/>
+                </a:solidFill>
+                <a:latin typeface="Georgia" pitchFamily="34" charset="0"/>
+                <a:ea typeface="Georgia" pitchFamily="34" charset="-122"/>
+                <a:cs typeface="Georgia" pitchFamily="34" charset="-120"/>
+              </a:rPr>
+              <a:t>What we would give up</a:t>
+            </a:r>
+            <a:endParaRPr lang="en-US" sz="1600" dirty="0"/>
+          </a:p>
+        </p:txBody>
+      </p:sp>
+      <p:sp>
+        <p:nvSpPr>
+          <p:cNvPr id="15" name="Text 13"/>
+          <p:cNvSpPr/>
+          <p:nvPr/>
+        </p:nvSpPr>
+        <p:spPr>
+          <a:xfrm>
+            <a:off x="3840480" y="4325112"/>
+            <a:ext cx="7498080" cy="621792"/>
+          </a:xfrm>
+          <a:prstGeom prst="rect">
+            <a:avLst/>
+          </a:prstGeom>
+          <a:noFill/>
+          <a:ln/>
+        </p:spPr>
+        <p:txBody>
+          <a:bodyPr wrap="square" lIns="0" tIns="0" rIns="0" bIns="0" rtlCol="0" anchor="ctr"/>
+          <a:lstStyle/>
+          <a:p>
+            <a:pPr marL="0" indent="0">
+              <a:buNone/>
+            </a:pPr>
+            <a:r>
+              <a:rPr lang="en-US" sz="1500" dirty="0">
+                <a:solidFill>
+                  <a:srgbClr val="1E2A26"/>
+                </a:solidFill>
+                <a:latin typeface="Calibri" pitchFamily="34" charset="0"/>
+                <a:ea typeface="Calibri" pitchFamily="34" charset="-122"/>
+                <a:cs typeface="Calibri" pitchFamily="34" charset="-120"/>
+              </a:rPr>
+              <a:t>The exact look of the new site. Subsplash sets the layout. We can change colors and words. We cannot freely redesign the page.</a:t>
+            </a:r>
+            <a:endParaRPr lang="en-US" sz="1500" dirty="0"/>
+          </a:p>
+        </p:txBody>
+      </p:sp>
+      <p:sp>
+        <p:nvSpPr>
+          <p:cNvPr id="16" name="Shape 14"/>
+          <p:cNvSpPr/>
+          <p:nvPr/>
+        </p:nvSpPr>
+        <p:spPr>
+          <a:xfrm>
+            <a:off x="502920" y="5148072"/>
+            <a:ext cx="11155680" cy="841248"/>
+          </a:xfrm>
+          <a:prstGeom prst="rect">
+            <a:avLst/>
+          </a:prstGeom>
+          <a:solidFill>
+            <a:srgbClr val="FFFFFF"/>
+          </a:solidFill>
+          <a:ln/>
+        </p:spPr>
+        <p:txBody>
+          <a:bodyPr/>
+          <a:lstStyle/>
+          <a:p>
+            <a:endParaRPr lang="en-US"/>
+          </a:p>
+        </p:txBody>
+      </p:sp>
+      <p:sp>
+        <p:nvSpPr>
+          <p:cNvPr id="17" name="Text 15"/>
+          <p:cNvSpPr/>
+          <p:nvPr/>
+        </p:nvSpPr>
+        <p:spPr>
+          <a:xfrm>
+            <a:off x="731520" y="5257800"/>
+            <a:ext cx="3017520" cy="621792"/>
+          </a:xfrm>
+          <a:prstGeom prst="rect">
+            <a:avLst/>
+          </a:prstGeom>
+          <a:noFill/>
+          <a:ln/>
+        </p:spPr>
+        <p:txBody>
+          <a:bodyPr wrap="square" lIns="0" tIns="0" rIns="0" bIns="0" rtlCol="0" anchor="ctr"/>
+          <a:lstStyle/>
+          <a:p>
+            <a:pPr marL="0" indent="0">
+              <a:buNone/>
+            </a:pPr>
+            <a:r>
+              <a:rPr lang="en-US" sz="1600" dirty="0">
+                <a:solidFill>
+                  <a:srgbClr val="1C3A32"/>
+                </a:solidFill>
+                <a:latin typeface="Georgia" pitchFamily="34" charset="0"/>
+                <a:ea typeface="Georgia" pitchFamily="34" charset="-122"/>
+                <a:cs typeface="Georgia" pitchFamily="34" charset="-120"/>
+              </a:rPr>
+              <a:t>The tradeoff</a:t>
+            </a:r>
+            <a:endParaRPr lang="en-US" sz="1600" dirty="0"/>
+          </a:p>
+        </p:txBody>
+      </p:sp>
+      <p:sp>
+        <p:nvSpPr>
+          <p:cNvPr id="18" name="Text 16"/>
+          <p:cNvSpPr/>
+          <p:nvPr/>
+        </p:nvSpPr>
+        <p:spPr>
+          <a:xfrm>
+            <a:off x="3840480" y="5257800"/>
+            <a:ext cx="7498080" cy="621792"/>
+          </a:xfrm>
+          <a:prstGeom prst="rect">
+            <a:avLst/>
+          </a:prstGeom>
+          <a:noFill/>
+          <a:ln/>
+        </p:spPr>
+        <p:txBody>
+          <a:bodyPr wrap="square" lIns="0" tIns="0" rIns="0" bIns="0" rtlCol="0" anchor="ctr"/>
+          <a:lstStyle/>
+          <a:p>
+            <a:pPr marL="0" indent="0">
+              <a:buNone/>
+            </a:pPr>
+            <a:r>
+              <a:rPr lang="en-US" sz="1500" dirty="0">
+                <a:solidFill>
+                  <a:srgbClr val="1E2A26"/>
+                </a:solidFill>
+                <a:latin typeface="Calibri" pitchFamily="34" charset="0"/>
+                <a:ea typeface="Calibri" pitchFamily="34" charset="-122"/>
+                <a:cs typeface="Calibri" pitchFamily="34" charset="-120"/>
+              </a:rPr>
+              <a:t>Easier if the office wants one church login. The finished site will look like a Subsplash site, not the one already designed.</a:t>
+            </a:r>
+            <a:endParaRPr lang="en-US" sz="1500" dirty="0"/>
+          </a:p>
+        </p:txBody>
+      </p:sp>
+      <p:sp>
+        <p:nvSpPr>
+          <p:cNvPr id="19" name="Text 17"/>
+          <p:cNvSpPr/>
+          <p:nvPr/>
+        </p:nvSpPr>
+        <p:spPr>
+          <a:xfrm>
+            <a:off x="502920" y="6510528"/>
+            <a:ext cx="9326880" cy="219456"/>
+          </a:xfrm>
+          <a:prstGeom prst="rect">
+            <a:avLst/>
+          </a:prstGeom>
+          <a:noFill/>
+          <a:ln/>
+        </p:spPr>
+        <p:txBody>
+          <a:bodyPr wrap="square" lIns="0" tIns="0" rIns="0" bIns="0" rtlCol="0" anchor="ctr"/>
+          <a:lstStyle/>
+          <a:p>
+            <a:pPr marL="0" indent="0">
+              <a:buNone/>
+            </a:pPr>
+            <a:r>
+              <a:rPr lang="en-US" sz="1100" dirty="0">
+                <a:solidFill>
+                  <a:srgbClr val="5C6B64"/>
+                </a:solidFill>
+                <a:latin typeface="Calibri" pitchFamily="34" charset="0"/>
+                <a:ea typeface="Calibri" pitchFamily="34" charset="-122"/>
+                <a:cs typeface="Calibri" pitchFamily="34" charset="-120"/>
+              </a:rPr>
+              <a:t>For Pastor Dave and Pastor Shawn  ·  28 September 2026</a:t>
+            </a:r>
+            <a:endParaRPr lang="en-US" sz="1100" dirty="0"/>
+          </a:p>
+        </p:txBody>
+      </p:sp>
+      <p:sp>
+        <p:nvSpPr>
+          <p:cNvPr id="20" name="Text 18"/>
+          <p:cNvSpPr/>
+          <p:nvPr/>
+        </p:nvSpPr>
+        <p:spPr>
+          <a:xfrm>
+            <a:off x="11155680" y="6510528"/>
+            <a:ext cx="502920" cy="219456"/>
+          </a:xfrm>
+          <a:prstGeom prst="rect">
+            <a:avLst/>
+          </a:prstGeom>
+          <a:noFill/>
+          <a:ln/>
+        </p:spPr>
+        <p:txBody>
+          <a:bodyPr wrap="square" lIns="0" tIns="0" rIns="0" bIns="0" rtlCol="0" anchor="ctr"/>
+          <a:lstStyle/>
+          <a:p>
+            <a:pPr marL="0" indent="0" algn="r">
+              <a:buNone/>
+            </a:pPr>
+            <a:r>
+              <a:rPr lang="en-US" sz="1100" dirty="0">
+                <a:solidFill>
+                  <a:srgbClr val="5C6B64"/>
+                </a:solidFill>
+                <a:latin typeface="Calibri" pitchFamily="34" charset="0"/>
+                <a:ea typeface="Calibri" pitchFamily="34" charset="-122"/>
+                <a:cs typeface="Calibri" pitchFamily="34" charset="-120"/>
+              </a:rPr>
+              <a:t>5</a:t>
+            </a:r>
+            <a:endParaRPr lang="en-US" sz="1100" dirty="0"/>
+          </a:p>
+        </p:txBody>
+      </p:sp>
+    </p:spTree>
+  </p:cSld>
+  <p:clrMapOvr>
+    <a:masterClrMapping/>
+  </p:clrMapOvr>
+</p:sld>
+</file>
+
+<file path=ppt/slides/slide8.xml><?xml version="1.0" encoding="utf-8"?>
+<p:sld xmlns:a="http://schemas.openxmlformats.org/drawingml/2006/main" xmlns:r="http://schemas.openxmlformats.org/officeDocument/2006/relationships" xmlns:p="http://schemas.openxmlformats.org/presentationml/2006/main">
+  <p:cSld name="Slide 6">
+    <p:bg>
+      <p:bgPr>
+        <a:solidFill>
+          <a:srgbClr val="F6F1E7"/>
+        </a:solidFill>
+        <a:effectLst/>
+      </p:bgPr>
+    </p:bg>
+    <p:spTree>
+      <p:nvGrpSpPr>
+        <p:cNvPr id="1" name=""/>
+        <p:cNvGrpSpPr/>
+        <p:nvPr/>
+      </p:nvGrpSpPr>
+      <p:grpSpPr>
+        <a:xfrm>
+          <a:off x="0" y="0"/>
+          <a:ext cx="0" cy="0"/>
+          <a:chOff x="0" y="0"/>
+          <a:chExt cx="0" cy="0"/>
+        </a:xfrm>
+      </p:grpSpPr>
+      <p:sp>
+        <p:nvSpPr>
           <p:cNvPr id="2" name="Text 0"/>
           <p:cNvSpPr/>
           <p:nvPr/>
@@ -4406,7 +5166,7 @@
           <a:bodyPr wrap="square" lIns="0" tIns="0" rIns="0" bIns="0" rtlCol="0" anchor="ctr"/>
           <a:lstStyle/>
           <a:p>
-            <a:pPr indent="0" marL="0">
+            <a:pPr marL="0" indent="0">
               <a:buNone/>
             </a:pPr>
             <a:r>
@@ -4445,7 +5205,7 @@
           <a:bodyPr wrap="square" lIns="0" tIns="0" rIns="0" bIns="0" rtlCol="0" anchor="ctr"/>
           <a:lstStyle/>
           <a:p>
-            <a:pPr indent="0" marL="0">
+            <a:pPr marL="0" indent="0">
               <a:buNone/>
             </a:pPr>
             <a:r>
@@ -4486,9 +5246,27 @@
             <a:tbl>
               <a:tblPr/>
               <a:tblGrid>
-                <a:gridCol w="2103120"/>
-                <a:gridCol w="4617720"/>
-                <a:gridCol w="4617720"/>
+                <a:gridCol w="2103120">
+                  <a:extLst>
+                    <a:ext uri="{9D8B030D-6E8A-4147-A177-3AD203B41FA5}">
+                      <a16:colId xmlns:a16="http://schemas.microsoft.com/office/drawing/2014/main" val="20000"/>
+                    </a:ext>
+                  </a:extLst>
+                </a:gridCol>
+                <a:gridCol w="4617720">
+                  <a:extLst>
+                    <a:ext uri="{9D8B030D-6E8A-4147-A177-3AD203B41FA5}">
+                      <a16:colId xmlns:a16="http://schemas.microsoft.com/office/drawing/2014/main" val="20001"/>
+                    </a:ext>
+                  </a:extLst>
+                </a:gridCol>
+                <a:gridCol w="4617720">
+                  <a:extLst>
+                    <a:ext uri="{9D8B030D-6E8A-4147-A177-3AD203B41FA5}">
+                      <a16:colId xmlns:a16="http://schemas.microsoft.com/office/drawing/2014/main" val="20002"/>
+                    </a:ext>
+                  </a:extLst>
+                </a:gridCol>
               </a:tblGrid>
               <a:tr h="830580">
                 <a:tc>
@@ -4496,7 +5274,7 @@
                     <a:bodyPr/>
                     <a:lstStyle/>
                     <a:p>
-                      <a:pPr algn="l" indent="0" marL="0">
+                      <a:pPr marL="0" indent="0" algn="l">
                         <a:buNone/>
                       </a:pPr>
                       <a:r>
@@ -4564,7 +5342,7 @@
                     <a:bodyPr/>
                     <a:lstStyle/>
                     <a:p>
-                      <a:pPr algn="l" indent="0" marL="0">
+                      <a:pPr marL="0" indent="0" algn="l">
                         <a:buNone/>
                       </a:pPr>
                       <a:r>
@@ -4576,7 +5354,7 @@
                           <a:ea typeface="Calibri" pitchFamily="34" charset="-122"/>
                           <a:cs typeface="Calibri" pitchFamily="34" charset="-120"/>
                         </a:rPr>
-                        <a:t>Option 1  ·  Tina</a:t>
+                        <a:t>Option 1  ·  Tina CMS</a:t>
                       </a:r>
                       <a:endParaRPr lang="en-US" sz="1300" dirty="0">
                         <a:latin typeface="Calibri" charset="0"/>
@@ -4632,7 +5410,7 @@
                     <a:bodyPr/>
                     <a:lstStyle/>
                     <a:p>
-                      <a:pPr algn="l" indent="0" marL="0">
+                      <a:pPr marL="0" indent="0" algn="l">
                         <a:buNone/>
                       </a:pPr>
                       <a:r>
@@ -4695,6 +5473,11 @@
                     </a:solidFill>
                   </a:tcPr>
                 </a:tc>
+                <a:extLst>
+                  <a:ext uri="{0D108BD9-81ED-4DB2-BD59-A6C34878D82A}">
+                    <a16:rowId xmlns:a16="http://schemas.microsoft.com/office/drawing/2014/main" val="10000"/>
+                  </a:ext>
+                </a:extLst>
               </a:tr>
               <a:tr h="830580">
                 <a:tc>
@@ -4702,7 +5485,7 @@
                     <a:bodyPr/>
                     <a:lstStyle/>
                     <a:p>
-                      <a:pPr algn="l" indent="0" marL="0">
+                      <a:pPr marL="0" indent="0" algn="l">
                         <a:buNone/>
                       </a:pPr>
                       <a:r>
@@ -4770,7 +5553,7 @@
                     <a:bodyPr/>
                     <a:lstStyle/>
                     <a:p>
-                      <a:pPr algn="l" indent="0" marL="0">
+                      <a:pPr marL="0" indent="0" algn="l">
                         <a:buNone/>
                       </a:pPr>
                       <a:r>
@@ -4838,7 +5621,7 @@
                     <a:bodyPr/>
                     <a:lstStyle/>
                     <a:p>
-                      <a:pPr algn="l" indent="0" marL="0">
+                      <a:pPr marL="0" indent="0" algn="l">
                         <a:buNone/>
                       </a:pPr>
                       <a:r>
@@ -4901,6 +5684,11 @@
                     </a:solidFill>
                   </a:tcPr>
                 </a:tc>
+                <a:extLst>
+                  <a:ext uri="{0D108BD9-81ED-4DB2-BD59-A6C34878D82A}">
+                    <a16:rowId xmlns:a16="http://schemas.microsoft.com/office/drawing/2014/main" val="10001"/>
+                  </a:ext>
+                </a:extLst>
               </a:tr>
               <a:tr h="830580">
                 <a:tc>
@@ -4908,7 +5696,7 @@
                     <a:bodyPr/>
                     <a:lstStyle/>
                     <a:p>
-                      <a:pPr algn="l" indent="0" marL="0">
+                      <a:pPr marL="0" indent="0" algn="l">
                         <a:buNone/>
                       </a:pPr>
                       <a:r>
@@ -4976,7 +5764,7 @@
                     <a:bodyPr/>
                     <a:lstStyle/>
                     <a:p>
-                      <a:pPr algn="l" indent="0" marL="0">
+                      <a:pPr marL="0" indent="0" algn="l">
                         <a:buNone/>
                       </a:pPr>
                       <a:r>
@@ -5044,7 +5832,7 @@
                     <a:bodyPr/>
                     <a:lstStyle/>
                     <a:p>
-                      <a:pPr algn="l" indent="0" marL="0">
+                      <a:pPr marL="0" indent="0" algn="l">
                         <a:buNone/>
                       </a:pPr>
                       <a:r>
@@ -5107,6 +5895,11 @@
                     </a:solidFill>
                   </a:tcPr>
                 </a:tc>
+                <a:extLst>
+                  <a:ext uri="{0D108BD9-81ED-4DB2-BD59-A6C34878D82A}">
+                    <a16:rowId xmlns:a16="http://schemas.microsoft.com/office/drawing/2014/main" val="10002"/>
+                  </a:ext>
+                </a:extLst>
               </a:tr>
               <a:tr h="830580">
                 <a:tc>
@@ -5114,7 +5907,7 @@
                     <a:bodyPr/>
                     <a:lstStyle/>
                     <a:p>
-                      <a:pPr algn="l" indent="0" marL="0">
+                      <a:pPr marL="0" indent="0" algn="l">
                         <a:buNone/>
                       </a:pPr>
                       <a:r>
@@ -5182,7 +5975,7 @@
                     <a:bodyPr/>
                     <a:lstStyle/>
                     <a:p>
-                      <a:pPr algn="l" indent="0" marL="0">
+                      <a:pPr marL="0" indent="0" algn="l">
                         <a:buNone/>
                       </a:pPr>
                       <a:r>
@@ -5250,7 +6043,7 @@
                     <a:bodyPr/>
                     <a:lstStyle/>
                     <a:p>
-                      <a:pPr algn="l" indent="0" marL="0">
+                      <a:pPr marL="0" indent="0" algn="l">
                         <a:buNone/>
                       </a:pPr>
                       <a:r>
@@ -5313,6 +6106,11 @@
                     </a:solidFill>
                   </a:tcPr>
                 </a:tc>
+                <a:extLst>
+                  <a:ext uri="{0D108BD9-81ED-4DB2-BD59-A6C34878D82A}">
+                    <a16:rowId xmlns:a16="http://schemas.microsoft.com/office/drawing/2014/main" val="10003"/>
+                  </a:ext>
+                </a:extLst>
               </a:tr>
               <a:tr h="830580">
                 <a:tc>
@@ -5320,7 +6118,7 @@
                     <a:bodyPr/>
                     <a:lstStyle/>
                     <a:p>
-                      <a:pPr algn="l" indent="0" marL="0">
+                      <a:pPr marL="0" indent="0" algn="l">
                         <a:buNone/>
                       </a:pPr>
                       <a:r>
@@ -5388,7 +6186,7 @@
                     <a:bodyPr/>
                     <a:lstStyle/>
                     <a:p>
-                      <a:pPr algn="l" indent="0" marL="0">
+                      <a:pPr marL="0" indent="0" algn="l">
                         <a:buNone/>
                       </a:pPr>
                       <a:r>
@@ -5456,7 +6254,7 @@
                     <a:bodyPr/>
                     <a:lstStyle/>
                     <a:p>
-                      <a:pPr algn="l" indent="0" marL="0">
+                      <a:pPr marL="0" indent="0" algn="l">
                         <a:buNone/>
                       </a:pPr>
                       <a:r>
@@ -5519,6 +6317,11 @@
                     </a:solidFill>
                   </a:tcPr>
                 </a:tc>
+                <a:extLst>
+                  <a:ext uri="{0D108BD9-81ED-4DB2-BD59-A6C34878D82A}">
+                    <a16:rowId xmlns:a16="http://schemas.microsoft.com/office/drawing/2014/main" val="10004"/>
+                  </a:ext>
+                </a:extLst>
               </a:tr>
               <a:tr h="830580">
                 <a:tc>
@@ -5526,7 +6329,7 @@
                     <a:bodyPr/>
                     <a:lstStyle/>
                     <a:p>
-                      <a:pPr algn="l" indent="0" marL="0">
+                      <a:pPr marL="0" indent="0" algn="l">
                         <a:buNone/>
                       </a:pPr>
                       <a:r>
@@ -5594,7 +6397,7 @@
                     <a:bodyPr/>
                     <a:lstStyle/>
                     <a:p>
-                      <a:pPr algn="l" indent="0" marL="0">
+                      <a:pPr marL="0" indent="0" algn="l">
                         <a:buNone/>
                       </a:pPr>
                       <a:r>
@@ -5606,7 +6409,7 @@
                           <a:ea typeface="Calibri" pitchFamily="34" charset="-122"/>
                           <a:cs typeface="Calibri" pitchFamily="34" charset="-120"/>
                         </a:rPr>
-                        <a:t>$0 for Tina. Hosting is $0, or up to about $240 for the year if a paid seat is needed.</a:t>
+                        <a:t>$0 for Tina CMS. Hosting is $0, or up to about $240 for the year if a paid seat is needed.</a:t>
                       </a:r>
                       <a:endParaRPr lang="en-US" sz="1300" dirty="0">
                         <a:latin typeface="Calibri" charset="0"/>
@@ -5662,7 +6465,7 @@
                     <a:bodyPr/>
                     <a:lstStyle/>
                     <a:p>
-                      <a:pPr algn="l" indent="0" marL="0">
+                      <a:pPr marL="0" indent="0" algn="l">
                         <a:buNone/>
                       </a:pPr>
                       <a:r>
@@ -5725,6 +6528,11 @@
                     </a:solidFill>
                   </a:tcPr>
                 </a:tc>
+                <a:extLst>
+                  <a:ext uri="{0D108BD9-81ED-4DB2-BD59-A6C34878D82A}">
+                    <a16:rowId xmlns:a16="http://schemas.microsoft.com/office/drawing/2014/main" val="10005"/>
+                  </a:ext>
+                </a:extLst>
               </a:tr>
             </a:tbl>
           </a:graphicData>
@@ -5751,7 +6559,7 @@
           <a:bodyPr wrap="square" lIns="0" tIns="0" rIns="0" bIns="0" rtlCol="0" anchor="ctr"/>
           <a:lstStyle/>
           <a:p>
-            <a:pPr indent="0" marL="0">
+            <a:pPr marL="0" indent="0">
               <a:buNone/>
             </a:pPr>
             <a:r>
@@ -5790,7 +6598,7 @@
           <a:bodyPr wrap="square" lIns="0" tIns="0" rIns="0" bIns="0" rtlCol="0" anchor="ctr"/>
           <a:lstStyle/>
           <a:p>
-            <a:pPr algn="r" indent="0" marL="0">
+            <a:pPr marL="0" indent="0" algn="r">
               <a:buNone/>
             </a:pPr>
             <a:r>
@@ -5802,7 +6610,7 @@
                 <a:ea typeface="Calibri" pitchFamily="34" charset="-122"/>
                 <a:cs typeface="Calibri" pitchFamily="34" charset="-120"/>
               </a:rPr>
-              <a:t>6</a:t>
+              <a:t>8</a:t>
             </a:r>
             <a:endParaRPr lang="en-US" sz="1100" dirty="0"/>
           </a:p>
@@ -5816,7 +6624,7 @@
 </p:sld>
 </file>
 
-<file path=ppt/slides/slide7.xml><?xml version="1.0" encoding="utf-8"?>
+<file path=ppt/slides/slide9.xml><?xml version="1.0" encoding="utf-8"?>
 <p:sld xmlns:a="http://schemas.openxmlformats.org/drawingml/2006/main" xmlns:r="http://schemas.openxmlformats.org/officeDocument/2006/relationships" xmlns:p="http://schemas.openxmlformats.org/presentationml/2006/main">
   <p:cSld name="Slide 7">
     <p:bg>
@@ -5824,6 +6632,7 @@
         <a:solidFill>
           <a:srgbClr val="F6F1E7"/>
         </a:solidFill>
+        <a:effectLst/>
       </p:bgPr>
     </p:bg>
     <p:spTree>
@@ -5861,7 +6670,7 @@
           <a:bodyPr wrap="square" lIns="0" tIns="0" rIns="0" bIns="0" rtlCol="0" anchor="ctr"/>
           <a:lstStyle/>
           <a:p>
-            <a:pPr indent="0" marL="0">
+            <a:pPr marL="0" indent="0">
               <a:buNone/>
             </a:pPr>
             <a:r>
@@ -5902,9 +6711,27 @@
             <a:tbl>
               <a:tblPr/>
               <a:tblGrid>
-                <a:gridCol w="2468880"/>
-                <a:gridCol w="4434840"/>
-                <a:gridCol w="4434840"/>
+                <a:gridCol w="2468880">
+                  <a:extLst>
+                    <a:ext uri="{9D8B030D-6E8A-4147-A177-3AD203B41FA5}">
+                      <a16:colId xmlns:a16="http://schemas.microsoft.com/office/drawing/2014/main" val="20000"/>
+                    </a:ext>
+                  </a:extLst>
+                </a:gridCol>
+                <a:gridCol w="4434840">
+                  <a:extLst>
+                    <a:ext uri="{9D8B030D-6E8A-4147-A177-3AD203B41FA5}">
+                      <a16:colId xmlns:a16="http://schemas.microsoft.com/office/drawing/2014/main" val="20001"/>
+                    </a:ext>
+                  </a:extLst>
+                </a:gridCol>
+                <a:gridCol w="4434840">
+                  <a:extLst>
+                    <a:ext uri="{9D8B030D-6E8A-4147-A177-3AD203B41FA5}">
+                      <a16:colId xmlns:a16="http://schemas.microsoft.com/office/drawing/2014/main" val="20002"/>
+                    </a:ext>
+                  </a:extLst>
+                </a:gridCol>
               </a:tblGrid>
               <a:tr h="838200">
                 <a:tc>
@@ -5912,7 +6739,7 @@
                     <a:bodyPr/>
                     <a:lstStyle/>
                     <a:p>
-                      <a:pPr algn="l" indent="0" marL="0">
+                      <a:pPr marL="0" indent="0" algn="l">
                         <a:buNone/>
                       </a:pPr>
                       <a:r>
@@ -5980,7 +6807,7 @@
                     <a:bodyPr/>
                     <a:lstStyle/>
                     <a:p>
-                      <a:pPr algn="l" indent="0" marL="0">
+                      <a:pPr marL="0" indent="0" algn="l">
                         <a:buNone/>
                       </a:pPr>
                       <a:r>
@@ -5992,7 +6819,7 @@
                           <a:ea typeface="Calibri" pitchFamily="34" charset="-122"/>
                           <a:cs typeface="Calibri" pitchFamily="34" charset="-120"/>
                         </a:rPr>
-                        <a:t>Tina</a:t>
+                        <a:t>Tina CMS</a:t>
                       </a:r>
                       <a:endParaRPr lang="en-US" sz="1400" dirty="0">
                         <a:latin typeface="Calibri" charset="0"/>
@@ -6048,7 +6875,7 @@
                     <a:bodyPr/>
                     <a:lstStyle/>
                     <a:p>
-                      <a:pPr algn="l" indent="0" marL="0">
+                      <a:pPr marL="0" indent="0" algn="l">
                         <a:buNone/>
                       </a:pPr>
                       <a:r>
@@ -6111,6 +6938,11 @@
                     </a:solidFill>
                   </a:tcPr>
                 </a:tc>
+                <a:extLst>
+                  <a:ext uri="{0D108BD9-81ED-4DB2-BD59-A6C34878D82A}">
+                    <a16:rowId xmlns:a16="http://schemas.microsoft.com/office/drawing/2014/main" val="10000"/>
+                  </a:ext>
+                </a:extLst>
               </a:tr>
               <a:tr h="838200">
                 <a:tc>
@@ -6118,7 +6950,7 @@
                     <a:bodyPr/>
                     <a:lstStyle/>
                     <a:p>
-                      <a:pPr algn="l" indent="0" marL="0">
+                      <a:pPr marL="0" indent="0" algn="l">
                         <a:buNone/>
                       </a:pPr>
                       <a:r>
@@ -6186,7 +7018,7 @@
                     <a:bodyPr/>
                     <a:lstStyle/>
                     <a:p>
-                      <a:pPr algn="l" indent="0" marL="0">
+                      <a:pPr marL="0" indent="0" algn="l">
                         <a:buNone/>
                       </a:pPr>
                       <a:r>
@@ -6254,7 +7086,7 @@
                     <a:bodyPr/>
                     <a:lstStyle/>
                     <a:p>
-                      <a:pPr algn="l" indent="0" marL="0">
+                      <a:pPr marL="0" indent="0" algn="l">
                         <a:buNone/>
                       </a:pPr>
                       <a:r>
@@ -6317,6 +7149,11 @@
                     </a:solidFill>
                   </a:tcPr>
                 </a:tc>
+                <a:extLst>
+                  <a:ext uri="{0D108BD9-81ED-4DB2-BD59-A6C34878D82A}">
+                    <a16:rowId xmlns:a16="http://schemas.microsoft.com/office/drawing/2014/main" val="10001"/>
+                  </a:ext>
+                </a:extLst>
               </a:tr>
               <a:tr h="838200">
                 <a:tc>
@@ -6324,7 +7161,7 @@
                     <a:bodyPr/>
                     <a:lstStyle/>
                     <a:p>
-                      <a:pPr algn="l" indent="0" marL="0">
+                      <a:pPr marL="0" indent="0" algn="l">
                         <a:buNone/>
                       </a:pPr>
                       <a:r>
@@ -6392,7 +7229,7 @@
                     <a:bodyPr/>
                     <a:lstStyle/>
                     <a:p>
-                      <a:pPr algn="l" indent="0" marL="0">
+                      <a:pPr marL="0" indent="0" algn="l">
                         <a:buNone/>
                       </a:pPr>
                       <a:r>
@@ -6460,7 +7297,7 @@
                     <a:bodyPr/>
                     <a:lstStyle/>
                     <a:p>
-                      <a:pPr algn="l" indent="0" marL="0">
+                      <a:pPr marL="0" indent="0" algn="l">
                         <a:buNone/>
                       </a:pPr>
                       <a:r>
@@ -6523,6 +7360,11 @@
                     </a:solidFill>
                   </a:tcPr>
                 </a:tc>
+                <a:extLst>
+                  <a:ext uri="{0D108BD9-81ED-4DB2-BD59-A6C34878D82A}">
+                    <a16:rowId xmlns:a16="http://schemas.microsoft.com/office/drawing/2014/main" val="10002"/>
+                  </a:ext>
+                </a:extLst>
               </a:tr>
               <a:tr h="838200">
                 <a:tc>
@@ -6530,7 +7372,7 @@
                     <a:bodyPr/>
                     <a:lstStyle/>
                     <a:p>
-                      <a:pPr algn="l" indent="0" marL="0">
+                      <a:pPr marL="0" indent="0" algn="l">
                         <a:buNone/>
                       </a:pPr>
                       <a:r>
@@ -6598,7 +7440,7 @@
                     <a:bodyPr/>
                     <a:lstStyle/>
                     <a:p>
-                      <a:pPr algn="l" indent="0" marL="0">
+                      <a:pPr marL="0" indent="0" algn="l">
                         <a:buNone/>
                       </a:pPr>
                       <a:r>
@@ -6666,7 +7508,7 @@
                     <a:bodyPr/>
                     <a:lstStyle/>
                     <a:p>
-                      <a:pPr algn="l" indent="0" marL="0">
+                      <a:pPr marL="0" indent="0" algn="l">
                         <a:buNone/>
                       </a:pPr>
                       <a:r>
@@ -6729,6 +7571,11 @@
                     </a:solidFill>
                   </a:tcPr>
                 </a:tc>
+                <a:extLst>
+                  <a:ext uri="{0D108BD9-81ED-4DB2-BD59-A6C34878D82A}">
+                    <a16:rowId xmlns:a16="http://schemas.microsoft.com/office/drawing/2014/main" val="10003"/>
+                  </a:ext>
+                </a:extLst>
               </a:tr>
               <a:tr h="838200">
                 <a:tc>
@@ -6736,7 +7583,7 @@
                     <a:bodyPr/>
                     <a:lstStyle/>
                     <a:p>
-                      <a:pPr algn="l" indent="0" marL="0">
+                      <a:pPr marL="0" indent="0" algn="l">
                         <a:buNone/>
                       </a:pPr>
                       <a:r>
@@ -6804,7 +7651,7 @@
                     <a:bodyPr/>
                     <a:lstStyle/>
                     <a:p>
-                      <a:pPr algn="l" indent="0" marL="0">
+                      <a:pPr marL="0" indent="0" algn="l">
                         <a:buNone/>
                       </a:pPr>
                       <a:r>
@@ -6872,7 +7719,7 @@
                     <a:bodyPr/>
                     <a:lstStyle/>
                     <a:p>
-                      <a:pPr algn="l" indent="0" marL="0">
+                      <a:pPr marL="0" indent="0" algn="l">
                         <a:buNone/>
                       </a:pPr>
                       <a:r>
@@ -6935,6 +7782,11 @@
                     </a:solidFill>
                   </a:tcPr>
                 </a:tc>
+                <a:extLst>
+                  <a:ext uri="{0D108BD9-81ED-4DB2-BD59-A6C34878D82A}">
+                    <a16:rowId xmlns:a16="http://schemas.microsoft.com/office/drawing/2014/main" val="10004"/>
+                  </a:ext>
+                </a:extLst>
               </a:tr>
               <a:tr h="838200">
                 <a:tc>
@@ -6942,7 +7794,7 @@
                     <a:bodyPr/>
                     <a:lstStyle/>
                     <a:p>
-                      <a:pPr algn="l" indent="0" marL="0">
+                      <a:pPr marL="0" indent="0" algn="l">
                         <a:buNone/>
                       </a:pPr>
                       <a:r>
@@ -7010,7 +7862,7 @@
                     <a:bodyPr/>
                     <a:lstStyle/>
                     <a:p>
-                      <a:pPr algn="l" indent="0" marL="0">
+                      <a:pPr marL="0" indent="0" algn="l">
                         <a:buNone/>
                       </a:pPr>
                       <a:r>
@@ -7078,7 +7930,7 @@
                     <a:bodyPr/>
                     <a:lstStyle/>
                     <a:p>
-                      <a:pPr algn="l" indent="0" marL="0">
+                      <a:pPr marL="0" indent="0" algn="l">
                         <a:buNone/>
                       </a:pPr>
                       <a:r>
@@ -7141,6 +7993,11 @@
                     </a:solidFill>
                   </a:tcPr>
                 </a:tc>
+                <a:extLst>
+                  <a:ext uri="{0D108BD9-81ED-4DB2-BD59-A6C34878D82A}">
+                    <a16:rowId xmlns:a16="http://schemas.microsoft.com/office/drawing/2014/main" val="10005"/>
+                  </a:ext>
+                </a:extLst>
               </a:tr>
             </a:tbl>
           </a:graphicData>
@@ -7167,7 +8024,7 @@
           <a:bodyPr wrap="square" lIns="0" tIns="0" rIns="0" bIns="0" rtlCol="0" anchor="ctr"/>
           <a:lstStyle/>
           <a:p>
-            <a:pPr indent="0" marL="0">
+            <a:pPr marL="0" indent="0">
               <a:buNone/>
             </a:pPr>
             <a:r>
@@ -7206,7 +8063,7 @@
           <a:bodyPr wrap="square" lIns="0" tIns="0" rIns="0" bIns="0" rtlCol="0" anchor="ctr"/>
           <a:lstStyle/>
           <a:p>
-            <a:pPr algn="r" indent="0" marL="0">
+            <a:pPr marL="0" indent="0" algn="r">
               <a:buNone/>
             </a:pPr>
             <a:r>
@@ -7218,546 +8075,7 @@
                 <a:ea typeface="Calibri" pitchFamily="34" charset="-122"/>
                 <a:cs typeface="Calibri" pitchFamily="34" charset="-120"/>
               </a:rPr>
-              <a:t>7</a:t>
-            </a:r>
-            <a:endParaRPr lang="en-US" sz="1100" dirty="0"/>
-          </a:p>
-        </p:txBody>
-      </p:sp>
-    </p:spTree>
-  </p:cSld>
-  <p:clrMapOvr>
-    <a:masterClrMapping/>
-  </p:clrMapOvr>
-</p:sld>
-</file>
-
-<file path=ppt/slides/slide8.xml><?xml version="1.0" encoding="utf-8"?>
-<p:sld xmlns:a="http://schemas.openxmlformats.org/drawingml/2006/main" xmlns:r="http://schemas.openxmlformats.org/officeDocument/2006/relationships" xmlns:p="http://schemas.openxmlformats.org/presentationml/2006/main">
-  <p:cSld name="Slide 8">
-    <p:bg>
-      <p:bgPr>
-        <a:solidFill>
-          <a:srgbClr val="F6F1E7"/>
-        </a:solidFill>
-      </p:bgPr>
-    </p:bg>
-    <p:spTree>
-      <p:nvGrpSpPr>
-        <p:cNvPr id="1" name=""/>
-        <p:cNvGrpSpPr/>
-        <p:nvPr/>
-      </p:nvGrpSpPr>
-      <p:grpSpPr>
-        <a:xfrm>
-          <a:off x="0" y="0"/>
-          <a:ext cx="0" cy="0"/>
-          <a:chOff x="0" y="0"/>
-          <a:chExt cx="0" cy="0"/>
-        </a:xfrm>
-      </p:grpSpPr>
-      <p:sp>
-        <p:nvSpPr>
-          <p:cNvPr id="2" name="Text 0"/>
-          <p:cNvSpPr/>
-          <p:nvPr/>
-        </p:nvSpPr>
-        <p:spPr>
-          <a:xfrm>
-            <a:off x="502920" y="347472"/>
-            <a:ext cx="10972800" cy="457200"/>
-          </a:xfrm>
-          <a:prstGeom prst="rect">
-            <a:avLst/>
-          </a:prstGeom>
-          <a:noFill/>
-          <a:ln/>
-        </p:spPr>
-        <p:txBody>
-          <a:bodyPr wrap="square" lIns="0" tIns="0" rIns="0" bIns="0" rtlCol="0" anchor="ctr"/>
-          <a:lstStyle/>
-          <a:p>
-            <a:pPr indent="0" marL="0">
-              <a:buNone/>
-            </a:pPr>
-            <a:r>
-              <a:rPr lang="en-US" sz="3200" dirty="0">
-                <a:solidFill>
-                  <a:srgbClr val="1C3A32"/>
-                </a:solidFill>
-                <a:latin typeface="Georgia" pitchFamily="34" charset="0"/>
-                <a:ea typeface="Georgia" pitchFamily="34" charset="-122"/>
-                <a:cs typeface="Georgia" pitchFamily="34" charset="-120"/>
-              </a:rPr>
-              <a:t>The simple version</a:t>
-            </a:r>
-            <a:endParaRPr lang="en-US" sz="3200" dirty="0"/>
-          </a:p>
-        </p:txBody>
-      </p:sp>
-      <p:sp>
-        <p:nvSpPr>
-          <p:cNvPr id="3" name="Text 1"/>
-          <p:cNvSpPr/>
-          <p:nvPr/>
-        </p:nvSpPr>
-        <p:spPr>
-          <a:xfrm>
-            <a:off x="502920" y="1005840"/>
-            <a:ext cx="3749040" cy="777240"/>
-          </a:xfrm>
-          <a:prstGeom prst="rect">
-            <a:avLst/>
-          </a:prstGeom>
-          <a:noFill/>
-          <a:ln/>
-        </p:spPr>
-        <p:txBody>
-          <a:bodyPr wrap="square" lIns="0" tIns="0" rIns="0" bIns="0" rtlCol="0" anchor="t"/>
-          <a:lstStyle/>
-          <a:p>
-            <a:pPr indent="0" marL="0">
-              <a:buNone/>
-            </a:pPr>
-            <a:r>
-              <a:rPr lang="en-US" sz="1600" dirty="0">
-                <a:solidFill>
-                  <a:srgbClr val="1C3A32"/>
-                </a:solidFill>
-                <a:latin typeface="Georgia" pitchFamily="34" charset="0"/>
-                <a:ea typeface="Georgia" pitchFamily="34" charset="-122"/>
-                <a:cs typeface="Georgia" pitchFamily="34" charset="-120"/>
-              </a:rPr>
-              <a:t>Tina is free for two people.</a:t>
-            </a:r>
-            <a:endParaRPr lang="en-US" sz="1600" dirty="0"/>
-          </a:p>
-        </p:txBody>
-      </p:sp>
-      <p:sp>
-        <p:nvSpPr>
-          <p:cNvPr id="4" name="Text 2"/>
-          <p:cNvSpPr/>
-          <p:nvPr/>
-        </p:nvSpPr>
-        <p:spPr>
-          <a:xfrm>
-            <a:off x="4389120" y="1005840"/>
-            <a:ext cx="7223760" cy="822960"/>
-          </a:xfrm>
-          <a:prstGeom prst="rect">
-            <a:avLst/>
-          </a:prstGeom>
-          <a:noFill/>
-          <a:ln/>
-        </p:spPr>
-        <p:txBody>
-          <a:bodyPr wrap="square" lIns="0" tIns="0" rIns="0" bIns="0" rtlCol="0" anchor="t"/>
-          <a:lstStyle/>
-          <a:p>
-            <a:pPr indent="0" marL="0">
-              <a:buNone/>
-            </a:pPr>
-            <a:r>
-              <a:rPr lang="en-US" sz="1500" dirty="0">
-                <a:solidFill>
-                  <a:srgbClr val="1E2A26"/>
-                </a:solidFill>
-                <a:latin typeface="Calibri" pitchFamily="34" charset="0"/>
-                <a:ea typeface="Calibri" pitchFamily="34" charset="-122"/>
-                <a:cs typeface="Calibri" pitchFamily="34" charset="-120"/>
-              </a:rPr>
-              <a:t>Two staff can each have a login. A third person would cost extra, and we are not planning that.</a:t>
-            </a:r>
-            <a:endParaRPr lang="en-US" sz="1500" dirty="0"/>
-          </a:p>
-        </p:txBody>
-      </p:sp>
-      <p:sp>
-        <p:nvSpPr>
-          <p:cNvPr id="5" name="Text 3"/>
-          <p:cNvSpPr/>
-          <p:nvPr/>
-        </p:nvSpPr>
-        <p:spPr>
-          <a:xfrm>
-            <a:off x="502920" y="1965960"/>
-            <a:ext cx="3749040" cy="777240"/>
-          </a:xfrm>
-          <a:prstGeom prst="rect">
-            <a:avLst/>
-          </a:prstGeom>
-          <a:noFill/>
-          <a:ln/>
-        </p:spPr>
-        <p:txBody>
-          <a:bodyPr wrap="square" lIns="0" tIns="0" rIns="0" bIns="0" rtlCol="0" anchor="t"/>
-          <a:lstStyle/>
-          <a:p>
-            <a:pPr indent="0" marL="0">
-              <a:buNone/>
-            </a:pPr>
-            <a:r>
-              <a:rPr lang="en-US" sz="1600" dirty="0">
-                <a:solidFill>
-                  <a:srgbClr val="1C3A32"/>
-                </a:solidFill>
-                <a:latin typeface="Georgia" pitchFamily="34" charset="0"/>
-                <a:ea typeface="Georgia" pitchFamily="34" charset="-122"/>
-                <a:cs typeface="Georgia" pitchFamily="34" charset="-120"/>
-              </a:rPr>
-              <a:t>SnapPages is already in our account.</a:t>
-            </a:r>
-            <a:endParaRPr lang="en-US" sz="1600" dirty="0"/>
-          </a:p>
-        </p:txBody>
-      </p:sp>
-      <p:sp>
-        <p:nvSpPr>
-          <p:cNvPr id="6" name="Text 4"/>
-          <p:cNvSpPr/>
-          <p:nvPr/>
-        </p:nvSpPr>
-        <p:spPr>
-          <a:xfrm>
-            <a:off x="4389120" y="1965960"/>
-            <a:ext cx="7223760" cy="822960"/>
-          </a:xfrm>
-          <a:prstGeom prst="rect">
-            <a:avLst/>
-          </a:prstGeom>
-          <a:noFill/>
-          <a:ln/>
-        </p:spPr>
-        <p:txBody>
-          <a:bodyPr wrap="square" lIns="0" tIns="0" rIns="0" bIns="0" rtlCol="0" anchor="t"/>
-          <a:lstStyle/>
-          <a:p>
-            <a:pPr indent="0" marL="0">
-              <a:buNone/>
-            </a:pPr>
-            <a:r>
-              <a:rPr lang="en-US" sz="1500" dirty="0">
-                <a:solidFill>
-                  <a:srgbClr val="1E2A26"/>
-                </a:solidFill>
-                <a:latin typeface="Calibri" pitchFamily="34" charset="0"/>
-                <a:ea typeface="Calibri" pitchFamily="34" charset="-122"/>
-                <a:cs typeface="Calibri" pitchFamily="34" charset="-120"/>
-              </a:rPr>
-              <a:t>A practice website is already started in Subsplash. They do not list a public price. Check our bill before adding a new website charge.</a:t>
-            </a:r>
-            <a:endParaRPr lang="en-US" sz="1500" dirty="0"/>
-          </a:p>
-        </p:txBody>
-      </p:sp>
-      <p:sp>
-        <p:nvSpPr>
-          <p:cNvPr id="7" name="Text 5"/>
-          <p:cNvSpPr/>
-          <p:nvPr/>
-        </p:nvSpPr>
-        <p:spPr>
-          <a:xfrm>
-            <a:off x="502920" y="2926080"/>
-            <a:ext cx="3749040" cy="777240"/>
-          </a:xfrm>
-          <a:prstGeom prst="rect">
-            <a:avLst/>
-          </a:prstGeom>
-          <a:noFill/>
-          <a:ln/>
-        </p:spPr>
-        <p:txBody>
-          <a:bodyPr wrap="square" lIns="0" tIns="0" rIns="0" bIns="0" rtlCol="0" anchor="t"/>
-          <a:lstStyle/>
-          <a:p>
-            <a:pPr indent="0" marL="0">
-              <a:buNone/>
-            </a:pPr>
-            <a:r>
-              <a:rPr lang="en-US" sz="1600" dirty="0">
-                <a:solidFill>
-                  <a:srgbClr val="1C3A32"/>
-                </a:solidFill>
-                <a:latin typeface="Georgia" pitchFamily="34" charset="0"/>
-                <a:ea typeface="Georgia" pitchFamily="34" charset="-122"/>
-                <a:cs typeface="Georgia" pitchFamily="34" charset="-120"/>
-              </a:rPr>
-              <a:t>We still pay Subsplash.</a:t>
-            </a:r>
-            <a:endParaRPr lang="en-US" sz="1600" dirty="0"/>
-          </a:p>
-        </p:txBody>
-      </p:sp>
-      <p:sp>
-        <p:nvSpPr>
-          <p:cNvPr id="8" name="Text 6"/>
-          <p:cNvSpPr/>
-          <p:nvPr/>
-        </p:nvSpPr>
-        <p:spPr>
-          <a:xfrm>
-            <a:off x="4389120" y="2926080"/>
-            <a:ext cx="7223760" cy="822960"/>
-          </a:xfrm>
-          <a:prstGeom prst="rect">
-            <a:avLst/>
-          </a:prstGeom>
-          <a:noFill/>
-          <a:ln/>
-        </p:spPr>
-        <p:txBody>
-          <a:bodyPr wrap="square" lIns="0" tIns="0" rIns="0" bIns="0" rtlCol="0" anchor="t"/>
-          <a:lstStyle/>
-          <a:p>
-            <a:pPr indent="0" marL="0">
-              <a:buNone/>
-            </a:pPr>
-            <a:r>
-              <a:rPr lang="en-US" sz="1500" dirty="0">
-                <a:solidFill>
-                  <a:srgbClr val="1E2A26"/>
-                </a:solidFill>
-                <a:latin typeface="Calibri" pitchFamily="34" charset="0"/>
-                <a:ea typeface="Calibri" pitchFamily="34" charset="-122"/>
-                <a:cs typeface="Calibri" pitchFamily="34" charset="-120"/>
-              </a:rPr>
-              <a:t>Choosing Tina does not cancel the app, giving, or sermons. If the website is part of our package, that part of the bill may stay.</a:t>
-            </a:r>
-            <a:endParaRPr lang="en-US" sz="1500" dirty="0"/>
-          </a:p>
-        </p:txBody>
-      </p:sp>
-      <p:sp>
-        <p:nvSpPr>
-          <p:cNvPr id="9" name="Text 7"/>
-          <p:cNvSpPr/>
-          <p:nvPr/>
-        </p:nvSpPr>
-        <p:spPr>
-          <a:xfrm>
-            <a:off x="502920" y="3886200"/>
-            <a:ext cx="3749040" cy="777240"/>
-          </a:xfrm>
-          <a:prstGeom prst="rect">
-            <a:avLst/>
-          </a:prstGeom>
-          <a:noFill/>
-          <a:ln/>
-        </p:spPr>
-        <p:txBody>
-          <a:bodyPr wrap="square" lIns="0" tIns="0" rIns="0" bIns="0" rtlCol="0" anchor="t"/>
-          <a:lstStyle/>
-          <a:p>
-            <a:pPr indent="0" marL="0">
-              <a:buNone/>
-            </a:pPr>
-            <a:r>
-              <a:rPr lang="en-US" sz="1600" dirty="0">
-                <a:solidFill>
-                  <a:srgbClr val="1C3A32"/>
-                </a:solidFill>
-                <a:latin typeface="Georgia" pitchFamily="34" charset="0"/>
-                <a:ea typeface="Georgia" pitchFamily="34" charset="-122"/>
-                <a:cs typeface="Georgia" pitchFamily="34" charset="-120"/>
-              </a:rPr>
-              <a:t>Giving fees stay the same.</a:t>
-            </a:r>
-            <a:endParaRPr lang="en-US" sz="1600" dirty="0"/>
-          </a:p>
-        </p:txBody>
-      </p:sp>
-      <p:sp>
-        <p:nvSpPr>
-          <p:cNvPr id="10" name="Text 8"/>
-          <p:cNvSpPr/>
-          <p:nvPr/>
-        </p:nvSpPr>
-        <p:spPr>
-          <a:xfrm>
-            <a:off x="4389120" y="3886200"/>
-            <a:ext cx="7223760" cy="822960"/>
-          </a:xfrm>
-          <a:prstGeom prst="rect">
-            <a:avLst/>
-          </a:prstGeom>
-          <a:noFill/>
-          <a:ln/>
-        </p:spPr>
-        <p:txBody>
-          <a:bodyPr wrap="square" lIns="0" tIns="0" rIns="0" bIns="0" rtlCol="0" anchor="t"/>
-          <a:lstStyle/>
-          <a:p>
-            <a:pPr indent="0" marL="0">
-              <a:buNone/>
-            </a:pPr>
-            <a:r>
-              <a:rPr lang="en-US" sz="1500" dirty="0">
-                <a:solidFill>
-                  <a:srgbClr val="1E2A26"/>
-                </a:solidFill>
-                <a:latin typeface="Calibri" pitchFamily="34" charset="0"/>
-                <a:ea typeface="Calibri" pitchFamily="34" charset="-122"/>
-                <a:cs typeface="Calibri" pitchFamily="34" charset="-120"/>
-              </a:rPr>
-              <a:t>A card gift is 2.3% plus 30 cents. A bank gift is 1%. Both choices keep Subsplash for giving.</a:t>
-            </a:r>
-            <a:endParaRPr lang="en-US" sz="1500" dirty="0"/>
-          </a:p>
-        </p:txBody>
-      </p:sp>
-      <p:sp>
-        <p:nvSpPr>
-          <p:cNvPr id="11" name="Text 9"/>
-          <p:cNvSpPr/>
-          <p:nvPr/>
-        </p:nvSpPr>
-        <p:spPr>
-          <a:xfrm>
-            <a:off x="502920" y="4846320"/>
-            <a:ext cx="3749040" cy="777240"/>
-          </a:xfrm>
-          <a:prstGeom prst="rect">
-            <a:avLst/>
-          </a:prstGeom>
-          <a:noFill/>
-          <a:ln/>
-        </p:spPr>
-        <p:txBody>
-          <a:bodyPr wrap="square" lIns="0" tIns="0" rIns="0" bIns="0" rtlCol="0" anchor="t"/>
-          <a:lstStyle/>
-          <a:p>
-            <a:pPr indent="0" marL="0">
-              <a:buNone/>
-            </a:pPr>
-            <a:r>
-              <a:rPr lang="en-US" sz="1600" dirty="0">
-                <a:solidFill>
-                  <a:srgbClr val="1C3A32"/>
-                </a:solidFill>
-                <a:latin typeface="Georgia" pitchFamily="34" charset="0"/>
-                <a:ea typeface="Georgia" pitchFamily="34" charset="-122"/>
-                <a:cs typeface="Georgia" pitchFamily="34" charset="-120"/>
-              </a:rPr>
-              <a:t>The real choice</a:t>
-            </a:r>
-            <a:endParaRPr lang="en-US" sz="1600" dirty="0"/>
-          </a:p>
-        </p:txBody>
-      </p:sp>
-      <p:sp>
-        <p:nvSpPr>
-          <p:cNvPr id="12" name="Text 10"/>
-          <p:cNvSpPr/>
-          <p:nvPr/>
-        </p:nvSpPr>
-        <p:spPr>
-          <a:xfrm>
-            <a:off x="4389120" y="4846320"/>
-            <a:ext cx="7223760" cy="822960"/>
-          </a:xfrm>
-          <a:prstGeom prst="rect">
-            <a:avLst/>
-          </a:prstGeom>
-          <a:noFill/>
-          <a:ln/>
-        </p:spPr>
-        <p:txBody>
-          <a:bodyPr wrap="square" lIns="0" tIns="0" rIns="0" bIns="0" rtlCol="0" anchor="t"/>
-          <a:lstStyle/>
-          <a:p>
-            <a:pPr indent="0" marL="0">
-              <a:buNone/>
-            </a:pPr>
-            <a:r>
-              <a:rPr lang="en-US" sz="1500" dirty="0">
-                <a:solidFill>
-                  <a:srgbClr val="1E2A26"/>
-                </a:solidFill>
-                <a:latin typeface="Calibri" pitchFamily="34" charset="0"/>
-                <a:ea typeface="Calibri" pitchFamily="34" charset="-122"/>
-                <a:cs typeface="Calibri" pitchFamily="34" charset="-120"/>
-              </a:rPr>
-              <a:t>Option 1 keeps the website we have already designed, at no editor cost for two people. Option 2 rebuilds it inside the Subsplash login the office already knows.</a:t>
-            </a:r>
-            <a:endParaRPr lang="en-US" sz="1500" dirty="0"/>
-          </a:p>
-        </p:txBody>
-      </p:sp>
-      <p:sp>
-        <p:nvSpPr>
-          <p:cNvPr id="13" name="Text 11"/>
-          <p:cNvSpPr/>
-          <p:nvPr/>
-        </p:nvSpPr>
-        <p:spPr>
-          <a:xfrm>
-            <a:off x="502920" y="6510528"/>
-            <a:ext cx="9326880" cy="219456"/>
-          </a:xfrm>
-          <a:prstGeom prst="rect">
-            <a:avLst/>
-          </a:prstGeom>
-          <a:noFill/>
-          <a:ln/>
-        </p:spPr>
-        <p:txBody>
-          <a:bodyPr wrap="square" lIns="0" tIns="0" rIns="0" bIns="0" rtlCol="0" anchor="ctr"/>
-          <a:lstStyle/>
-          <a:p>
-            <a:pPr indent="0" marL="0">
-              <a:buNone/>
-            </a:pPr>
-            <a:r>
-              <a:rPr lang="en-US" sz="1100" dirty="0">
-                <a:solidFill>
-                  <a:srgbClr val="5C6B64"/>
-                </a:solidFill>
-                <a:latin typeface="Calibri" pitchFamily="34" charset="0"/>
-                <a:ea typeface="Calibri" pitchFamily="34" charset="-122"/>
-                <a:cs typeface="Calibri" pitchFamily="34" charset="-120"/>
-              </a:rPr>
-              <a:t>For Pastor Dave and Pastor Shawn  ·  28 September 2026</a:t>
-            </a:r>
-            <a:endParaRPr lang="en-US" sz="1100" dirty="0"/>
-          </a:p>
-        </p:txBody>
-      </p:sp>
-      <p:sp>
-        <p:nvSpPr>
-          <p:cNvPr id="14" name="Text 12"/>
-          <p:cNvSpPr/>
-          <p:nvPr/>
-        </p:nvSpPr>
-        <p:spPr>
-          <a:xfrm>
-            <a:off x="11155680" y="6510528"/>
-            <a:ext cx="502920" cy="219456"/>
-          </a:xfrm>
-          <a:prstGeom prst="rect">
-            <a:avLst/>
-          </a:prstGeom>
-          <a:noFill/>
-          <a:ln/>
-        </p:spPr>
-        <p:txBody>
-          <a:bodyPr wrap="square" lIns="0" tIns="0" rIns="0" bIns="0" rtlCol="0" anchor="ctr"/>
-          <a:lstStyle/>
-          <a:p>
-            <a:pPr algn="r" indent="0" marL="0">
-              <a:buNone/>
-            </a:pPr>
-            <a:r>
-              <a:rPr lang="en-US" sz="1100" dirty="0">
-                <a:solidFill>
-                  <a:srgbClr val="5C6B64"/>
-                </a:solidFill>
-                <a:latin typeface="Calibri" pitchFamily="34" charset="0"/>
-                <a:ea typeface="Calibri" pitchFamily="34" charset="-122"/>
-                <a:cs typeface="Calibri" pitchFamily="34" charset="-120"/>
-              </a:rPr>
-              <a:t>8</a:t>
+              <a:t>9</a:t>
             </a:r>
             <a:endParaRPr lang="en-US" sz="1100" dirty="0"/>
           </a:p>
@@ -8064,4 +8382,319 @@
     </a:ext>
   </a:extLst>
 </a:theme>
+</file>
+
+<file path=ppt/theme/theme2.xml><?xml version="1.0" encoding="utf-8"?>
+<a:theme xmlns:a="http://schemas.openxmlformats.org/drawingml/2006/main" name="Office Theme">
+  <a:themeElements>
+    <a:clrScheme name="Office">
+      <a:dk1>
+        <a:sysClr val="windowText" lastClr="000000"/>
+      </a:dk1>
+      <a:lt1>
+        <a:sysClr val="window" lastClr="FFFFFF"/>
+      </a:lt1>
+      <a:dk2>
+        <a:srgbClr val="0E2841"/>
+      </a:dk2>
+      <a:lt2>
+        <a:srgbClr val="E8E8E8"/>
+      </a:lt2>
+      <a:accent1>
+        <a:srgbClr val="156082"/>
+      </a:accent1>
+      <a:accent2>
+        <a:srgbClr val="E97132"/>
+      </a:accent2>
+      <a:accent3>
+        <a:srgbClr val="196B24"/>
+      </a:accent3>
+      <a:accent4>
+        <a:srgbClr val="0F9ED5"/>
+      </a:accent4>
+      <a:accent5>
+        <a:srgbClr val="A02B93"/>
+      </a:accent5>
+      <a:accent6>
+        <a:srgbClr val="4EA72E"/>
+      </a:accent6>
+      <a:hlink>
+        <a:srgbClr val="467886"/>
+      </a:hlink>
+      <a:folHlink>
+        <a:srgbClr val="96607D"/>
+      </a:folHlink>
+    </a:clrScheme>
+    <a:fontScheme name="Office">
+      <a:majorFont>
+        <a:latin typeface="Aptos Display" panose="02110004020202020204"/>
+        <a:ea typeface=""/>
+        <a:cs typeface=""/>
+        <a:font script="Jpan" typeface="游ゴシック Light"/>
+        <a:font script="Hang" typeface="맑은 고딕"/>
+        <a:font script="Hans" typeface="等线 Light"/>
+        <a:font script="Hant" typeface="新細明體"/>
+        <a:font script="Arab" typeface="Times New Roman"/>
+        <a:font script="Hebr" typeface="Times New Roman"/>
+        <a:font script="Thai" typeface="Angsana New"/>
+        <a:font script="Ethi" typeface="Nyala"/>
+        <a:font script="Beng" typeface="Vrinda"/>
+        <a:font script="Gujr" typeface="Shruti"/>
+        <a:font script="Khmr" typeface="MoolBoran"/>
+        <a:font script="Knda" typeface="Tunga"/>
+        <a:font script="Guru" typeface="Raavi"/>
+        <a:font script="Cans" typeface="Euphemia"/>
+        <a:font script="Cher" typeface="Plantagenet Cherokee"/>
+        <a:font script="Yiii" typeface="Microsoft Yi Baiti"/>
+        <a:font script="Tibt" typeface="Microsoft Himalaya"/>
+        <a:font script="Thaa" typeface="MV Boli"/>
+        <a:font script="Deva" typeface="Mangal"/>
+        <a:font script="Telu" typeface="Gautami"/>
+        <a:font script="Taml" typeface="Latha"/>
+        <a:font script="Syrc" typeface="Estrangelo Edessa"/>
+        <a:font script="Orya" typeface="Kalinga"/>
+        <a:font script="Mlym" typeface="Kartika"/>
+        <a:font script="Laoo" typeface="DokChampa"/>
+        <a:font script="Sinh" typeface="Iskoola Pota"/>
+        <a:font script="Mong" typeface="Mongolian Baiti"/>
+        <a:font script="Viet" typeface="Times New Roman"/>
+        <a:font script="Uigh" typeface="Microsoft Uighur"/>
+        <a:font script="Geor" typeface="Sylfaen"/>
+        <a:font script="Armn" typeface="Arial"/>
+        <a:font script="Bugi" typeface="Leelawadee UI"/>
+        <a:font script="Bopo" typeface="Microsoft JhengHei"/>
+        <a:font script="Java" typeface="Javanese Text"/>
+        <a:font script="Lisu" typeface="Segoe UI"/>
+        <a:font script="Mymr" typeface="Myanmar Text"/>
+        <a:font script="Nkoo" typeface="Ebrima"/>
+        <a:font script="Olck" typeface="Nirmala UI"/>
+        <a:font script="Osma" typeface="Ebrima"/>
+        <a:font script="Phag" typeface="Phagspa"/>
+        <a:font script="Syrn" typeface="Estrangelo Edessa"/>
+        <a:font script="Syrj" typeface="Estrangelo Edessa"/>
+        <a:font script="Syre" typeface="Estrangelo Edessa"/>
+        <a:font script="Sora" typeface="Nirmala UI"/>
+        <a:font script="Tale" typeface="Microsoft Tai Le"/>
+        <a:font script="Talu" typeface="Microsoft New Tai Lue"/>
+        <a:font script="Tfng" typeface="Ebrima"/>
+      </a:majorFont>
+      <a:minorFont>
+        <a:latin typeface="Aptos" panose="02110004020202020204"/>
+        <a:ea typeface=""/>
+        <a:cs typeface=""/>
+        <a:font script="Jpan" typeface="游ゴシック"/>
+        <a:font script="Hang" typeface="맑은 고딕"/>
+        <a:font script="Hans" typeface="等线"/>
+        <a:font script="Hant" typeface="新細明體"/>
+        <a:font script="Arab" typeface="Arial"/>
+        <a:font script="Hebr" typeface="Arial"/>
+        <a:font script="Thai" typeface="Cordia New"/>
+        <a:font script="Ethi" typeface="Nyala"/>
+        <a:font script="Beng" typeface="Vrinda"/>
+        <a:font script="Gujr" typeface="Shruti"/>
+        <a:font script="Khmr" typeface="DaunPenh"/>
+        <a:font script="Knda" typeface="Tunga"/>
+        <a:font script="Guru" typeface="Raavi"/>
+        <a:font script="Cans" typeface="Euphemia"/>
+        <a:font script="Cher" typeface="Plantagenet Cherokee"/>
+        <a:font script="Yiii" typeface="Microsoft Yi Baiti"/>
+        <a:font script="Tibt" typeface="Microsoft Himalaya"/>
+        <a:font script="Thaa" typeface="MV Boli"/>
+        <a:font script="Deva" typeface="Mangal"/>
+        <a:font script="Telu" typeface="Gautami"/>
+        <a:font script="Taml" typeface="Latha"/>
+        <a:font script="Syrc" typeface="Estrangelo Edessa"/>
+        <a:font script="Orya" typeface="Kalinga"/>
+        <a:font script="Mlym" typeface="Kartika"/>
+        <a:font script="Laoo" typeface="DokChampa"/>
+        <a:font script="Sinh" typeface="Iskoola Pota"/>
+        <a:font script="Mong" typeface="Mongolian Baiti"/>
+        <a:font script="Viet" typeface="Arial"/>
+        <a:font script="Uigh" typeface="Microsoft Uighur"/>
+        <a:font script="Geor" typeface="Sylfaen"/>
+        <a:font script="Armn" typeface="Arial"/>
+        <a:font script="Bugi" typeface="Leelawadee UI"/>
+        <a:font script="Bopo" typeface="Microsoft JhengHei"/>
+        <a:font script="Java" typeface="Javanese Text"/>
+        <a:font script="Lisu" typeface="Segoe UI"/>
+        <a:font script="Mymr" typeface="Myanmar Text"/>
+        <a:font script="Nkoo" typeface="Ebrima"/>
+        <a:font script="Olck" typeface="Nirmala UI"/>
+        <a:font script="Osma" typeface="Ebrima"/>
+        <a:font script="Phag" typeface="Phagspa"/>
+        <a:font script="Syrn" typeface="Estrangelo Edessa"/>
+        <a:font script="Syrj" typeface="Estrangelo Edessa"/>
+        <a:font script="Syre" typeface="Estrangelo Edessa"/>
+        <a:font script="Sora" typeface="Nirmala UI"/>
+        <a:font script="Tale" typeface="Microsoft Tai Le"/>
+        <a:font script="Talu" typeface="Microsoft New Tai Lue"/>
+        <a:font script="Tfng" typeface="Ebrima"/>
+      </a:minorFont>
+    </a:fontScheme>
+    <a:fmtScheme name="Office">
+      <a:fillStyleLst>
+        <a:solidFill>
+          <a:schemeClr val="phClr"/>
+        </a:solidFill>
+        <a:gradFill rotWithShape="1">
+          <a:gsLst>
+            <a:gs pos="0">
+              <a:schemeClr val="phClr">
+                <a:lumMod val="110000"/>
+                <a:satMod val="105000"/>
+                <a:tint val="67000"/>
+              </a:schemeClr>
+            </a:gs>
+            <a:gs pos="50000">
+              <a:schemeClr val="phClr">
+                <a:lumMod val="105000"/>
+                <a:satMod val="103000"/>
+                <a:tint val="73000"/>
+              </a:schemeClr>
+            </a:gs>
+            <a:gs pos="100000">
+              <a:schemeClr val="phClr">
+                <a:lumMod val="105000"/>
+                <a:satMod val="109000"/>
+                <a:tint val="81000"/>
+              </a:schemeClr>
+            </a:gs>
+          </a:gsLst>
+          <a:lin ang="5400000" scaled="0"/>
+        </a:gradFill>
+        <a:gradFill rotWithShape="1">
+          <a:gsLst>
+            <a:gs pos="0">
+              <a:schemeClr val="phClr">
+                <a:satMod val="103000"/>
+                <a:lumMod val="102000"/>
+                <a:tint val="94000"/>
+              </a:schemeClr>
+            </a:gs>
+            <a:gs pos="50000">
+              <a:schemeClr val="phClr">
+                <a:satMod val="110000"/>
+                <a:lumMod val="100000"/>
+                <a:shade val="100000"/>
+              </a:schemeClr>
+            </a:gs>
+            <a:gs pos="100000">
+              <a:schemeClr val="phClr">
+                <a:lumMod val="99000"/>
+                <a:satMod val="120000"/>
+                <a:shade val="78000"/>
+              </a:schemeClr>
+            </a:gs>
+          </a:gsLst>
+          <a:lin ang="5400000" scaled="0"/>
+        </a:gradFill>
+      </a:fillStyleLst>
+      <a:lnStyleLst>
+        <a:ln w="12700" cap="flat" cmpd="sng" algn="ctr">
+          <a:solidFill>
+            <a:schemeClr val="phClr"/>
+          </a:solidFill>
+          <a:prstDash val="solid"/>
+          <a:miter lim="800000"/>
+        </a:ln>
+        <a:ln w="19050" cap="flat" cmpd="sng" algn="ctr">
+          <a:solidFill>
+            <a:schemeClr val="phClr"/>
+          </a:solidFill>
+          <a:prstDash val="solid"/>
+          <a:miter lim="800000"/>
+        </a:ln>
+        <a:ln w="25400" cap="flat" cmpd="sng" algn="ctr">
+          <a:solidFill>
+            <a:schemeClr val="phClr"/>
+          </a:solidFill>
+          <a:prstDash val="solid"/>
+          <a:miter lim="800000"/>
+        </a:ln>
+      </a:lnStyleLst>
+      <a:effectStyleLst>
+        <a:effectStyle>
+          <a:effectLst/>
+        </a:effectStyle>
+        <a:effectStyle>
+          <a:effectLst/>
+        </a:effectStyle>
+        <a:effectStyle>
+          <a:effectLst>
+            <a:outerShdw blurRad="57150" dist="19050" dir="5400000" algn="ctr" rotWithShape="0">
+              <a:srgbClr val="000000">
+                <a:alpha val="63000"/>
+              </a:srgbClr>
+            </a:outerShdw>
+          </a:effectLst>
+        </a:effectStyle>
+      </a:effectStyleLst>
+      <a:bgFillStyleLst>
+        <a:solidFill>
+          <a:schemeClr val="phClr"/>
+        </a:solidFill>
+        <a:solidFill>
+          <a:schemeClr val="phClr">
+            <a:tint val="95000"/>
+            <a:satMod val="170000"/>
+          </a:schemeClr>
+        </a:solidFill>
+        <a:gradFill rotWithShape="1">
+          <a:gsLst>
+            <a:gs pos="0">
+              <a:schemeClr val="phClr">
+                <a:tint val="93000"/>
+                <a:satMod val="150000"/>
+                <a:shade val="98000"/>
+                <a:lumMod val="102000"/>
+              </a:schemeClr>
+            </a:gs>
+            <a:gs pos="50000">
+              <a:schemeClr val="phClr">
+                <a:tint val="98000"/>
+                <a:satMod val="130000"/>
+                <a:shade val="90000"/>
+                <a:lumMod val="103000"/>
+              </a:schemeClr>
+            </a:gs>
+            <a:gs pos="100000">
+              <a:schemeClr val="phClr">
+                <a:shade val="63000"/>
+                <a:satMod val="120000"/>
+              </a:schemeClr>
+            </a:gs>
+          </a:gsLst>
+          <a:lin ang="5400000" scaled="0"/>
+        </a:gradFill>
+      </a:bgFillStyleLst>
+    </a:fmtScheme>
+  </a:themeElements>
+  <a:objectDefaults>
+    <a:lnDef>
+      <a:spPr/>
+      <a:bodyPr/>
+      <a:lstStyle/>
+      <a:style>
+        <a:lnRef idx="2">
+          <a:schemeClr val="accent1"/>
+        </a:lnRef>
+        <a:fillRef idx="0">
+          <a:schemeClr val="accent1"/>
+        </a:fillRef>
+        <a:effectRef idx="1">
+          <a:schemeClr val="accent1"/>
+        </a:effectRef>
+        <a:fontRef idx="minor">
+          <a:schemeClr val="tx1"/>
+        </a:fontRef>
+      </a:style>
+    </a:lnDef>
+  </a:objectDefaults>
+  <a:extraClrSchemeLst/>
+  <a:extLst>
+    <a:ext uri="{05A4C25C-085E-4340-85A3-A5531E510DB2}">
+      <thm15:themeFamily xmlns:thm15="http://schemas.microsoft.com/office/thememl/2012/main" name="Office Theme" id="{2E142A2C-CD16-42D6-873A-C26D2A0506FA}" vid="{1BDDFF52-6CD6-40A5-AB3C-68EB2F1E4D0A}"/>
+    </a:ext>
+  </a:extLst>
+</a:theme>
 </file>
</xml_diff>